<commit_message>
Tidied up some scripts and added a script to save Bayesian diagnostic plots in Reports. Wrote up most of the final report and updated presentation slides.
</commit_message>
<xml_diff>
--- a/Project1/Reports/Project1_Presentation_summers.pptx
+++ b/Project1/Reports/Project1_Presentation_summers.pptx
@@ -5,7 +5,7 @@
     <p:sldMasterId id="2147483648" r:id="rId1"/>
   </p:sldMasterIdLst>
   <p:notesMasterIdLst>
-    <p:notesMasterId r:id="rId9"/>
+    <p:notesMasterId r:id="rId10"/>
   </p:notesMasterIdLst>
   <p:sldIdLst>
     <p:sldId id="260" r:id="rId2"/>
@@ -14,46 +14,47 @@
     <p:sldId id="263" r:id="rId5"/>
     <p:sldId id="264" r:id="rId6"/>
     <p:sldId id="265" r:id="rId7"/>
-    <p:sldId id="266" r:id="rId8"/>
+    <p:sldId id="267" r:id="rId8"/>
+    <p:sldId id="266" r:id="rId9"/>
   </p:sldIdLst>
   <p:sldSz cx="12192000" cy="6858000"/>
   <p:notesSz cx="12192000" cy="6858000"/>
   <p:embeddedFontLst>
     <p:embeddedFont>
       <p:font typeface="Cambria Math" panose="02040503050406030204" pitchFamily="18" charset="0"/>
-      <p:regular r:id="rId10"/>
+      <p:regular r:id="rId11"/>
     </p:embeddedFont>
     <p:embeddedFont>
       <p:font typeface="GEHAIV+FranklinGothic-Book" panose="02000500000000000000" pitchFamily="2" charset="0"/>
-      <p:regular r:id="rId11"/>
+      <p:regular r:id="rId12"/>
     </p:embeddedFont>
     <p:embeddedFont>
       <p:font typeface="KDMFEK+FranklinGothic-Book" panose="02000500000000000000" pitchFamily="2" charset="0"/>
-      <p:regular r:id="rId12"/>
+      <p:regular r:id="rId13"/>
     </p:embeddedFont>
     <p:embeddedFont>
       <p:font typeface="LVLFDH+FranklinGothic-Book" panose="02000500000000000000" pitchFamily="2" charset="0"/>
-      <p:regular r:id="rId13"/>
+      <p:regular r:id="rId14"/>
     </p:embeddedFont>
     <p:embeddedFont>
       <p:font typeface="MPIRPG+FranklinGothic-Book" panose="02000500000000000000" pitchFamily="2" charset="0"/>
-      <p:regular r:id="rId14"/>
+      <p:regular r:id="rId15"/>
     </p:embeddedFont>
     <p:embeddedFont>
       <p:font typeface="NOOILK+FranklinGothic-Book" panose="02000500000000000000" pitchFamily="2" charset="0"/>
-      <p:regular r:id="rId15"/>
+      <p:regular r:id="rId16"/>
     </p:embeddedFont>
     <p:embeddedFont>
       <p:font typeface="OAGDQN+FranklinGothic-BookItalic" panose="02000500000000000000" pitchFamily="2" charset="0"/>
-      <p:regular r:id="rId16"/>
+      <p:regular r:id="rId17"/>
     </p:embeddedFont>
     <p:embeddedFont>
       <p:font typeface="VTCKGD+FranklinGothic-Book" panose="02000500000000000000" pitchFamily="2" charset="0"/>
-      <p:regular r:id="rId17"/>
+      <p:regular r:id="rId18"/>
     </p:embeddedFont>
     <p:embeddedFont>
       <p:font typeface="WPQCJM+FranklinGothic-Book" panose="02000500000000000000" pitchFamily="2" charset="0"/>
-      <p:regular r:id="rId18"/>
+      <p:regular r:id="rId19"/>
     </p:embeddedFont>
   </p:embeddedFontLst>
   <p:defaultTextStyle>
@@ -699,11 +700,15 @@
                 <a:ea typeface="+mn-ea"/>
                 <a:cs typeface="+mn-cs"/>
               </a:rPr>
-              <a:t>First, </a:t>
-            </a:r>
-          </a:p>
-          <a:p>
-            <a:br>
+              <a:t>First question is addressing whether there will be decrease in viral load and an increase in CD4 counts at year-2 check up.</a:t>
+            </a:r>
+          </a:p>
+          <a:p>
+            <a:pPr marL="171450" indent="-171450">
+              <a:buFont typeface="Arial" panose="020B0604020202020204" pitchFamily="34" charset="0"/>
+              <a:buChar char="•"/>
+            </a:pPr>
+            <a:r>
               <a:rPr lang="en-US" sz="1200" kern="1200" dirty="0">
                 <a:solidFill>
                   <a:schemeClr val="tx1"/>
@@ -713,8 +718,11 @@
                 <a:ea typeface="+mn-ea"/>
                 <a:cs typeface="+mn-cs"/>
               </a:rPr>
-            </a:br>
-            <a:r>
+              <a:t>Its hypothesized that Year 2 viral load will be higher among hard drug users as compared to non-users and CD4 counts lower</a:t>
+            </a:r>
+          </a:p>
+          <a:p>
+            <a:br>
               <a:rPr lang="en-US" sz="1200" kern="1200" dirty="0">
                 <a:solidFill>
                   <a:schemeClr val="tx1"/>
@@ -724,11 +732,8 @@
                 <a:ea typeface="+mn-ea"/>
                 <a:cs typeface="+mn-cs"/>
               </a:rPr>
-              <a:t>Second, </a:t>
-            </a:r>
-          </a:p>
-          <a:p>
-            <a:br>
+            </a:br>
+            <a:r>
               <a:rPr lang="en-US" sz="1200" kern="1200" dirty="0">
                 <a:solidFill>
                   <a:schemeClr val="tx1"/>
@@ -738,7 +743,14 @@
                 <a:ea typeface="+mn-ea"/>
                 <a:cs typeface="+mn-cs"/>
               </a:rPr>
-            </a:br>
+              <a:t>Second question is looking at physical and mental QOL metrics.</a:t>
+            </a:r>
+          </a:p>
+          <a:p>
+            <a:pPr marL="171450" indent="-171450">
+              <a:buFont typeface="Arial" panose="020B0604020202020204" pitchFamily="34" charset="0"/>
+              <a:buChar char="•"/>
+            </a:pPr>
             <a:r>
               <a:rPr lang="en-US" sz="1200" kern="1200" dirty="0">
                 <a:solidFill>
@@ -749,7 +761,57 @@
                 <a:ea typeface="+mn-ea"/>
                 <a:cs typeface="+mn-cs"/>
               </a:rPr>
-              <a:t>Finally, </a:t>
+              <a:t>Hypothesis is addressing any differences between hard drug users and non-users</a:t>
+            </a:r>
+          </a:p>
+          <a:p>
+            <a:br>
+              <a:rPr lang="en-US" sz="1200" kern="1200" dirty="0">
+                <a:solidFill>
+                  <a:schemeClr val="tx1"/>
+                </a:solidFill>
+                <a:effectLst/>
+                <a:latin typeface="+mn-lt"/>
+                <a:ea typeface="+mn-ea"/>
+                <a:cs typeface="+mn-cs"/>
+              </a:rPr>
+            </a:br>
+            <a:r>
+              <a:rPr lang="en-US" sz="1200" kern="1200" dirty="0">
+                <a:solidFill>
+                  <a:schemeClr val="tx1"/>
+                </a:solidFill>
+                <a:effectLst/>
+                <a:latin typeface="+mn-lt"/>
+                <a:ea typeface="+mn-ea"/>
+                <a:cs typeface="+mn-cs"/>
+              </a:rPr>
+              <a:t>Third question is determining adherence mediates the association between hard drug use and year-2 outcomes</a:t>
+            </a:r>
+          </a:p>
+          <a:p>
+            <a:endParaRPr lang="en-US" sz="1200" kern="1200" dirty="0">
+              <a:solidFill>
+                <a:schemeClr val="tx1"/>
+              </a:solidFill>
+              <a:effectLst/>
+              <a:latin typeface="+mn-lt"/>
+              <a:ea typeface="+mn-ea"/>
+              <a:cs typeface="+mn-cs"/>
+            </a:endParaRPr>
+          </a:p>
+          <a:p>
+            <a:r>
+              <a:rPr lang="en-US" sz="1200" kern="1200" dirty="0">
+                <a:solidFill>
+                  <a:schemeClr val="tx1"/>
+                </a:solidFill>
+                <a:effectLst/>
+                <a:latin typeface="+mn-lt"/>
+                <a:ea typeface="+mn-ea"/>
+                <a:cs typeface="+mn-cs"/>
+              </a:rPr>
+              <a:t>Lastly, we are determining if there is a difference in drop out rates between users and non-users</a:t>
             </a:r>
             <a:endParaRPr lang="en-US" dirty="0"/>
           </a:p>
@@ -874,6 +936,20 @@
             </a:r>
           </a:p>
           <a:p>
+            <a:r>
+              <a:rPr lang="en-US" sz="1200" kern="1200" dirty="0">
+                <a:solidFill>
+                  <a:schemeClr val="tx1"/>
+                </a:solidFill>
+                <a:effectLst/>
+                <a:latin typeface="+mn-lt"/>
+                <a:ea typeface="+mn-ea"/>
+                <a:cs typeface="+mn-cs"/>
+              </a:rPr>
+              <a:t>With the implausible BMI values labeled as missing and doing a complete-case analysis on all outcomes and covariates reduced the dataset to 463 subjects being used</a:t>
+            </a:r>
+          </a:p>
+          <a:p>
             <a:endParaRPr lang="en-US" sz="1200" kern="1200" dirty="0">
               <a:solidFill>
                 <a:schemeClr val="tx1"/>
@@ -1182,51 +1258,17 @@
               <a:buChar char="•"/>
             </a:pPr>
             <a:r>
-              <a:rPr lang="en-US" sz="1200" kern="1200" dirty="0">
-                <a:solidFill>
-                  <a:schemeClr val="tx1"/>
-                </a:solidFill>
-                <a:effectLst/>
-                <a:latin typeface="+mn-lt"/>
-                <a:ea typeface="+mn-ea"/>
-                <a:cs typeface="+mn-cs"/>
-              </a:rPr>
-              <a:t>For the time trends, Cortisol and DHEA showed distinct diurnal patterns for the first 30min after waking. Cortisol levels increased by approximately 0.6% per minute or about 20% cumulatively, while DHEA levels decreased by 1.8% per minute</a:t>
-            </a:r>
-          </a:p>
-          <a:p>
-            <a:pPr marL="171450" indent="-171450">
-              <a:buFont typeface="Arial" panose="020B0604020202020204" pitchFamily="34" charset="0"/>
-              <a:buChar char="•"/>
-            </a:pPr>
-            <a:endParaRPr lang="en-US" sz="1200" kern="1200" dirty="0">
-              <a:solidFill>
-                <a:schemeClr val="tx1"/>
-              </a:solidFill>
-              <a:effectLst/>
-              <a:latin typeface="+mn-lt"/>
-              <a:ea typeface="+mn-ea"/>
-              <a:cs typeface="+mn-cs"/>
-            </a:endParaRPr>
-          </a:p>
-          <a:p>
-            <a:pPr marL="171450" indent="-171450">
-              <a:buFont typeface="Arial" panose="020B0604020202020204" pitchFamily="34" charset="0"/>
-              <a:buChar char="•"/>
-            </a:pPr>
-            <a:r>
-              <a:rPr lang="en-US" sz="1200" kern="1200" dirty="0">
-                <a:solidFill>
-                  <a:schemeClr val="tx1"/>
-                </a:solidFill>
-                <a:effectLst/>
-                <a:latin typeface="+mn-lt"/>
-                <a:ea typeface="+mn-ea"/>
-                <a:cs typeface="+mn-cs"/>
-              </a:rPr>
-              <a:t>After 30 minutes, cortisol levels declined steadily at approximately 12.5% per hour and DHEA at about 8.9% per hour, on average</a:t>
-            </a:r>
-            <a:endParaRPr lang="en-US" dirty="0"/>
+              <a:rPr lang="en-US" dirty="0"/>
+              <a:t>Loss to follow-up was associated with lower baseline physical QOL scores within both hard drug users and non-</a:t>
+            </a:r>
+            <a:r>
+              <a:rPr lang="en-US" dirty="0" err="1"/>
+              <a:t>busers</a:t>
+            </a:r>
+            <a:r>
+              <a:rPr lang="en-US" dirty="0"/>
+              <a:t> but not associated with baseline laboratory measures</a:t>
+            </a:r>
           </a:p>
         </p:txBody>
       </p:sp>
@@ -1267,6 +1309,180 @@
 </file>
 
 <file path=ppt/notesSlides/notesSlide7.xml><?xml version="1.0" encoding="utf-8"?>
+<p:notes xmlns:a="http://schemas.openxmlformats.org/drawingml/2006/main" xmlns:r="http://schemas.openxmlformats.org/officeDocument/2006/relationships" xmlns:p="http://schemas.openxmlformats.org/presentationml/2006/main">
+  <p:cSld>
+    <p:spTree>
+      <p:nvGrpSpPr>
+        <p:cNvPr id="1" name="">
+          <a:extLst>
+            <a:ext uri="{FF2B5EF4-FFF2-40B4-BE49-F238E27FC236}">
+              <a16:creationId xmlns:a16="http://schemas.microsoft.com/office/drawing/2014/main" id="{B3272795-C7C6-4CFF-FB8D-74FB9212DD2E}"/>
+            </a:ext>
+          </a:extLst>
+        </p:cNvPr>
+        <p:cNvGrpSpPr/>
+        <p:nvPr/>
+      </p:nvGrpSpPr>
+      <p:grpSpPr>
+        <a:xfrm>
+          <a:off x="0" y="0"/>
+          <a:ext cx="0" cy="0"/>
+          <a:chOff x="0" y="0"/>
+          <a:chExt cx="0" cy="0"/>
+        </a:xfrm>
+      </p:grpSpPr>
+      <p:sp>
+        <p:nvSpPr>
+          <p:cNvPr id="2" name="Slide Image Placeholder 1">
+            <a:extLst>
+              <a:ext uri="{FF2B5EF4-FFF2-40B4-BE49-F238E27FC236}">
+                <a16:creationId xmlns:a16="http://schemas.microsoft.com/office/drawing/2014/main" id="{2C7F8C60-3717-8C63-2521-FF787C81373C}"/>
+              </a:ext>
+            </a:extLst>
+          </p:cNvPr>
+          <p:cNvSpPr>
+            <a:spLocks noGrp="1" noRot="1" noChangeAspect="1"/>
+          </p:cNvSpPr>
+          <p:nvPr>
+            <p:ph type="sldImg"/>
+          </p:nvPr>
+        </p:nvSpPr>
+        <p:spPr/>
+      </p:sp>
+      <p:sp>
+        <p:nvSpPr>
+          <p:cNvPr id="3" name="Notes Placeholder 2">
+            <a:extLst>
+              <a:ext uri="{FF2B5EF4-FFF2-40B4-BE49-F238E27FC236}">
+                <a16:creationId xmlns:a16="http://schemas.microsoft.com/office/drawing/2014/main" id="{0CB63FB7-7ADD-CDBA-2977-663E8B4F44BE}"/>
+              </a:ext>
+            </a:extLst>
+          </p:cNvPr>
+          <p:cNvSpPr>
+            <a:spLocks noGrp="1"/>
+          </p:cNvSpPr>
+          <p:nvPr>
+            <p:ph type="body" idx="1"/>
+          </p:nvPr>
+        </p:nvSpPr>
+        <p:spPr/>
+        <p:txBody>
+          <a:bodyPr/>
+          <a:lstStyle/>
+          <a:p>
+            <a:pPr marL="0" indent="0">
+              <a:buFont typeface="Arial" panose="020B0604020202020204" pitchFamily="34" charset="0"/>
+              <a:buNone/>
+            </a:pPr>
+            <a:r>
+              <a:rPr lang="en-US" sz="1200" kern="1200" dirty="0">
+                <a:solidFill>
+                  <a:schemeClr val="tx1"/>
+                </a:solidFill>
+                <a:effectLst/>
+                <a:latin typeface="+mn-lt"/>
+                <a:ea typeface="+mn-ea"/>
+                <a:cs typeface="+mn-cs"/>
+              </a:rPr>
+              <a:t>Baseline lab and quality-of-life measures between participants by whether they had complete measurements or not, and stratified by baseline hard drug use</a:t>
+            </a:r>
+            <a:r>
+              <a:rPr lang="en-US" dirty="0">
+                <a:effectLst/>
+              </a:rPr>
+              <a:t> </a:t>
+            </a:r>
+            <a:endParaRPr lang="en-US" dirty="0"/>
+          </a:p>
+          <a:p>
+            <a:pPr marL="171450" indent="-171450">
+              <a:buFont typeface="Arial" panose="020B0604020202020204" pitchFamily="34" charset="0"/>
+              <a:buChar char="•"/>
+            </a:pPr>
+            <a:endParaRPr lang="en-US" dirty="0"/>
+          </a:p>
+          <a:p>
+            <a:pPr marL="171450" indent="-171450">
+              <a:buFont typeface="Arial" panose="020B0604020202020204" pitchFamily="34" charset="0"/>
+              <a:buChar char="•"/>
+            </a:pPr>
+            <a:r>
+              <a:rPr lang="en-US" dirty="0"/>
+              <a:t>Loss to follow-up appeared to be most associated with lower baseline physical QOL scores within both hard drug users and non-users but not so with baseline laboratory measures</a:t>
+            </a:r>
+          </a:p>
+          <a:p>
+            <a:pPr marL="171450" indent="-171450">
+              <a:buFont typeface="Arial" panose="020B0604020202020204" pitchFamily="34" charset="0"/>
+              <a:buChar char="•"/>
+            </a:pPr>
+            <a:endParaRPr lang="en-US" dirty="0"/>
+          </a:p>
+          <a:p>
+            <a:pPr marL="171450" indent="-171450">
+              <a:buFont typeface="Arial" panose="020B0604020202020204" pitchFamily="34" charset="0"/>
+              <a:buChar char="•"/>
+            </a:pPr>
+            <a:r>
+              <a:rPr lang="en-US" dirty="0"/>
+              <a:t>Younger age -&gt; higher odds of dropping out</a:t>
+            </a:r>
+          </a:p>
+          <a:p>
+            <a:pPr marL="171450" indent="-171450">
+              <a:buFont typeface="Arial" panose="020B0604020202020204" pitchFamily="34" charset="0"/>
+              <a:buChar char="•"/>
+            </a:pPr>
+            <a:r>
+              <a:rPr lang="en-US" dirty="0"/>
+              <a:t>Lower physical QOL = higher odds of dropping out</a:t>
+            </a:r>
+          </a:p>
+        </p:txBody>
+      </p:sp>
+      <p:sp>
+        <p:nvSpPr>
+          <p:cNvPr id="4" name="Slide Number Placeholder 3">
+            <a:extLst>
+              <a:ext uri="{FF2B5EF4-FFF2-40B4-BE49-F238E27FC236}">
+                <a16:creationId xmlns:a16="http://schemas.microsoft.com/office/drawing/2014/main" id="{4BF687E7-EE41-77F6-A19D-4CEC4F60E66B}"/>
+              </a:ext>
+            </a:extLst>
+          </p:cNvPr>
+          <p:cNvSpPr>
+            <a:spLocks noGrp="1"/>
+          </p:cNvSpPr>
+          <p:nvPr>
+            <p:ph type="sldNum" sz="quarter" idx="5"/>
+          </p:nvPr>
+        </p:nvSpPr>
+        <p:spPr/>
+        <p:txBody>
+          <a:bodyPr/>
+          <a:lstStyle/>
+          <a:p>
+            <a:fld id="{8055A014-AA40-5B4A-A5FD-4F58A1D7AE4A}" type="slidenum">
+              <a:rPr lang="en-US" smtClean="0"/>
+              <a:t>7</a:t>
+            </a:fld>
+            <a:endParaRPr lang="en-US"/>
+          </a:p>
+        </p:txBody>
+      </p:sp>
+    </p:spTree>
+    <p:extLst>
+      <p:ext uri="{BB962C8B-B14F-4D97-AF65-F5344CB8AC3E}">
+        <p14:creationId xmlns:p14="http://schemas.microsoft.com/office/powerpoint/2010/main" val="3777470123"/>
+      </p:ext>
+    </p:extLst>
+  </p:cSld>
+  <p:clrMapOvr>
+    <a:masterClrMapping/>
+  </p:clrMapOvr>
+</p:notes>
+</file>
+
+<file path=ppt/notesSlides/notesSlide8.xml><?xml version="1.0" encoding="utf-8"?>
 <p:notes xmlns:a="http://schemas.openxmlformats.org/drawingml/2006/main" xmlns:r="http://schemas.openxmlformats.org/officeDocument/2006/relationships" xmlns:p="http://schemas.openxmlformats.org/presentationml/2006/main">
   <p:cSld>
     <p:spTree>
@@ -1320,7 +1536,7 @@
                 <a:ea typeface="+mn-ea"/>
                 <a:cs typeface="+mn-cs"/>
               </a:rPr>
-              <a:t>In summary, booklet-recorded times closely tracked cap times, with booklet times tending to be recorded earlier. </a:t>
+              <a:t>In summary,</a:t>
             </a:r>
           </a:p>
           <a:p>
@@ -1345,13 +1561,26 @@
                 <a:ea typeface="+mn-ea"/>
                 <a:cs typeface="+mn-cs"/>
               </a:rPr>
-              <a:t>Adherence to protocol-defined windows varied by sample and threshold, with lower adherence being observed for later collections and tighter windows, </a:t>
-            </a:r>
-          </a:p>
-          <a:p>
-            <a:pPr marL="171450" indent="-171450">
-              <a:buFont typeface="Arial" panose="020B0604020202020204" pitchFamily="34" charset="0"/>
-              <a:buChar char="•"/>
+              <a:t>At year 2:</a:t>
+            </a:r>
+          </a:p>
+          <a:p>
+            <a:pPr marL="0" marR="0" lvl="0" indent="0" algn="l" defTabSz="914400" rtl="0" eaLnBrk="1" fontAlgn="auto" latinLnBrk="0" hangingPunct="1">
+              <a:lnSpc>
+                <a:spcPct val="100000"/>
+              </a:lnSpc>
+              <a:spcBef>
+                <a:spcPts val="0"/>
+              </a:spcBef>
+              <a:spcAft>
+                <a:spcPts val="0"/>
+              </a:spcAft>
+              <a:buClrTx/>
+              <a:buSzTx/>
+              <a:buFontTx/>
+              <a:buNone/>
+              <a:tabLst/>
+              <a:defRPr/>
             </a:pPr>
             <a:r>
               <a:rPr lang="en-US" sz="1200" kern="1200" dirty="0">
@@ -1363,14 +1592,10 @@
                 <a:ea typeface="+mn-ea"/>
                 <a:cs typeface="+mn-cs"/>
               </a:rPr>
-              <a:t>booklet-based timing showed higher adherence as compared to cap-based timing.</a:t>
-            </a:r>
-          </a:p>
-          <a:p>
-            <a:pPr marL="171450" indent="-171450">
-              <a:buFont typeface="Arial" panose="020B0604020202020204" pitchFamily="34" charset="0"/>
-              <a:buChar char="•"/>
-            </a:pPr>
+              <a:t>Overall, these findings suggest that baseline hard drug use is associated with poorer immunologic recovery and lower physical quality of life following HAART initiation, but adherence does not appear to meaningfully mediate these associations.</a:t>
+            </a:r>
+          </a:p>
+          <a:p>
             <a:endParaRPr lang="en-US" sz="1200" kern="1200" dirty="0">
               <a:solidFill>
                 <a:schemeClr val="tx1"/>
@@ -1382,105 +1607,24 @@
             </a:endParaRPr>
           </a:p>
           <a:p>
-            <a:pPr marL="0" indent="0">
-              <a:buFont typeface="Arial" panose="020B0604020202020204" pitchFamily="34" charset="0"/>
-              <a:buNone/>
-            </a:pPr>
-            <a:r>
-              <a:rPr lang="en-US" sz="1200" kern="1200" dirty="0">
-                <a:solidFill>
-                  <a:schemeClr val="tx1"/>
-                </a:solidFill>
-                <a:effectLst/>
-                <a:latin typeface="+mn-lt"/>
-                <a:ea typeface="+mn-ea"/>
-                <a:cs typeface="+mn-cs"/>
-              </a:rPr>
-              <a:t>Cortisol and DHEA showed opposite rates of change during the first 30min of waking but based on prior literature this is to be expected.</a:t>
-            </a:r>
-          </a:p>
-          <a:p>
-            <a:endParaRPr lang="en-US" sz="1200" kern="1200" dirty="0">
-              <a:solidFill>
-                <a:schemeClr val="tx1"/>
-              </a:solidFill>
-              <a:effectLst/>
-              <a:latin typeface="+mn-lt"/>
-              <a:ea typeface="+mn-ea"/>
-              <a:cs typeface="+mn-cs"/>
-            </a:endParaRPr>
-          </a:p>
-          <a:p>
-            <a:r>
-              <a:rPr lang="en-US" sz="1200" kern="1200" dirty="0">
-                <a:solidFill>
-                  <a:schemeClr val="tx1"/>
-                </a:solidFill>
-                <a:effectLst/>
-                <a:latin typeface="+mn-lt"/>
-                <a:ea typeface="+mn-ea"/>
-                <a:cs typeface="+mn-cs"/>
-              </a:rPr>
-              <a:t>So, when we take all these points together, I believe these results supports the feasibility of this type of saliva collection method for studying hormone trajectories over time.</a:t>
-            </a:r>
-            <a:br>
-              <a:rPr lang="en-US" sz="1200" kern="1200" dirty="0">
-                <a:solidFill>
-                  <a:schemeClr val="tx1"/>
-                </a:solidFill>
-                <a:effectLst/>
-                <a:latin typeface="+mn-lt"/>
-                <a:ea typeface="+mn-ea"/>
-                <a:cs typeface="+mn-cs"/>
-              </a:rPr>
-            </a:br>
-            <a:endParaRPr lang="en-US" sz="1200" kern="1200" dirty="0">
-              <a:solidFill>
-                <a:schemeClr val="tx1"/>
-              </a:solidFill>
-              <a:effectLst/>
-              <a:latin typeface="+mn-lt"/>
-              <a:ea typeface="+mn-ea"/>
-              <a:cs typeface="+mn-cs"/>
-            </a:endParaRPr>
-          </a:p>
-          <a:p>
-            <a:r>
-              <a:rPr lang="en-US" sz="1200" kern="1200" dirty="0">
-                <a:solidFill>
-                  <a:schemeClr val="tx1"/>
-                </a:solidFill>
-                <a:effectLst/>
-                <a:latin typeface="+mn-lt"/>
-                <a:ea typeface="+mn-ea"/>
-                <a:cs typeface="+mn-cs"/>
-              </a:rPr>
-              <a:t>But there are Key limitations of this analysis including missing data, which can bias some of the results if there’s some dependency on unobserved values or events</a:t>
-            </a:r>
-          </a:p>
-          <a:p>
-            <a:endParaRPr lang="en-US" sz="1200" kern="1200" dirty="0">
-              <a:solidFill>
-                <a:schemeClr val="tx1"/>
-              </a:solidFill>
-              <a:effectLst/>
-              <a:latin typeface="+mn-lt"/>
-              <a:ea typeface="+mn-ea"/>
-              <a:cs typeface="+mn-cs"/>
-            </a:endParaRPr>
-          </a:p>
-          <a:p>
-            <a:r>
-              <a:rPr lang="en-US" sz="1200" kern="1200" dirty="0">
-                <a:solidFill>
-                  <a:schemeClr val="tx1"/>
-                </a:solidFill>
-                <a:effectLst/>
-                <a:latin typeface="+mn-lt"/>
-                <a:ea typeface="+mn-ea"/>
-                <a:cs typeface="+mn-cs"/>
-              </a:rPr>
-              <a:t>and lastly the use of a simple mixed-effects models, when used to evaluate agreement between the two collection methods, can not fully capture variability across the four collection samples </a:t>
+            <a:endParaRPr lang="en-US" dirty="0"/>
+          </a:p>
+          <a:p>
+            <a:r>
+              <a:rPr lang="en-US" dirty="0"/>
+              <a:t>Limitations:</a:t>
+            </a:r>
+          </a:p>
+          <a:p>
+            <a:r>
+              <a:rPr lang="en-US" dirty="0"/>
+              <a:t>Study can suffer bias from lack of randomization and unmeasured variables</a:t>
+            </a:r>
+          </a:p>
+          <a:p>
+            <a:r>
+              <a:rPr lang="en-US" dirty="0"/>
+              <a:t>Adherence was coded as binary – which may be too simplistic for classification. </a:t>
             </a:r>
           </a:p>
           <a:p>
@@ -1489,31 +1633,45 @@
               <a:buChar char="•"/>
             </a:pPr>
             <a:r>
-              <a:rPr lang="en-US" sz="1200" kern="1200" dirty="0">
-                <a:solidFill>
-                  <a:schemeClr val="tx1"/>
-                </a:solidFill>
-                <a:effectLst/>
-                <a:latin typeface="+mn-lt"/>
-                <a:ea typeface="+mn-ea"/>
-                <a:cs typeface="+mn-cs"/>
-              </a:rPr>
-              <a:t>I highlighted this back in the data overview section where there was wide ranges of differences between booklet-cap times, which likely reflects non-compliance and/or device recording errors, which are to be expected but caution should be taken when interpreting this idea of agreement</a:t>
-            </a:r>
-          </a:p>
-          <a:p>
-            <a:endParaRPr lang="en-US" sz="1200" kern="1200" dirty="0">
-              <a:solidFill>
-                <a:schemeClr val="tx1"/>
-              </a:solidFill>
-              <a:effectLst/>
-              <a:latin typeface="+mn-lt"/>
-              <a:ea typeface="+mn-ea"/>
-              <a:cs typeface="+mn-cs"/>
-            </a:endParaRPr>
-          </a:p>
-          <a:p>
-            <a:endParaRPr lang="en-US" dirty="0"/>
+              <a:rPr lang="en-US" dirty="0"/>
+              <a:t>Because of this classification and the negative proportion mediated, Adherence overall should be interpretated as more descriptive rather than a formal mediation approach</a:t>
+            </a:r>
+          </a:p>
+          <a:p>
+            <a:pPr marL="171450" indent="-171450">
+              <a:buFont typeface="Arial" panose="020B0604020202020204" pitchFamily="34" charset="0"/>
+              <a:buChar char="•"/>
+            </a:pPr>
+            <a:r>
+              <a:rPr lang="en-US" dirty="0"/>
+              <a:t>It also has strong confounding assumptions which can never be fully verified with observation studies </a:t>
+            </a:r>
+          </a:p>
+          <a:p>
+            <a:r>
+              <a:rPr lang="en-US" dirty="0"/>
+              <a:t>Hard drug user group was relatively small so we may not have had enough to power to make precise comparisons</a:t>
+            </a:r>
+          </a:p>
+          <a:p>
+            <a:r>
+              <a:rPr lang="en-US" dirty="0"/>
+              <a:t>SF-36 scores are limited in interpretation because it typically requires comparisons matched on </a:t>
+            </a:r>
+            <a:r>
+              <a:rPr lang="en-US" dirty="0" err="1"/>
+              <a:t>Age,Sex</a:t>
+            </a:r>
+            <a:r>
+              <a:rPr lang="en-US" dirty="0"/>
+              <a:t>, or other demographics, which was not done here</a:t>
+            </a:r>
+          </a:p>
+          <a:p>
+            <a:r>
+              <a:rPr lang="en-US" dirty="0"/>
+              <a:t>Lastly, missingness appeared to be associated with age and physical health, which were observed, but it may depend on some unmeasured factor that we did not model. So it suggests MAR but doesn’t prove it</a:t>
+            </a:r>
           </a:p>
         </p:txBody>
       </p:sp>
@@ -1534,7 +1692,7 @@
           <a:p>
             <a:fld id="{8055A014-AA40-5B4A-A5FD-4F58A1D7AE4A}" type="slidenum">
               <a:rPr lang="en-US" smtClean="0"/>
-              <a:t>7</a:t>
+              <a:t>8</a:t>
             </a:fld>
             <a:endParaRPr lang="en-US"/>
           </a:p>
@@ -3139,7 +3297,7 @@
             <p:spPr>
               <a:xfrm>
                 <a:off x="1092464" y="1054471"/>
-                <a:ext cx="11089232" cy="6194003"/>
+                <a:ext cx="11089232" cy="6488956"/>
               </a:xfrm>
               <a:prstGeom prst="rect">
                 <a:avLst/>
@@ -3411,12 +3569,8 @@
                   <a:buChar char="o"/>
                 </a:pPr>
                 <a:r>
-                  <a:rPr lang="en-US" dirty="0"/>
-                  <a:t>Age, BMI, smoking status, education, race/ethnicity</a:t>
-                </a:r>
-                <a:r>
                   <a:rPr lang="en-US" sz="2000" dirty="0"/>
-                  <a:t> </a:t>
+                  <a:t>Age, BMI, smoking status, education, race/ethnicity </a:t>
                 </a:r>
                 <a:endParaRPr lang="en-US" sz="2000" spc="-25" dirty="0">
                   <a:solidFill>
@@ -3630,6 +3784,24 @@
                     </a:solidFill>
                     <a:cs typeface="OAGDQN+FranklinGothic-BookItalic"/>
                   </a:rPr>
+                  <a:t>Complete cases vs incomplete (missing year2), stratified by hard drug users and non-users</a:t>
+                </a:r>
+              </a:p>
+              <a:p>
+                <a:pPr marL="1257300" lvl="2" indent="-342900">
+                  <a:lnSpc>
+                    <a:spcPts val="2258"/>
+                  </a:lnSpc>
+                  <a:buFont typeface="Courier New" panose="02070309020205020404" pitchFamily="49" charset="0"/>
+                  <a:buChar char="o"/>
+                </a:pPr>
+                <a:r>
+                  <a:rPr lang="en-US" sz="2000" spc="-25" dirty="0">
+                    <a:solidFill>
+                      <a:srgbClr val="181A0D"/>
+                    </a:solidFill>
+                    <a:cs typeface="OAGDQN+FranklinGothic-BookItalic"/>
+                  </a:rPr>
                   <a:t>Wilcoxon rank sum test</a:t>
                 </a:r>
               </a:p>
@@ -3648,7 +3820,7 @@
                     </a:solidFill>
                     <a:cs typeface="OAGDQN+FranklinGothic-BookItalic"/>
                   </a:rPr>
-                  <a:t>Complete cases vs incomplete (missing year2)</a:t>
+                  <a:t>Logistic regression w/complete measurements = 0 &amp; missing = 1</a:t>
                 </a:r>
               </a:p>
               <a:p>
@@ -3750,7 +3922,7 @@
             <p:spPr>
               <a:xfrm>
                 <a:off x="1092464" y="1054471"/>
-                <a:ext cx="11089232" cy="6194003"/>
+                <a:ext cx="11089232" cy="6488956"/>
               </a:xfrm>
               <a:prstGeom prst="rect">
                 <a:avLst/>
@@ -3758,7 +3930,7 @@
               <a:blipFill>
                 <a:blip r:embed="rId4"/>
                 <a:stretch>
-                  <a:fillRect l="-1486" t="-2664"/>
+                  <a:fillRect l="-1486" t="-2544"/>
                 </a:stretch>
               </a:blipFill>
             </p:spPr>
@@ -3842,7 +4014,7 @@
         <p:spPr>
           <a:xfrm>
             <a:off x="1463069" y="173199"/>
-            <a:ext cx="1903917" cy="641201"/>
+            <a:ext cx="7657267" cy="641201"/>
           </a:xfrm>
           <a:prstGeom prst="rect">
             <a:avLst/>
@@ -3874,6 +4046,21 @@
               </a:rPr>
               <a:t>Results</a:t>
             </a:r>
+            <a:r>
+              <a:rPr lang="en-US" sz="4400" spc="-12" dirty="0">
+                <a:solidFill>
+                  <a:srgbClr val="181A0D"/>
+                </a:solidFill>
+                <a:cs typeface="MPIRPG+FranklinGothic-Book"/>
+              </a:rPr>
+              <a:t> - treatment response</a:t>
+            </a:r>
+            <a:endParaRPr sz="4400" spc="-12" dirty="0">
+              <a:solidFill>
+                <a:srgbClr val="181A0D"/>
+              </a:solidFill>
+              <a:cs typeface="MPIRPG+FranklinGothic-Book"/>
+            </a:endParaRPr>
           </a:p>
         </p:txBody>
       </p:sp>
@@ -3891,8 +4078,8 @@
         </p:nvSpPr>
         <p:spPr>
           <a:xfrm>
-            <a:off x="875245" y="980779"/>
-            <a:ext cx="4392488" cy="5014193"/>
+            <a:off x="1703512" y="4853634"/>
+            <a:ext cx="4392488" cy="4129336"/>
           </a:xfrm>
           <a:prstGeom prst="rect">
             <a:avLst/>
@@ -3961,69 +4148,10 @@
             </a:endParaRPr>
           </a:p>
           <a:p>
-            <a:pPr marL="342900" indent="-342900">
-              <a:lnSpc>
-                <a:spcPts val="2258"/>
-              </a:lnSpc>
-              <a:buFont typeface="Wingdings" pitchFamily="2" charset="2"/>
-              <a:buChar char="Ø"/>
-            </a:pPr>
-            <a:endParaRPr lang="en-US" sz="2000" spc="-25" dirty="0">
-              <a:solidFill>
-                <a:srgbClr val="181A0D"/>
-              </a:solidFill>
-              <a:cs typeface="OAGDQN+FranklinGothic-BookItalic"/>
-            </a:endParaRPr>
-          </a:p>
-          <a:p>
-            <a:pPr marL="342900" marR="0" indent="-342900">
-              <a:lnSpc>
-                <a:spcPts val="2258"/>
-              </a:lnSpc>
-              <a:spcBef>
-                <a:spcPts val="0"/>
-              </a:spcBef>
-              <a:spcAft>
-                <a:spcPts val="0"/>
-              </a:spcAft>
-              <a:buFont typeface="Wingdings" pitchFamily="2" charset="2"/>
-              <a:buChar char="q"/>
-            </a:pPr>
-            <a:r>
-              <a:rPr lang="en-US" sz="2000" b="1" spc="-25" dirty="0">
-                <a:solidFill>
-                  <a:srgbClr val="181A0D"/>
-                </a:solidFill>
-                <a:cs typeface="OAGDQN+FranklinGothic-BookItalic"/>
-              </a:rPr>
-              <a:t>Adherence:</a:t>
-            </a:r>
-          </a:p>
-          <a:p>
-            <a:pPr marL="342900" indent="-342900">
-              <a:lnSpc>
-                <a:spcPts val="2258"/>
-              </a:lnSpc>
-              <a:buFont typeface="Wingdings" pitchFamily="2" charset="2"/>
-              <a:buChar char="Ø"/>
-            </a:pPr>
-            <a:r>
-              <a:rPr lang="en-US" sz="2000" spc="-25" dirty="0">
-                <a:solidFill>
-                  <a:srgbClr val="181A0D"/>
-                </a:solidFill>
-                <a:cs typeface="OAGDQN+FranklinGothic-BookItalic"/>
-              </a:rPr>
-              <a:t>±</a:t>
-            </a:r>
-          </a:p>
-          <a:p>
-            <a:pPr marL="800100" lvl="1" indent="-342900">
-              <a:lnSpc>
-                <a:spcPts val="2258"/>
-              </a:lnSpc>
-              <a:buFont typeface="Wingdings" pitchFamily="2" charset="2"/>
-              <a:buChar char="Ø"/>
+            <a:pPr lvl="1">
+              <a:lnSpc>
+                <a:spcPts val="2258"/>
+              </a:lnSpc>
             </a:pPr>
             <a:endParaRPr lang="en-US" sz="2000" spc="-25" dirty="0">
               <a:solidFill>
@@ -4180,10 +4308,10 @@
       </p:sp>
       <p:pic>
         <p:nvPicPr>
-          <p:cNvPr id="4" name="Picture 3" descr="A graph of different colored boxes&#10;&#10;AI-generated content may be incorrect.">
+          <p:cNvPr id="10" name="Picture 9" descr="A screenshot of a computer&#10;&#10;AI-generated content may be incorrect.">
             <a:extLst>
               <a:ext uri="{FF2B5EF4-FFF2-40B4-BE49-F238E27FC236}">
-                <a16:creationId xmlns:a16="http://schemas.microsoft.com/office/drawing/2014/main" id="{4D5A6EF3-C6DD-AED9-03C3-861AD6216702}"/>
+                <a16:creationId xmlns:a16="http://schemas.microsoft.com/office/drawing/2014/main" id="{83C7B31D-2D4F-03C6-A0AB-6D2DB7691526}"/>
               </a:ext>
             </a:extLst>
           </p:cNvPr>
@@ -4200,38 +4328,8 @@
         </p:blipFill>
         <p:spPr>
           <a:xfrm>
-            <a:off x="5780088" y="173199"/>
-            <a:ext cx="5547283" cy="3897427"/>
-          </a:xfrm>
-          <a:prstGeom prst="rect">
-            <a:avLst/>
-          </a:prstGeom>
-        </p:spPr>
-      </p:pic>
-      <p:pic>
-        <p:nvPicPr>
-          <p:cNvPr id="9" name="Picture 8">
-            <a:extLst>
-              <a:ext uri="{FF2B5EF4-FFF2-40B4-BE49-F238E27FC236}">
-                <a16:creationId xmlns:a16="http://schemas.microsoft.com/office/drawing/2014/main" id="{C9A6FD47-8844-5F74-EE60-E7A9FFA9F8B6}"/>
-              </a:ext>
-            </a:extLst>
-          </p:cNvPr>
-          <p:cNvPicPr>
-            <a:picLocks noChangeAspect="1"/>
-          </p:cNvPicPr>
-          <p:nvPr/>
-        </p:nvPicPr>
-        <p:blipFill>
-          <a:blip r:embed="rId5"/>
-          <a:stretch>
-            <a:fillRect/>
-          </a:stretch>
-        </p:blipFill>
-        <p:spPr>
-          <a:xfrm>
-            <a:off x="5529393" y="4129819"/>
-            <a:ext cx="6048672" cy="2554982"/>
+            <a:off x="2207568" y="934019"/>
+            <a:ext cx="8593371" cy="3799996"/>
           </a:xfrm>
           <a:prstGeom prst="rect">
             <a:avLst/>
@@ -4333,26 +4431,32 @@
                 </a:solidFill>
                 <a:cs typeface="WPQCJM+FranklinGothic-Book"/>
               </a:rPr>
-              <a:t>Results,</a:t>
-            </a:r>
-            <a:r>
-              <a:rPr sz="4400" spc="13" dirty="0">
+              <a:t>Results</a:t>
+            </a:r>
+            <a:r>
+              <a:rPr lang="en-US" sz="4400" spc="-11" dirty="0">
                 <a:solidFill>
                   <a:srgbClr val="181A0D"/>
                 </a:solidFill>
                 <a:cs typeface="WPQCJM+FranklinGothic-Book"/>
               </a:rPr>
-              <a:t> </a:t>
-            </a:r>
-            <a:r>
-              <a:rPr sz="4400" dirty="0">
+              <a:t> - </a:t>
+            </a:r>
+            <a:r>
+              <a:rPr lang="en-US" sz="4400" dirty="0">
                 <a:solidFill>
                   <a:srgbClr val="181A0D"/>
                 </a:solidFill>
                 <a:cs typeface="WPQCJM+FranklinGothic-Book"/>
               </a:rPr>
-              <a:t>continued</a:t>
-            </a:r>
+              <a:t>mediation</a:t>
+            </a:r>
+            <a:endParaRPr sz="4400" dirty="0">
+              <a:solidFill>
+                <a:srgbClr val="181A0D"/>
+              </a:solidFill>
+              <a:cs typeface="WPQCJM+FranklinGothic-Book"/>
+            </a:endParaRPr>
           </a:p>
         </p:txBody>
       </p:sp>
@@ -4371,7 +4475,7 @@
         <p:spPr>
           <a:xfrm>
             <a:off x="875244" y="980779"/>
-            <a:ext cx="4811155" cy="10028386"/>
+            <a:ext cx="4811155" cy="4424288"/>
           </a:xfrm>
           <a:prstGeom prst="rect">
             <a:avLst/>
@@ -4394,17 +4498,14 @@
                 <a:spcPts val="0"/>
               </a:spcAft>
               <a:buFont typeface="Wingdings" pitchFamily="2" charset="2"/>
-              <a:buChar char="q"/>
-            </a:pPr>
-            <a:r>
-              <a:rPr lang="en-US" b="1" spc="-25" dirty="0">
-                <a:solidFill>
-                  <a:srgbClr val="181A0D"/>
-                </a:solidFill>
-                <a:cs typeface="OAGDQN+FranklinGothic-BookItalic"/>
-              </a:rPr>
-              <a:t>Cortisol Trends:</a:t>
-            </a:r>
+              <a:buChar char="Ø"/>
+            </a:pPr>
+            <a:endParaRPr lang="en-US" sz="2000" spc="-25" dirty="0">
+              <a:solidFill>
+                <a:srgbClr val="181A0D"/>
+              </a:solidFill>
+              <a:cs typeface="OAGDQN+FranklinGothic-BookItalic"/>
+            </a:endParaRPr>
           </a:p>
           <a:p>
             <a:pPr marL="342900" marR="0" indent="-342900">
@@ -4420,15 +4521,12 @@
               <a:buFont typeface="Wingdings" pitchFamily="2" charset="2"/>
               <a:buChar char="Ø"/>
             </a:pPr>
-            <a:r>
-              <a:rPr lang="en-US" spc="-25" dirty="0">
-                <a:solidFill>
-                  <a:srgbClr val="181A0D"/>
-                </a:solidFill>
-                <a:cs typeface="OAGDQN+FranklinGothic-BookItalic"/>
-              </a:rPr>
-              <a:t>On average, a subject’s cortisol levels increased by 0.6% per minute (≈20% cumulatively) during the first 30min after waking (95% CI: -0.1% to 1.3%; p=0.09).</a:t>
-            </a:r>
+            <a:endParaRPr lang="en-US" sz="2000" spc="-25" dirty="0">
+              <a:solidFill>
+                <a:srgbClr val="181A0D"/>
+              </a:solidFill>
+              <a:cs typeface="OAGDQN+FranklinGothic-BookItalic"/>
+            </a:endParaRPr>
           </a:p>
           <a:p>
             <a:pPr marL="342900" marR="0" indent="-342900">
@@ -4444,7 +4542,7 @@
               <a:buFont typeface="Wingdings" pitchFamily="2" charset="2"/>
               <a:buChar char="Ø"/>
             </a:pPr>
-            <a:endParaRPr lang="en-US" spc="-25" dirty="0">
+            <a:endParaRPr lang="en-US" sz="2000" spc="-25" dirty="0">
               <a:solidFill>
                 <a:srgbClr val="181A0D"/>
               </a:solidFill>
@@ -4452,25 +4550,7 @@
             </a:endParaRPr>
           </a:p>
           <a:p>
-            <a:pPr marL="342900" indent="-342900">
-              <a:lnSpc>
-                <a:spcPts val="2258"/>
-              </a:lnSpc>
-              <a:buFont typeface="Wingdings" pitchFamily="2" charset="2"/>
-              <a:buChar char="Ø"/>
-            </a:pPr>
-            <a:r>
-              <a:rPr lang="en-US" spc="-25" dirty="0">
-                <a:solidFill>
-                  <a:srgbClr val="181A0D"/>
-                </a:solidFill>
-                <a:cs typeface="OAGDQN+FranklinGothic-BookItalic"/>
-              </a:rPr>
-              <a:t>After 30min, a subject’s cortisol levels decreased by 12.5% per hour, on average (95% CI: -14.4% to -10.6%; p&lt;0.001)</a:t>
-            </a:r>
-          </a:p>
-          <a:p>
-            <a:pPr marR="0">
+            <a:pPr marL="342900" marR="0" indent="-342900">
               <a:lnSpc>
                 <a:spcPts val="2258"/>
               </a:lnSpc>
@@ -4480,8 +4560,10 @@
               <a:spcAft>
                 <a:spcPts val="0"/>
               </a:spcAft>
-            </a:pPr>
-            <a:endParaRPr lang="en-US" spc="-25" dirty="0">
+              <a:buFont typeface="Wingdings" pitchFamily="2" charset="2"/>
+              <a:buChar char="Ø"/>
+            </a:pPr>
+            <a:endParaRPr lang="en-US" sz="2000" spc="-25" dirty="0">
               <a:solidFill>
                 <a:srgbClr val="181A0D"/>
               </a:solidFill>
@@ -4500,17 +4582,102 @@
                 <a:spcPts val="0"/>
               </a:spcAft>
               <a:buFont typeface="Wingdings" pitchFamily="2" charset="2"/>
+              <a:buChar char="Ø"/>
+            </a:pPr>
+            <a:endParaRPr lang="en-US" sz="2000" b="1" spc="-25" dirty="0">
+              <a:solidFill>
+                <a:srgbClr val="181A0D"/>
+              </a:solidFill>
+              <a:cs typeface="OAGDQN+FranklinGothic-BookItalic"/>
+            </a:endParaRPr>
+          </a:p>
+          <a:p>
+            <a:pPr>
+              <a:lnSpc>
+                <a:spcPts val="2258"/>
+              </a:lnSpc>
+            </a:pPr>
+            <a:endParaRPr lang="en-US" sz="2000" spc="-25" dirty="0">
+              <a:solidFill>
+                <a:srgbClr val="181A0D"/>
+              </a:solidFill>
+              <a:cs typeface="OAGDQN+FranklinGothic-BookItalic"/>
+            </a:endParaRPr>
+          </a:p>
+          <a:p>
+            <a:pPr marL="800100" lvl="1" indent="-342900">
+              <a:lnSpc>
+                <a:spcPts val="2258"/>
+              </a:lnSpc>
+              <a:buFont typeface="Wingdings" pitchFamily="2" charset="2"/>
+              <a:buChar char="Ø"/>
+            </a:pPr>
+            <a:endParaRPr lang="en-US" sz="2000" spc="-25" dirty="0">
+              <a:solidFill>
+                <a:srgbClr val="181A0D"/>
+              </a:solidFill>
+              <a:cs typeface="OAGDQN+FranklinGothic-BookItalic"/>
+            </a:endParaRPr>
+          </a:p>
+          <a:p>
+            <a:pPr marL="342900" indent="-342900">
+              <a:lnSpc>
+                <a:spcPts val="2258"/>
+              </a:lnSpc>
+              <a:buFont typeface="Wingdings" pitchFamily="2" charset="2"/>
+              <a:buChar char="Ø"/>
+            </a:pPr>
+            <a:endParaRPr lang="en-US" sz="2000" spc="-25" dirty="0">
+              <a:solidFill>
+                <a:srgbClr val="181A0D"/>
+              </a:solidFill>
+              <a:cs typeface="OAGDQN+FranklinGothic-BookItalic"/>
+            </a:endParaRPr>
+          </a:p>
+          <a:p>
+            <a:pPr marL="800100" lvl="1" indent="-342900">
+              <a:lnSpc>
+                <a:spcPts val="2258"/>
+              </a:lnSpc>
+              <a:buFont typeface="Arial" panose="020B0604020202020204" pitchFamily="34" charset="0"/>
+              <a:buChar char="•"/>
+            </a:pPr>
+            <a:endParaRPr lang="en-US" sz="2000" spc="-25" dirty="0">
+              <a:solidFill>
+                <a:srgbClr val="181A0D"/>
+              </a:solidFill>
+              <a:cs typeface="OAGDQN+FranklinGothic-BookItalic"/>
+            </a:endParaRPr>
+          </a:p>
+          <a:p>
+            <a:pPr marL="342900" indent="-342900">
+              <a:lnSpc>
+                <a:spcPts val="2258"/>
+              </a:lnSpc>
+              <a:buFont typeface="Wingdings" pitchFamily="2" charset="2"/>
               <a:buChar char="q"/>
             </a:pPr>
-            <a:r>
-              <a:rPr lang="en-US" b="1" spc="-25" dirty="0">
-                <a:solidFill>
-                  <a:srgbClr val="181A0D"/>
-                </a:solidFill>
-                <a:cs typeface="OAGDQN+FranklinGothic-BookItalic"/>
-              </a:rPr>
-              <a:t>DHEA Trends:</a:t>
-            </a:r>
+            <a:endParaRPr lang="en-US" sz="2000" spc="-25" dirty="0">
+              <a:solidFill>
+                <a:srgbClr val="181A0D"/>
+              </a:solidFill>
+              <a:cs typeface="OAGDQN+FranklinGothic-BookItalic"/>
+            </a:endParaRPr>
+          </a:p>
+          <a:p>
+            <a:pPr marL="342900" indent="-342900">
+              <a:lnSpc>
+                <a:spcPts val="2258"/>
+              </a:lnSpc>
+              <a:buFont typeface="Wingdings" pitchFamily="2" charset="2"/>
+              <a:buChar char="Ø"/>
+            </a:pPr>
+            <a:endParaRPr lang="en-US" sz="2000" spc="-25" dirty="0">
+              <a:solidFill>
+                <a:srgbClr val="181A0D"/>
+              </a:solidFill>
+              <a:cs typeface="OAGDQN+FranklinGothic-BookItalic"/>
+            </a:endParaRPr>
           </a:p>
           <a:p>
             <a:pPr marL="342900" marR="0" indent="-342900">
@@ -4524,17 +4691,14 @@
                 <a:spcPts val="0"/>
               </a:spcAft>
               <a:buFont typeface="Wingdings" pitchFamily="2" charset="2"/>
-              <a:buChar char="Ø"/>
-            </a:pPr>
-            <a:r>
-              <a:rPr lang="en-US" spc="-25" dirty="0">
-                <a:solidFill>
-                  <a:srgbClr val="181A0D"/>
-                </a:solidFill>
-                <a:cs typeface="OAGDQN+FranklinGothic-BookItalic"/>
-              </a:rPr>
-              <a:t>On average, a subject’s DHEA levels decreased by 1.8% per minute (≈58% cumulatively) during the first 30min after waking (95% CI: -2.4% to -1.2%; p&lt;0.001).</a:t>
-            </a:r>
+              <a:buChar char="q"/>
+            </a:pPr>
+            <a:endParaRPr lang="en-US" sz="2000" spc="-25" dirty="0">
+              <a:solidFill>
+                <a:srgbClr val="181A0D"/>
+              </a:solidFill>
+              <a:cs typeface="OAGDQN+FranklinGothic-BookItalic"/>
+            </a:endParaRPr>
           </a:p>
           <a:p>
             <a:pPr marL="342900" marR="0" indent="-342900">
@@ -4548,9 +4712,9 @@
                 <a:spcPts val="0"/>
               </a:spcAft>
               <a:buFont typeface="Wingdings" pitchFamily="2" charset="2"/>
-              <a:buChar char="Ø"/>
-            </a:pPr>
-            <a:endParaRPr lang="en-US" spc="-25" dirty="0">
+              <a:buChar char="q"/>
+            </a:pPr>
+            <a:endParaRPr lang="en-US" sz="2000" spc="-25" dirty="0">
               <a:solidFill>
                 <a:srgbClr val="181A0D"/>
               </a:solidFill>
@@ -4569,17 +4733,14 @@
                 <a:spcPts val="0"/>
               </a:spcAft>
               <a:buFont typeface="Wingdings" pitchFamily="2" charset="2"/>
-              <a:buChar char="Ø"/>
-            </a:pPr>
-            <a:r>
-              <a:rPr lang="en-US" spc="-25" dirty="0">
-                <a:solidFill>
-                  <a:srgbClr val="181A0D"/>
-                </a:solidFill>
-                <a:cs typeface="OAGDQN+FranklinGothic-BookItalic"/>
-              </a:rPr>
-              <a:t>After 30min, a subject’s DHEA levels decreased by 8.9% per hour (95% CI: -10.5% to -7.2%; p&lt;0.001)</a:t>
-            </a:r>
+              <a:buChar char="q"/>
+            </a:pPr>
+            <a:endParaRPr lang="en-US" sz="2000" spc="-25" dirty="0">
+              <a:solidFill>
+                <a:srgbClr val="181A0D"/>
+              </a:solidFill>
+              <a:cs typeface="OAGDQN+FranklinGothic-BookItalic"/>
+            </a:endParaRPr>
           </a:p>
           <a:p>
             <a:pPr marL="342900" marR="0" indent="-342900">
@@ -4593,262 +4754,6 @@
                 <a:spcPts val="0"/>
               </a:spcAft>
               <a:buFont typeface="Wingdings" pitchFamily="2" charset="2"/>
-              <a:buChar char="Ø"/>
-            </a:pPr>
-            <a:endParaRPr lang="en-US" sz="2000" spc="-25" dirty="0">
-              <a:solidFill>
-                <a:srgbClr val="181A0D"/>
-              </a:solidFill>
-              <a:cs typeface="OAGDQN+FranklinGothic-BookItalic"/>
-            </a:endParaRPr>
-          </a:p>
-          <a:p>
-            <a:pPr marL="342900" marR="0" indent="-342900">
-              <a:lnSpc>
-                <a:spcPts val="2258"/>
-              </a:lnSpc>
-              <a:spcBef>
-                <a:spcPts val="0"/>
-              </a:spcBef>
-              <a:spcAft>
-                <a:spcPts val="0"/>
-              </a:spcAft>
-              <a:buFont typeface="Wingdings" pitchFamily="2" charset="2"/>
-              <a:buChar char="Ø"/>
-            </a:pPr>
-            <a:endParaRPr lang="en-US" sz="2000" spc="-25" dirty="0">
-              <a:solidFill>
-                <a:srgbClr val="181A0D"/>
-              </a:solidFill>
-              <a:cs typeface="OAGDQN+FranklinGothic-BookItalic"/>
-            </a:endParaRPr>
-          </a:p>
-          <a:p>
-            <a:pPr marL="342900" marR="0" indent="-342900">
-              <a:lnSpc>
-                <a:spcPts val="2258"/>
-              </a:lnSpc>
-              <a:spcBef>
-                <a:spcPts val="0"/>
-              </a:spcBef>
-              <a:spcAft>
-                <a:spcPts val="0"/>
-              </a:spcAft>
-              <a:buFont typeface="Wingdings" pitchFamily="2" charset="2"/>
-              <a:buChar char="Ø"/>
-            </a:pPr>
-            <a:endParaRPr lang="en-US" sz="2000" spc="-25" dirty="0">
-              <a:solidFill>
-                <a:srgbClr val="181A0D"/>
-              </a:solidFill>
-              <a:cs typeface="OAGDQN+FranklinGothic-BookItalic"/>
-            </a:endParaRPr>
-          </a:p>
-          <a:p>
-            <a:pPr marL="342900" marR="0" indent="-342900">
-              <a:lnSpc>
-                <a:spcPts val="2258"/>
-              </a:lnSpc>
-              <a:spcBef>
-                <a:spcPts val="0"/>
-              </a:spcBef>
-              <a:spcAft>
-                <a:spcPts val="0"/>
-              </a:spcAft>
-              <a:buFont typeface="Wingdings" pitchFamily="2" charset="2"/>
-              <a:buChar char="Ø"/>
-            </a:pPr>
-            <a:endParaRPr lang="en-US" sz="2000" spc="-25" dirty="0">
-              <a:solidFill>
-                <a:srgbClr val="181A0D"/>
-              </a:solidFill>
-              <a:cs typeface="OAGDQN+FranklinGothic-BookItalic"/>
-            </a:endParaRPr>
-          </a:p>
-          <a:p>
-            <a:pPr marL="342900" marR="0" indent="-342900">
-              <a:lnSpc>
-                <a:spcPts val="2258"/>
-              </a:lnSpc>
-              <a:spcBef>
-                <a:spcPts val="0"/>
-              </a:spcBef>
-              <a:spcAft>
-                <a:spcPts val="0"/>
-              </a:spcAft>
-              <a:buFont typeface="Wingdings" pitchFamily="2" charset="2"/>
-              <a:buChar char="Ø"/>
-            </a:pPr>
-            <a:endParaRPr lang="en-US" sz="2000" b="1" spc="-25" dirty="0">
-              <a:solidFill>
-                <a:srgbClr val="181A0D"/>
-              </a:solidFill>
-              <a:cs typeface="OAGDQN+FranklinGothic-BookItalic"/>
-            </a:endParaRPr>
-          </a:p>
-          <a:p>
-            <a:pPr>
-              <a:lnSpc>
-                <a:spcPts val="2258"/>
-              </a:lnSpc>
-            </a:pPr>
-            <a:endParaRPr lang="en-US" sz="2000" spc="-25" dirty="0">
-              <a:solidFill>
-                <a:srgbClr val="181A0D"/>
-              </a:solidFill>
-              <a:cs typeface="OAGDQN+FranklinGothic-BookItalic"/>
-            </a:endParaRPr>
-          </a:p>
-          <a:p>
-            <a:pPr marL="800100" lvl="1" indent="-342900">
-              <a:lnSpc>
-                <a:spcPts val="2258"/>
-              </a:lnSpc>
-              <a:buFont typeface="Wingdings" pitchFamily="2" charset="2"/>
-              <a:buChar char="Ø"/>
-            </a:pPr>
-            <a:endParaRPr lang="en-US" sz="2000" spc="-25" dirty="0">
-              <a:solidFill>
-                <a:srgbClr val="181A0D"/>
-              </a:solidFill>
-              <a:cs typeface="OAGDQN+FranklinGothic-BookItalic"/>
-            </a:endParaRPr>
-          </a:p>
-          <a:p>
-            <a:pPr marL="342900" indent="-342900">
-              <a:lnSpc>
-                <a:spcPts val="2258"/>
-              </a:lnSpc>
-              <a:buFont typeface="Wingdings" pitchFamily="2" charset="2"/>
-              <a:buChar char="Ø"/>
-            </a:pPr>
-            <a:endParaRPr lang="en-US" sz="2000" spc="-25" dirty="0">
-              <a:solidFill>
-                <a:srgbClr val="181A0D"/>
-              </a:solidFill>
-              <a:cs typeface="OAGDQN+FranklinGothic-BookItalic"/>
-            </a:endParaRPr>
-          </a:p>
-          <a:p>
-            <a:pPr marL="800100" lvl="1" indent="-342900">
-              <a:lnSpc>
-                <a:spcPts val="2258"/>
-              </a:lnSpc>
-              <a:buFont typeface="Arial" panose="020B0604020202020204" pitchFamily="34" charset="0"/>
-              <a:buChar char="•"/>
-            </a:pPr>
-            <a:endParaRPr lang="en-US" sz="2000" spc="-25" dirty="0">
-              <a:solidFill>
-                <a:srgbClr val="181A0D"/>
-              </a:solidFill>
-              <a:cs typeface="OAGDQN+FranklinGothic-BookItalic"/>
-            </a:endParaRPr>
-          </a:p>
-          <a:p>
-            <a:pPr marL="342900" indent="-342900">
-              <a:lnSpc>
-                <a:spcPts val="2258"/>
-              </a:lnSpc>
-              <a:buFont typeface="Wingdings" pitchFamily="2" charset="2"/>
-              <a:buChar char="q"/>
-            </a:pPr>
-            <a:endParaRPr lang="en-US" sz="2000" spc="-25" dirty="0">
-              <a:solidFill>
-                <a:srgbClr val="181A0D"/>
-              </a:solidFill>
-              <a:cs typeface="OAGDQN+FranklinGothic-BookItalic"/>
-            </a:endParaRPr>
-          </a:p>
-          <a:p>
-            <a:pPr marL="342900" indent="-342900">
-              <a:lnSpc>
-                <a:spcPts val="2258"/>
-              </a:lnSpc>
-              <a:buFont typeface="Wingdings" pitchFamily="2" charset="2"/>
-              <a:buChar char="Ø"/>
-            </a:pPr>
-            <a:endParaRPr lang="en-US" sz="2000" spc="-25" dirty="0">
-              <a:solidFill>
-                <a:srgbClr val="181A0D"/>
-              </a:solidFill>
-              <a:cs typeface="OAGDQN+FranklinGothic-BookItalic"/>
-            </a:endParaRPr>
-          </a:p>
-          <a:p>
-            <a:pPr marL="342900" marR="0" indent="-342900">
-              <a:lnSpc>
-                <a:spcPts val="2258"/>
-              </a:lnSpc>
-              <a:spcBef>
-                <a:spcPts val="0"/>
-              </a:spcBef>
-              <a:spcAft>
-                <a:spcPts val="0"/>
-              </a:spcAft>
-              <a:buFont typeface="Wingdings" pitchFamily="2" charset="2"/>
-              <a:buChar char="q"/>
-            </a:pPr>
-            <a:endParaRPr lang="en-US" sz="2000" spc="-25" dirty="0">
-              <a:solidFill>
-                <a:srgbClr val="181A0D"/>
-              </a:solidFill>
-              <a:cs typeface="OAGDQN+FranklinGothic-BookItalic"/>
-            </a:endParaRPr>
-          </a:p>
-          <a:p>
-            <a:pPr marL="342900" marR="0" indent="-342900">
-              <a:lnSpc>
-                <a:spcPts val="2258"/>
-              </a:lnSpc>
-              <a:spcBef>
-                <a:spcPts val="0"/>
-              </a:spcBef>
-              <a:spcAft>
-                <a:spcPts val="0"/>
-              </a:spcAft>
-              <a:buFont typeface="Wingdings" pitchFamily="2" charset="2"/>
-              <a:buChar char="q"/>
-            </a:pPr>
-            <a:endParaRPr lang="en-US" sz="2000" spc="-25" dirty="0">
-              <a:solidFill>
-                <a:srgbClr val="181A0D"/>
-              </a:solidFill>
-              <a:cs typeface="OAGDQN+FranklinGothic-BookItalic"/>
-            </a:endParaRPr>
-          </a:p>
-          <a:p>
-            <a:pPr marL="342900" marR="0" indent="-342900">
-              <a:lnSpc>
-                <a:spcPts val="2258"/>
-              </a:lnSpc>
-              <a:spcBef>
-                <a:spcPts val="0"/>
-              </a:spcBef>
-              <a:spcAft>
-                <a:spcPts val="0"/>
-              </a:spcAft>
-              <a:buFont typeface="Wingdings" pitchFamily="2" charset="2"/>
-              <a:buChar char="q"/>
-            </a:pPr>
-            <a:endParaRPr lang="en-US" sz="2000" spc="-25" dirty="0">
-              <a:solidFill>
-                <a:srgbClr val="181A0D"/>
-              </a:solidFill>
-              <a:cs typeface="OAGDQN+FranklinGothic-BookItalic"/>
-            </a:endParaRPr>
-          </a:p>
-          <a:p>
-            <a:pPr marL="342900" marR="0" indent="-342900">
-              <a:lnSpc>
-                <a:spcPts val="2258"/>
-              </a:lnSpc>
-              <a:spcBef>
-                <a:spcPts val="0"/>
-              </a:spcBef>
-              <a:spcAft>
-                <a:spcPts val="0"/>
-              </a:spcAft>
-              <a:buFont typeface="Wingdings" pitchFamily="2" charset="2"/>
               <a:buChar char="q"/>
             </a:pPr>
             <a:endParaRPr sz="2000" spc="-25" dirty="0">
@@ -4860,6 +4765,36 @@
           </a:p>
         </p:txBody>
       </p:sp>
+      <p:pic>
+        <p:nvPicPr>
+          <p:cNvPr id="5" name="Picture 4" descr="A screenshot of a computer&#10;&#10;AI-generated content may be incorrect.">
+            <a:extLst>
+              <a:ext uri="{FF2B5EF4-FFF2-40B4-BE49-F238E27FC236}">
+                <a16:creationId xmlns:a16="http://schemas.microsoft.com/office/drawing/2014/main" id="{FC982772-C5EA-DA3E-6CBC-3ED39B55EF11}"/>
+              </a:ext>
+            </a:extLst>
+          </p:cNvPr>
+          <p:cNvPicPr>
+            <a:picLocks noChangeAspect="1"/>
+          </p:cNvPicPr>
+          <p:nvPr/>
+        </p:nvPicPr>
+        <p:blipFill>
+          <a:blip r:embed="rId4"/>
+          <a:stretch>
+            <a:fillRect/>
+          </a:stretch>
+        </p:blipFill>
+        <p:spPr>
+          <a:xfrm>
+            <a:off x="1760800" y="1089432"/>
+            <a:ext cx="9073120" cy="4206981"/>
+          </a:xfrm>
+          <a:prstGeom prst="rect">
+            <a:avLst/>
+          </a:prstGeom>
+        </p:spPr>
+      </p:pic>
     </p:spTree>
   </p:cSld>
   <p:clrMapOvr>
@@ -4869,6 +4804,479 @@
 </file>
 
 <file path=ppt/slides/slide7.xml><?xml version="1.0" encoding="utf-8"?>
+<p:sld xmlns:a="http://schemas.openxmlformats.org/drawingml/2006/main" xmlns:r="http://schemas.openxmlformats.org/officeDocument/2006/relationships" xmlns:p="http://schemas.openxmlformats.org/presentationml/2006/main">
+  <p:cSld>
+    <p:spTree>
+      <p:nvGrpSpPr>
+        <p:cNvPr id="1" name="">
+          <a:extLst>
+            <a:ext uri="{FF2B5EF4-FFF2-40B4-BE49-F238E27FC236}">
+              <a16:creationId xmlns:a16="http://schemas.microsoft.com/office/drawing/2014/main" id="{CC67BFF8-83E8-1705-B857-C1662A4C399D}"/>
+            </a:ext>
+          </a:extLst>
+        </p:cNvPr>
+        <p:cNvGrpSpPr/>
+        <p:nvPr/>
+      </p:nvGrpSpPr>
+      <p:grpSpPr>
+        <a:xfrm>
+          <a:off x="0" y="0"/>
+          <a:ext cx="0" cy="0"/>
+          <a:chOff x="0" y="0"/>
+          <a:chExt cx="0" cy="0"/>
+        </a:xfrm>
+      </p:grpSpPr>
+      <p:sp>
+        <p:nvSpPr>
+          <p:cNvPr id="2" name="object 1">
+            <a:extLst>
+              <a:ext uri="{FF2B5EF4-FFF2-40B4-BE49-F238E27FC236}">
+                <a16:creationId xmlns:a16="http://schemas.microsoft.com/office/drawing/2014/main" id="{893EAD98-92CD-50E2-1499-119554E29617}"/>
+              </a:ext>
+            </a:extLst>
+          </p:cNvPr>
+          <p:cNvSpPr/>
+          <p:nvPr/>
+        </p:nvSpPr>
+        <p:spPr>
+          <a:xfrm>
+            <a:off x="0" y="14166"/>
+            <a:ext cx="12192000" cy="6858000"/>
+          </a:xfrm>
+          <a:prstGeom prst="rect">
+            <a:avLst/>
+          </a:prstGeom>
+          <a:blipFill>
+            <a:blip r:embed="rId3" cstate="print"/>
+            <a:stretch>
+              <a:fillRect/>
+            </a:stretch>
+          </a:blipFill>
+        </p:spPr>
+        <p:txBody>
+          <a:bodyPr wrap="square" lIns="0" tIns="0" rIns="0" bIns="0" rtlCol="0">
+            <a:spAutoFit/>
+          </a:bodyPr>
+          <a:lstStyle/>
+          <a:p>
+            <a:endParaRPr dirty="0"/>
+          </a:p>
+        </p:txBody>
+      </p:sp>
+      <p:sp>
+        <p:nvSpPr>
+          <p:cNvPr id="3" name="object 3">
+            <a:extLst>
+              <a:ext uri="{FF2B5EF4-FFF2-40B4-BE49-F238E27FC236}">
+                <a16:creationId xmlns:a16="http://schemas.microsoft.com/office/drawing/2014/main" id="{918818CD-D913-2EBD-9985-7DE114355D85}"/>
+              </a:ext>
+            </a:extLst>
+          </p:cNvPr>
+          <p:cNvSpPr txBox="1"/>
+          <p:nvPr/>
+        </p:nvSpPr>
+        <p:spPr>
+          <a:xfrm>
+            <a:off x="1415480" y="188640"/>
+            <a:ext cx="4528479" cy="641201"/>
+          </a:xfrm>
+          <a:prstGeom prst="rect">
+            <a:avLst/>
+          </a:prstGeom>
+        </p:spPr>
+        <p:txBody>
+          <a:bodyPr vert="horz" wrap="square" lIns="0" tIns="0" rIns="0" bIns="0" rtlCol="0">
+            <a:spAutoFit/>
+          </a:bodyPr>
+          <a:lstStyle/>
+          <a:p>
+            <a:pPr marL="0" marR="0">
+              <a:lnSpc>
+                <a:spcPts val="4979"/>
+              </a:lnSpc>
+              <a:spcBef>
+                <a:spcPts val="0"/>
+              </a:spcBef>
+              <a:spcAft>
+                <a:spcPts val="0"/>
+              </a:spcAft>
+            </a:pPr>
+            <a:r>
+              <a:rPr sz="4400" spc="-11" dirty="0">
+                <a:solidFill>
+                  <a:srgbClr val="181A0D"/>
+                </a:solidFill>
+                <a:cs typeface="WPQCJM+FranklinGothic-Book"/>
+              </a:rPr>
+              <a:t>Results</a:t>
+            </a:r>
+            <a:r>
+              <a:rPr lang="en-US" sz="4400" spc="-11" dirty="0">
+                <a:solidFill>
+                  <a:srgbClr val="181A0D"/>
+                </a:solidFill>
+                <a:cs typeface="WPQCJM+FranklinGothic-Book"/>
+              </a:rPr>
+              <a:t> – follow-up</a:t>
+            </a:r>
+            <a:endParaRPr sz="4400" dirty="0">
+              <a:solidFill>
+                <a:srgbClr val="181A0D"/>
+              </a:solidFill>
+              <a:cs typeface="WPQCJM+FranklinGothic-Book"/>
+            </a:endParaRPr>
+          </a:p>
+        </p:txBody>
+      </p:sp>
+      <p:sp>
+        <p:nvSpPr>
+          <p:cNvPr id="8" name="object 4">
+            <a:extLst>
+              <a:ext uri="{FF2B5EF4-FFF2-40B4-BE49-F238E27FC236}">
+                <a16:creationId xmlns:a16="http://schemas.microsoft.com/office/drawing/2014/main" id="{7A565ACD-C3A5-C6FF-175E-9FA2948A8278}"/>
+              </a:ext>
+            </a:extLst>
+          </p:cNvPr>
+          <p:cNvSpPr txBox="1"/>
+          <p:nvPr/>
+        </p:nvSpPr>
+        <p:spPr>
+          <a:xfrm>
+            <a:off x="875244" y="980779"/>
+            <a:ext cx="4811155" cy="4424288"/>
+          </a:xfrm>
+          <a:prstGeom prst="rect">
+            <a:avLst/>
+          </a:prstGeom>
+        </p:spPr>
+        <p:txBody>
+          <a:bodyPr vert="horz" wrap="square" lIns="0" tIns="0" rIns="0" bIns="0" rtlCol="0">
+            <a:spAutoFit/>
+          </a:bodyPr>
+          <a:lstStyle/>
+          <a:p>
+            <a:pPr marL="342900" marR="0" indent="-342900">
+              <a:lnSpc>
+                <a:spcPts val="2258"/>
+              </a:lnSpc>
+              <a:spcBef>
+                <a:spcPts val="0"/>
+              </a:spcBef>
+              <a:spcAft>
+                <a:spcPts val="0"/>
+              </a:spcAft>
+              <a:buFont typeface="Wingdings" pitchFamily="2" charset="2"/>
+              <a:buChar char="Ø"/>
+            </a:pPr>
+            <a:endParaRPr lang="en-US" sz="2000" spc="-25" dirty="0">
+              <a:solidFill>
+                <a:srgbClr val="181A0D"/>
+              </a:solidFill>
+              <a:cs typeface="OAGDQN+FranklinGothic-BookItalic"/>
+            </a:endParaRPr>
+          </a:p>
+          <a:p>
+            <a:pPr marL="342900" marR="0" indent="-342900">
+              <a:lnSpc>
+                <a:spcPts val="2258"/>
+              </a:lnSpc>
+              <a:spcBef>
+                <a:spcPts val="0"/>
+              </a:spcBef>
+              <a:spcAft>
+                <a:spcPts val="0"/>
+              </a:spcAft>
+              <a:buFont typeface="Wingdings" pitchFamily="2" charset="2"/>
+              <a:buChar char="Ø"/>
+            </a:pPr>
+            <a:endParaRPr lang="en-US" sz="2000" spc="-25" dirty="0">
+              <a:solidFill>
+                <a:srgbClr val="181A0D"/>
+              </a:solidFill>
+              <a:cs typeface="OAGDQN+FranklinGothic-BookItalic"/>
+            </a:endParaRPr>
+          </a:p>
+          <a:p>
+            <a:pPr marL="342900" marR="0" indent="-342900">
+              <a:lnSpc>
+                <a:spcPts val="2258"/>
+              </a:lnSpc>
+              <a:spcBef>
+                <a:spcPts val="0"/>
+              </a:spcBef>
+              <a:spcAft>
+                <a:spcPts val="0"/>
+              </a:spcAft>
+              <a:buFont typeface="Wingdings" pitchFamily="2" charset="2"/>
+              <a:buChar char="Ø"/>
+            </a:pPr>
+            <a:endParaRPr lang="en-US" sz="2000" spc="-25" dirty="0">
+              <a:solidFill>
+                <a:srgbClr val="181A0D"/>
+              </a:solidFill>
+              <a:cs typeface="OAGDQN+FranklinGothic-BookItalic"/>
+            </a:endParaRPr>
+          </a:p>
+          <a:p>
+            <a:pPr marL="342900" marR="0" indent="-342900">
+              <a:lnSpc>
+                <a:spcPts val="2258"/>
+              </a:lnSpc>
+              <a:spcBef>
+                <a:spcPts val="0"/>
+              </a:spcBef>
+              <a:spcAft>
+                <a:spcPts val="0"/>
+              </a:spcAft>
+              <a:buFont typeface="Wingdings" pitchFamily="2" charset="2"/>
+              <a:buChar char="Ø"/>
+            </a:pPr>
+            <a:endParaRPr lang="en-US" sz="2000" spc="-25" dirty="0">
+              <a:solidFill>
+                <a:srgbClr val="181A0D"/>
+              </a:solidFill>
+              <a:cs typeface="OAGDQN+FranklinGothic-BookItalic"/>
+            </a:endParaRPr>
+          </a:p>
+          <a:p>
+            <a:pPr marL="342900" marR="0" indent="-342900">
+              <a:lnSpc>
+                <a:spcPts val="2258"/>
+              </a:lnSpc>
+              <a:spcBef>
+                <a:spcPts val="0"/>
+              </a:spcBef>
+              <a:spcAft>
+                <a:spcPts val="0"/>
+              </a:spcAft>
+              <a:buFont typeface="Wingdings" pitchFamily="2" charset="2"/>
+              <a:buChar char="Ø"/>
+            </a:pPr>
+            <a:endParaRPr lang="en-US" sz="2000" b="1" spc="-25" dirty="0">
+              <a:solidFill>
+                <a:srgbClr val="181A0D"/>
+              </a:solidFill>
+              <a:cs typeface="OAGDQN+FranklinGothic-BookItalic"/>
+            </a:endParaRPr>
+          </a:p>
+          <a:p>
+            <a:pPr>
+              <a:lnSpc>
+                <a:spcPts val="2258"/>
+              </a:lnSpc>
+            </a:pPr>
+            <a:endParaRPr lang="en-US" sz="2000" spc="-25" dirty="0">
+              <a:solidFill>
+                <a:srgbClr val="181A0D"/>
+              </a:solidFill>
+              <a:cs typeface="OAGDQN+FranklinGothic-BookItalic"/>
+            </a:endParaRPr>
+          </a:p>
+          <a:p>
+            <a:pPr marL="800100" lvl="1" indent="-342900">
+              <a:lnSpc>
+                <a:spcPts val="2258"/>
+              </a:lnSpc>
+              <a:buFont typeface="Wingdings" pitchFamily="2" charset="2"/>
+              <a:buChar char="Ø"/>
+            </a:pPr>
+            <a:endParaRPr lang="en-US" sz="2000" spc="-25" dirty="0">
+              <a:solidFill>
+                <a:srgbClr val="181A0D"/>
+              </a:solidFill>
+              <a:cs typeface="OAGDQN+FranklinGothic-BookItalic"/>
+            </a:endParaRPr>
+          </a:p>
+          <a:p>
+            <a:pPr marL="342900" indent="-342900">
+              <a:lnSpc>
+                <a:spcPts val="2258"/>
+              </a:lnSpc>
+              <a:buFont typeface="Wingdings" pitchFamily="2" charset="2"/>
+              <a:buChar char="Ø"/>
+            </a:pPr>
+            <a:endParaRPr lang="en-US" sz="2000" spc="-25" dirty="0">
+              <a:solidFill>
+                <a:srgbClr val="181A0D"/>
+              </a:solidFill>
+              <a:cs typeface="OAGDQN+FranklinGothic-BookItalic"/>
+            </a:endParaRPr>
+          </a:p>
+          <a:p>
+            <a:pPr marL="800100" lvl="1" indent="-342900">
+              <a:lnSpc>
+                <a:spcPts val="2258"/>
+              </a:lnSpc>
+              <a:buFont typeface="Arial" panose="020B0604020202020204" pitchFamily="34" charset="0"/>
+              <a:buChar char="•"/>
+            </a:pPr>
+            <a:endParaRPr lang="en-US" sz="2000" spc="-25" dirty="0">
+              <a:solidFill>
+                <a:srgbClr val="181A0D"/>
+              </a:solidFill>
+              <a:cs typeface="OAGDQN+FranklinGothic-BookItalic"/>
+            </a:endParaRPr>
+          </a:p>
+          <a:p>
+            <a:pPr marL="342900" indent="-342900">
+              <a:lnSpc>
+                <a:spcPts val="2258"/>
+              </a:lnSpc>
+              <a:buFont typeface="Wingdings" pitchFamily="2" charset="2"/>
+              <a:buChar char="q"/>
+            </a:pPr>
+            <a:endParaRPr lang="en-US" sz="2000" spc="-25" dirty="0">
+              <a:solidFill>
+                <a:srgbClr val="181A0D"/>
+              </a:solidFill>
+              <a:cs typeface="OAGDQN+FranklinGothic-BookItalic"/>
+            </a:endParaRPr>
+          </a:p>
+          <a:p>
+            <a:pPr marL="342900" indent="-342900">
+              <a:lnSpc>
+                <a:spcPts val="2258"/>
+              </a:lnSpc>
+              <a:buFont typeface="Wingdings" pitchFamily="2" charset="2"/>
+              <a:buChar char="Ø"/>
+            </a:pPr>
+            <a:endParaRPr lang="en-US" sz="2000" spc="-25" dirty="0">
+              <a:solidFill>
+                <a:srgbClr val="181A0D"/>
+              </a:solidFill>
+              <a:cs typeface="OAGDQN+FranklinGothic-BookItalic"/>
+            </a:endParaRPr>
+          </a:p>
+          <a:p>
+            <a:pPr marL="342900" marR="0" indent="-342900">
+              <a:lnSpc>
+                <a:spcPts val="2258"/>
+              </a:lnSpc>
+              <a:spcBef>
+                <a:spcPts val="0"/>
+              </a:spcBef>
+              <a:spcAft>
+                <a:spcPts val="0"/>
+              </a:spcAft>
+              <a:buFont typeface="Wingdings" pitchFamily="2" charset="2"/>
+              <a:buChar char="q"/>
+            </a:pPr>
+            <a:endParaRPr lang="en-US" sz="2000" spc="-25" dirty="0">
+              <a:solidFill>
+                <a:srgbClr val="181A0D"/>
+              </a:solidFill>
+              <a:cs typeface="OAGDQN+FranklinGothic-BookItalic"/>
+            </a:endParaRPr>
+          </a:p>
+          <a:p>
+            <a:pPr marL="342900" marR="0" indent="-342900">
+              <a:lnSpc>
+                <a:spcPts val="2258"/>
+              </a:lnSpc>
+              <a:spcBef>
+                <a:spcPts val="0"/>
+              </a:spcBef>
+              <a:spcAft>
+                <a:spcPts val="0"/>
+              </a:spcAft>
+              <a:buFont typeface="Wingdings" pitchFamily="2" charset="2"/>
+              <a:buChar char="q"/>
+            </a:pPr>
+            <a:endParaRPr lang="en-US" sz="2000" spc="-25" dirty="0">
+              <a:solidFill>
+                <a:srgbClr val="181A0D"/>
+              </a:solidFill>
+              <a:cs typeface="OAGDQN+FranklinGothic-BookItalic"/>
+            </a:endParaRPr>
+          </a:p>
+          <a:p>
+            <a:pPr marL="342900" marR="0" indent="-342900">
+              <a:lnSpc>
+                <a:spcPts val="2258"/>
+              </a:lnSpc>
+              <a:spcBef>
+                <a:spcPts val="0"/>
+              </a:spcBef>
+              <a:spcAft>
+                <a:spcPts val="0"/>
+              </a:spcAft>
+              <a:buFont typeface="Wingdings" pitchFamily="2" charset="2"/>
+              <a:buChar char="q"/>
+            </a:pPr>
+            <a:endParaRPr lang="en-US" sz="2000" spc="-25" dirty="0">
+              <a:solidFill>
+                <a:srgbClr val="181A0D"/>
+              </a:solidFill>
+              <a:cs typeface="OAGDQN+FranklinGothic-BookItalic"/>
+            </a:endParaRPr>
+          </a:p>
+          <a:p>
+            <a:pPr marL="342900" marR="0" indent="-342900">
+              <a:lnSpc>
+                <a:spcPts val="2258"/>
+              </a:lnSpc>
+              <a:spcBef>
+                <a:spcPts val="0"/>
+              </a:spcBef>
+              <a:spcAft>
+                <a:spcPts val="0"/>
+              </a:spcAft>
+              <a:buFont typeface="Wingdings" pitchFamily="2" charset="2"/>
+              <a:buChar char="q"/>
+            </a:pPr>
+            <a:endParaRPr sz="2000" spc="-25" dirty="0">
+              <a:solidFill>
+                <a:srgbClr val="181A0D"/>
+              </a:solidFill>
+              <a:cs typeface="OAGDQN+FranklinGothic-BookItalic"/>
+            </a:endParaRPr>
+          </a:p>
+        </p:txBody>
+      </p:sp>
+      <p:pic>
+        <p:nvPicPr>
+          <p:cNvPr id="5" name="Picture 4" descr="A screenshot of a computer&#10;&#10;AI-generated content may be incorrect.">
+            <a:extLst>
+              <a:ext uri="{FF2B5EF4-FFF2-40B4-BE49-F238E27FC236}">
+                <a16:creationId xmlns:a16="http://schemas.microsoft.com/office/drawing/2014/main" id="{971385C0-40DF-79F0-D47A-5B1F28B42EAA}"/>
+              </a:ext>
+            </a:extLst>
+          </p:cNvPr>
+          <p:cNvPicPr>
+            <a:picLocks noChangeAspect="1"/>
+          </p:cNvPicPr>
+          <p:nvPr/>
+        </p:nvPicPr>
+        <p:blipFill>
+          <a:blip r:embed="rId4"/>
+          <a:stretch>
+            <a:fillRect/>
+          </a:stretch>
+        </p:blipFill>
+        <p:spPr>
+          <a:xfrm>
+            <a:off x="2567608" y="1007371"/>
+            <a:ext cx="9449909" cy="5242882"/>
+          </a:xfrm>
+          <a:prstGeom prst="rect">
+            <a:avLst/>
+          </a:prstGeom>
+        </p:spPr>
+      </p:pic>
+    </p:spTree>
+    <p:extLst>
+      <p:ext uri="{BB962C8B-B14F-4D97-AF65-F5344CB8AC3E}">
+        <p14:creationId xmlns:p14="http://schemas.microsoft.com/office/powerpoint/2010/main" val="3605892447"/>
+      </p:ext>
+    </p:extLst>
+  </p:cSld>
+  <p:clrMapOvr>
+    <a:masterClrMapping/>
+  </p:clrMapOvr>
+</p:sld>
+</file>
+
+<file path=ppt/slides/slide8.xml><?xml version="1.0" encoding="utf-8"?>
 <p:sld xmlns:a="http://schemas.openxmlformats.org/drawingml/2006/main" xmlns:r="http://schemas.openxmlformats.org/officeDocument/2006/relationships" xmlns:p="http://schemas.openxmlformats.org/presentationml/2006/main" showMasterSp="0">
   <p:cSld>
     <p:spTree>
@@ -4981,7 +5389,7 @@
         <p:spPr>
           <a:xfrm>
             <a:off x="1415480" y="901849"/>
-            <a:ext cx="10297144" cy="7078861"/>
+            <a:ext cx="10297144" cy="6194003"/>
           </a:xfrm>
           <a:prstGeom prst="rect">
             <a:avLst/>
@@ -5022,7 +5430,7 @@
                 </a:solidFill>
                 <a:cs typeface="OAGDQN+FranklinGothic-BookItalic"/>
               </a:rPr>
-              <a:t>Booklet-record times closely tracked cap times, with an average bias of 6-7min being recorded by booklet method</a:t>
+              <a:t>Lower CD4 T-cell counts among baseline hard drug users</a:t>
             </a:r>
           </a:p>
           <a:p>
@@ -5033,6 +5441,60 @@
               <a:buFont typeface="Wingdings" pitchFamily="2" charset="2"/>
               <a:buChar char="q"/>
             </a:pPr>
+            <a:r>
+              <a:rPr lang="en-US" sz="2000" spc="-25" dirty="0">
+                <a:solidFill>
+                  <a:srgbClr val="181A0D"/>
+                </a:solidFill>
+                <a:cs typeface="OAGDQN+FranklinGothic-BookItalic"/>
+              </a:rPr>
+              <a:t>Lower physical QOL scores</a:t>
+            </a:r>
+          </a:p>
+          <a:p>
+            <a:pPr marL="342900" indent="-342900">
+              <a:lnSpc>
+                <a:spcPts val="2258"/>
+              </a:lnSpc>
+              <a:buFont typeface="Wingdings" pitchFamily="2" charset="2"/>
+              <a:buChar char="q"/>
+            </a:pPr>
+            <a:r>
+              <a:rPr lang="en-US" sz="2000" spc="-25" dirty="0">
+                <a:solidFill>
+                  <a:srgbClr val="181A0D"/>
+                </a:solidFill>
+                <a:cs typeface="OAGDQN+FranklinGothic-BookItalic"/>
+              </a:rPr>
+              <a:t>No meaningful differences in viral load or mental QOL</a:t>
+            </a:r>
+          </a:p>
+          <a:p>
+            <a:pPr marL="342900" indent="-342900">
+              <a:lnSpc>
+                <a:spcPts val="2258"/>
+              </a:lnSpc>
+              <a:buFont typeface="Wingdings" pitchFamily="2" charset="2"/>
+              <a:buChar char="q"/>
+            </a:pPr>
+            <a:r>
+              <a:rPr lang="en-US" sz="2000" spc="-25" dirty="0">
+                <a:solidFill>
+                  <a:srgbClr val="181A0D"/>
+                </a:solidFill>
+                <a:cs typeface="OAGDQN+FranklinGothic-BookItalic"/>
+              </a:rPr>
+              <a:t>Adherence wasn’t meaningful</a:t>
+            </a:r>
+          </a:p>
+          <a:p>
+            <a:pPr marL="342900" indent="-342900">
+              <a:lnSpc>
+                <a:spcPts val="2258"/>
+              </a:lnSpc>
+              <a:buFont typeface="Wingdings" pitchFamily="2" charset="2"/>
+              <a:buChar char="q"/>
+            </a:pPr>
             <a:endParaRPr lang="en-US" sz="2000" spc="-25" dirty="0">
               <a:solidFill>
                 <a:srgbClr val="181A0D"/>
@@ -5048,6 +5510,54 @@
               <a:buFont typeface="Wingdings" pitchFamily="2" charset="2"/>
               <a:buChar char="q"/>
             </a:pPr>
+            <a:endParaRPr lang="en-US" sz="2000" spc="-25" dirty="0">
+              <a:solidFill>
+                <a:srgbClr val="181A0D"/>
+              </a:solidFill>
+              <a:cs typeface="OAGDQN+FranklinGothic-BookItalic"/>
+            </a:endParaRPr>
+          </a:p>
+          <a:p>
+            <a:pPr marL="800100" lvl="1" indent="-342900">
+              <a:lnSpc>
+                <a:spcPts val="2258"/>
+              </a:lnSpc>
+              <a:buFont typeface="Wingdings" pitchFamily="2" charset="2"/>
+              <a:buChar char="q"/>
+            </a:pPr>
+            <a:endParaRPr lang="en-US" sz="2000" spc="-25" dirty="0">
+              <a:solidFill>
+                <a:srgbClr val="181A0D"/>
+              </a:solidFill>
+              <a:cs typeface="OAGDQN+FranklinGothic-BookItalic"/>
+            </a:endParaRPr>
+          </a:p>
+          <a:p>
+            <a:pPr marL="342900" indent="-342900">
+              <a:lnSpc>
+                <a:spcPts val="2258"/>
+              </a:lnSpc>
+              <a:buFont typeface="Wingdings" pitchFamily="2" charset="2"/>
+              <a:buChar char="q"/>
+            </a:pPr>
+            <a:r>
+              <a:rPr lang="en-US" sz="2000" b="1" spc="-25" dirty="0">
+                <a:solidFill>
+                  <a:srgbClr val="181A0D"/>
+                </a:solidFill>
+                <a:cs typeface="OAGDQN+FranklinGothic-BookItalic"/>
+              </a:rPr>
+              <a:t>Limitations:</a:t>
+            </a:r>
+          </a:p>
+          <a:p>
+            <a:pPr marL="800100" lvl="1" indent="-342900">
+              <a:lnSpc>
+                <a:spcPts val="2258"/>
+              </a:lnSpc>
+              <a:buFont typeface="Wingdings" pitchFamily="2" charset="2"/>
+              <a:buChar char="Ø"/>
+            </a:pPr>
             <a:r>
               <a:rPr lang="en-US" sz="2000" spc="-25" dirty="0">
                 <a:solidFill>
@@ -5055,7 +5565,7 @@
                 </a:solidFill>
                 <a:cs typeface="OAGDQN+FranklinGothic-BookItalic"/>
               </a:rPr>
-              <a:t>Adherence to protocol defined collection windows varied by sample and window</a:t>
+              <a:t>Observational study design</a:t>
             </a:r>
           </a:p>
           <a:p>
@@ -5073,7 +5583,7 @@
                 </a:solidFill>
                 <a:cs typeface="OAGDQN+FranklinGothic-BookItalic"/>
               </a:rPr>
-              <a:t>Lower adherence was noted at the +600min collection and ±7min window</a:t>
+              <a:t>Adherence coded as binary (&lt;95% vs ≥95%)</a:t>
             </a:r>
           </a:p>
           <a:p>
@@ -5091,32 +5601,17 @@
                 </a:solidFill>
                 <a:cs typeface="OAGDQN+FranklinGothic-BookItalic"/>
               </a:rPr>
-              <a:t>Booklet showed higher rates of adherence</a:t>
-            </a:r>
-          </a:p>
-          <a:p>
-            <a:pPr marL="1257300" lvl="2" indent="-342900">
+              <a:t>Mediation = exploratory </a:t>
+            </a:r>
+          </a:p>
+          <a:p>
+            <a:pPr marL="800100" lvl="1" indent="-342900">
               <a:lnSpc>
                 <a:spcPts val="2258"/>
               </a:lnSpc>
               <a:buFont typeface="Wingdings" pitchFamily="2" charset="2"/>
               <a:buChar char="Ø"/>
             </a:pPr>
-            <a:endParaRPr lang="en-US" sz="2000" spc="-25" dirty="0">
-              <a:solidFill>
-                <a:srgbClr val="181A0D"/>
-              </a:solidFill>
-              <a:cs typeface="OAGDQN+FranklinGothic-BookItalic"/>
-            </a:endParaRPr>
-          </a:p>
-          <a:p>
-            <a:pPr marL="342900" indent="-342900">
-              <a:lnSpc>
-                <a:spcPts val="2258"/>
-              </a:lnSpc>
-              <a:buFont typeface="Wingdings" pitchFamily="2" charset="2"/>
-              <a:buChar char="q"/>
-            </a:pPr>
             <a:r>
               <a:rPr lang="en-US" sz="2000" spc="-25" dirty="0">
                 <a:solidFill>
@@ -5124,7 +5619,7 @@
                 </a:solidFill>
                 <a:cs typeface="OAGDQN+FranklinGothic-BookItalic"/>
               </a:rPr>
-              <a:t>Cortisol and DHEA concentrations collected using booklet showed expected patterns</a:t>
+              <a:t>Hard drug user group was relatively small (36)</a:t>
             </a:r>
           </a:p>
           <a:p>
@@ -5142,29 +5637,16 @@
                 </a:solidFill>
                 <a:cs typeface="OAGDQN+FranklinGothic-BookItalic"/>
               </a:rPr>
-              <a:t>Prior literature has noted an inverse relationship (Ahmed et al 2023)</a:t>
-            </a:r>
-          </a:p>
-          <a:p>
-            <a:pPr lvl="1">
-              <a:lnSpc>
-                <a:spcPts val="2258"/>
-              </a:lnSpc>
-            </a:pPr>
-            <a:endParaRPr lang="en-US" sz="2000" spc="-25" dirty="0">
-              <a:solidFill>
-                <a:srgbClr val="181A0D"/>
-              </a:solidFill>
-              <a:cs typeface="OAGDQN+FranklinGothic-BookItalic"/>
-            </a:endParaRPr>
-          </a:p>
-          <a:p>
-            <a:pPr marL="342900" indent="-342900">
-              <a:lnSpc>
-                <a:spcPts val="2258"/>
-              </a:lnSpc>
-              <a:buFont typeface="Wingdings" pitchFamily="2" charset="2"/>
-              <a:buChar char="q"/>
+              <a:t>SF-36 Scores comparisons are limited</a:t>
+            </a:r>
+          </a:p>
+          <a:p>
+            <a:pPr marL="800100" lvl="1" indent="-342900">
+              <a:lnSpc>
+                <a:spcPts val="2258"/>
+              </a:lnSpc>
+              <a:buFont typeface="Wingdings" pitchFamily="2" charset="2"/>
+              <a:buChar char="Ø"/>
             </a:pPr>
             <a:r>
               <a:rPr lang="en-US" sz="2000" spc="-25" dirty="0">
@@ -5173,76 +5655,7 @@
                 </a:solidFill>
                 <a:cs typeface="OAGDQN+FranklinGothic-BookItalic"/>
               </a:rPr>
-              <a:t>Overall, despite some timing biases and variable adherence, the SPIT booklet appears to have the ability to capture expected diurnal patterns</a:t>
-            </a:r>
-          </a:p>
-          <a:p>
-            <a:pPr marL="800100" lvl="1" indent="-342900">
-              <a:lnSpc>
-                <a:spcPts val="2258"/>
-              </a:lnSpc>
-              <a:buFont typeface="Wingdings" pitchFamily="2" charset="2"/>
-              <a:buChar char="q"/>
-            </a:pPr>
-            <a:endParaRPr lang="en-US" sz="2000" spc="-25" dirty="0">
-              <a:solidFill>
-                <a:srgbClr val="181A0D"/>
-              </a:solidFill>
-              <a:cs typeface="OAGDQN+FranklinGothic-BookItalic"/>
-            </a:endParaRPr>
-          </a:p>
-          <a:p>
-            <a:pPr marL="342900" indent="-342900">
-              <a:lnSpc>
-                <a:spcPts val="2258"/>
-              </a:lnSpc>
-              <a:buFont typeface="Wingdings" pitchFamily="2" charset="2"/>
-              <a:buChar char="q"/>
-            </a:pPr>
-            <a:r>
-              <a:rPr lang="en-US" sz="2000" b="1" spc="-25" dirty="0">
-                <a:solidFill>
-                  <a:srgbClr val="181A0D"/>
-                </a:solidFill>
-                <a:cs typeface="OAGDQN+FranklinGothic-BookItalic"/>
-              </a:rPr>
-              <a:t>Limitations:</a:t>
-            </a:r>
-          </a:p>
-          <a:p>
-            <a:pPr marL="800100" lvl="1" indent="-342900">
-              <a:lnSpc>
-                <a:spcPts val="2258"/>
-              </a:lnSpc>
-              <a:buFont typeface="Wingdings" pitchFamily="2" charset="2"/>
-              <a:buChar char="Ø"/>
-            </a:pPr>
-            <a:r>
-              <a:rPr lang="en-US" sz="2000" spc="-25" dirty="0">
-                <a:solidFill>
-                  <a:srgbClr val="181A0D"/>
-                </a:solidFill>
-                <a:cs typeface="OAGDQN+FranklinGothic-BookItalic"/>
-              </a:rPr>
               <a:t>Missing data – biases if missingness depended on unobserved events</a:t>
-            </a:r>
-          </a:p>
-          <a:p>
-            <a:pPr marL="800100" lvl="1" indent="-342900">
-              <a:lnSpc>
-                <a:spcPts val="2258"/>
-              </a:lnSpc>
-              <a:buFont typeface="Wingdings" pitchFamily="2" charset="2"/>
-              <a:buChar char="Ø"/>
-            </a:pPr>
-            <a:r>
-              <a:rPr lang="en-US" sz="2000" spc="-25" dirty="0">
-                <a:solidFill>
-                  <a:srgbClr val="181A0D"/>
-                </a:solidFill>
-                <a:cs typeface="OAGDQN+FranklinGothic-BookItalic"/>
-              </a:rPr>
-              <a:t>Simple linear mixed model is limited in that it can’t capture specific collection sample variability</a:t>
             </a:r>
           </a:p>
           <a:p>

</xml_diff>

<commit_message>
Final touches on final report, presentation slides, and code.
</commit_message>
<xml_diff>
--- a/Project1/Reports/Project1_Presentation_summers.pptx
+++ b/Project1/Reports/Project1_Presentation_summers.pptx
@@ -5,56 +5,57 @@
     <p:sldMasterId id="2147483648" r:id="rId1"/>
   </p:sldMasterIdLst>
   <p:notesMasterIdLst>
-    <p:notesMasterId r:id="rId10"/>
+    <p:notesMasterId r:id="rId11"/>
   </p:notesMasterIdLst>
   <p:sldIdLst>
     <p:sldId id="260" r:id="rId2"/>
     <p:sldId id="261" r:id="rId3"/>
-    <p:sldId id="262" r:id="rId4"/>
-    <p:sldId id="263" r:id="rId5"/>
-    <p:sldId id="264" r:id="rId6"/>
-    <p:sldId id="265" r:id="rId7"/>
-    <p:sldId id="267" r:id="rId8"/>
-    <p:sldId id="266" r:id="rId9"/>
+    <p:sldId id="268" r:id="rId4"/>
+    <p:sldId id="262" r:id="rId5"/>
+    <p:sldId id="263" r:id="rId6"/>
+    <p:sldId id="264" r:id="rId7"/>
+    <p:sldId id="265" r:id="rId8"/>
+    <p:sldId id="267" r:id="rId9"/>
+    <p:sldId id="266" r:id="rId10"/>
   </p:sldIdLst>
   <p:sldSz cx="12192000" cy="6858000"/>
   <p:notesSz cx="12192000" cy="6858000"/>
   <p:embeddedFontLst>
     <p:embeddedFont>
       <p:font typeface="Cambria Math" panose="02040503050406030204" pitchFamily="18" charset="0"/>
-      <p:regular r:id="rId11"/>
+      <p:regular r:id="rId12"/>
     </p:embeddedFont>
     <p:embeddedFont>
       <p:font typeface="GEHAIV+FranklinGothic-Book" panose="02000500000000000000" pitchFamily="2" charset="0"/>
-      <p:regular r:id="rId12"/>
+      <p:regular r:id="rId13"/>
     </p:embeddedFont>
     <p:embeddedFont>
       <p:font typeface="KDMFEK+FranklinGothic-Book" panose="02000500000000000000" pitchFamily="2" charset="0"/>
-      <p:regular r:id="rId13"/>
+      <p:regular r:id="rId14"/>
     </p:embeddedFont>
     <p:embeddedFont>
       <p:font typeface="LVLFDH+FranklinGothic-Book" panose="02000500000000000000" pitchFamily="2" charset="0"/>
-      <p:regular r:id="rId14"/>
+      <p:regular r:id="rId15"/>
     </p:embeddedFont>
     <p:embeddedFont>
       <p:font typeface="MPIRPG+FranklinGothic-Book" panose="02000500000000000000" pitchFamily="2" charset="0"/>
-      <p:regular r:id="rId15"/>
+      <p:regular r:id="rId16"/>
     </p:embeddedFont>
     <p:embeddedFont>
       <p:font typeface="NOOILK+FranklinGothic-Book" panose="02000500000000000000" pitchFamily="2" charset="0"/>
-      <p:regular r:id="rId16"/>
+      <p:regular r:id="rId17"/>
     </p:embeddedFont>
     <p:embeddedFont>
       <p:font typeface="OAGDQN+FranklinGothic-BookItalic" panose="02000500000000000000" pitchFamily="2" charset="0"/>
-      <p:regular r:id="rId17"/>
+      <p:regular r:id="rId18"/>
     </p:embeddedFont>
     <p:embeddedFont>
       <p:font typeface="VTCKGD+FranklinGothic-Book" panose="02000500000000000000" pitchFamily="2" charset="0"/>
-      <p:regular r:id="rId18"/>
+      <p:regular r:id="rId19"/>
     </p:embeddedFont>
     <p:embeddedFont>
       <p:font typeface="WPQCJM+FranklinGothic-Book" panose="02000500000000000000" pitchFamily="2" charset="0"/>
-      <p:regular r:id="rId19"/>
+      <p:regular r:id="rId20"/>
     </p:embeddedFont>
   </p:embeddedFontLst>
   <p:defaultTextStyle>
@@ -675,7 +676,7 @@
                 <a:ea typeface="+mn-ea"/>
                 <a:cs typeface="+mn-cs"/>
               </a:rPr>
-              <a:t>This project was guided by three research questions: </a:t>
+              <a:t>The primary objective of this project was to determine whether baseline hard drug use was associated with differences in treatment response two years after initiating HAART.</a:t>
             </a:r>
           </a:p>
           <a:p>
@@ -858,7 +859,13 @@
   <p:cSld>
     <p:spTree>
       <p:nvGrpSpPr>
-        <p:cNvPr id="1" name=""/>
+        <p:cNvPr id="1" name="">
+          <a:extLst>
+            <a:ext uri="{FF2B5EF4-FFF2-40B4-BE49-F238E27FC236}">
+              <a16:creationId xmlns:a16="http://schemas.microsoft.com/office/drawing/2014/main" id="{02571355-85F6-CF92-4C8F-3100CC56C270}"/>
+            </a:ext>
+          </a:extLst>
+        </p:cNvPr>
         <p:cNvGrpSpPr/>
         <p:nvPr/>
       </p:nvGrpSpPr>
@@ -872,7 +879,13 @@
       </p:grpSpPr>
       <p:sp>
         <p:nvSpPr>
-          <p:cNvPr id="2" name="Slide Image Placeholder 1"/>
+          <p:cNvPr id="2" name="Slide Image Placeholder 1">
+            <a:extLst>
+              <a:ext uri="{FF2B5EF4-FFF2-40B4-BE49-F238E27FC236}">
+                <a16:creationId xmlns:a16="http://schemas.microsoft.com/office/drawing/2014/main" id="{555B7C8D-BDAB-8FCD-FB0D-EDFDCED0C7F0}"/>
+              </a:ext>
+            </a:extLst>
+          </p:cNvPr>
           <p:cNvSpPr>
             <a:spLocks noGrp="1" noRot="1" noChangeAspect="1"/>
           </p:cNvSpPr>
@@ -884,7 +897,13 @@
       </p:sp>
       <p:sp>
         <p:nvSpPr>
-          <p:cNvPr id="3" name="Notes Placeholder 2"/>
+          <p:cNvPr id="3" name="Notes Placeholder 2">
+            <a:extLst>
+              <a:ext uri="{FF2B5EF4-FFF2-40B4-BE49-F238E27FC236}">
+                <a16:creationId xmlns:a16="http://schemas.microsoft.com/office/drawing/2014/main" id="{66BF0FD8-6C3E-4632-2908-448E25301190}"/>
+              </a:ext>
+            </a:extLst>
+          </p:cNvPr>
           <p:cNvSpPr>
             <a:spLocks noGrp="1"/>
           </p:cNvSpPr>
@@ -897,6 +916,23 @@
           <a:bodyPr/>
           <a:lstStyle/>
           <a:p>
+            <a:pPr marL="0" marR="0" lvl="0" indent="0" algn="l" defTabSz="914400" rtl="0" eaLnBrk="1" fontAlgn="auto" latinLnBrk="0" hangingPunct="1">
+              <a:lnSpc>
+                <a:spcPct val="100000"/>
+              </a:lnSpc>
+              <a:spcBef>
+                <a:spcPts val="0"/>
+              </a:spcBef>
+              <a:spcAft>
+                <a:spcPts val="0"/>
+              </a:spcAft>
+              <a:buClrTx/>
+              <a:buSzTx/>
+              <a:buFontTx/>
+              <a:buNone/>
+              <a:tabLst/>
+              <a:defRPr/>
+            </a:pPr>
             <a:r>
               <a:rPr lang="en-US" sz="1200" kern="1200" dirty="0">
                 <a:solidFill>
@@ -907,7 +943,7 @@
                 <a:ea typeface="+mn-ea"/>
                 <a:cs typeface="+mn-cs"/>
               </a:rPr>
-              <a:t>Data comes from the MAC study which is a prospective cohort study of HIV-1 infection in homosexual and bisexual men from four major cities</a:t>
+              <a:t>The primary research question was whether baseline hard drug use was associated with differences in treatment response two years after initiating HAART</a:t>
             </a:r>
           </a:p>
           <a:p>
@@ -932,8 +968,19 @@
                 <a:ea typeface="+mn-ea"/>
                 <a:cs typeface="+mn-cs"/>
               </a:rPr>
-              <a:t>715 subjects were in the original dataset</a:t>
-            </a:r>
+              <a:t>Secondary objectives are to test whether adherence mediates the association between hard drug use and year-2 outcomes </a:t>
+            </a:r>
+          </a:p>
+          <a:p>
+            <a:endParaRPr lang="en-US" sz="1200" kern="1200" dirty="0">
+              <a:solidFill>
+                <a:schemeClr val="tx1"/>
+              </a:solidFill>
+              <a:effectLst/>
+              <a:latin typeface="+mn-lt"/>
+              <a:ea typeface="+mn-ea"/>
+              <a:cs typeface="+mn-cs"/>
+            </a:endParaRPr>
           </a:p>
           <a:p>
             <a:r>
@@ -946,7 +993,7 @@
                 <a:ea typeface="+mn-ea"/>
                 <a:cs typeface="+mn-cs"/>
               </a:rPr>
-              <a:t>With the implausible BMI values labeled as missing and doing a complete-case analysis on all outcomes and covariates reduced the dataset to 463 subjects being used</a:t>
+              <a:t>And to evaluate whether dropout rates differ between hard drug users and non-user</a:t>
             </a:r>
           </a:p>
           <a:p>
@@ -961,24 +1008,19 @@
             </a:endParaRPr>
           </a:p>
           <a:p>
-            <a:br>
-              <a:rPr lang="en-US" sz="1200" kern="1200" dirty="0">
-                <a:solidFill>
-                  <a:schemeClr val="tx1"/>
-                </a:solidFill>
-                <a:effectLst/>
-                <a:latin typeface="+mn-lt"/>
-                <a:ea typeface="+mn-ea"/>
-                <a:cs typeface="+mn-cs"/>
-              </a:rPr>
-            </a:br>
             <a:endParaRPr lang="en-US" dirty="0"/>
           </a:p>
         </p:txBody>
       </p:sp>
       <p:sp>
         <p:nvSpPr>
-          <p:cNvPr id="4" name="Slide Number Placeholder 3"/>
+          <p:cNvPr id="4" name="Slide Number Placeholder 3">
+            <a:extLst>
+              <a:ext uri="{FF2B5EF4-FFF2-40B4-BE49-F238E27FC236}">
+                <a16:creationId xmlns:a16="http://schemas.microsoft.com/office/drawing/2014/main" id="{759B22E7-FE82-EFCF-D187-6F41357AC3B4}"/>
+              </a:ext>
+            </a:extLst>
+          </p:cNvPr>
           <p:cNvSpPr>
             <a:spLocks noGrp="1"/>
           </p:cNvSpPr>
@@ -1002,7 +1044,7 @@
     </p:spTree>
     <p:extLst>
       <p:ext uri="{BB962C8B-B14F-4D97-AF65-F5344CB8AC3E}">
-        <p14:creationId xmlns:p14="http://schemas.microsoft.com/office/powerpoint/2010/main" val="774045196"/>
+        <p14:creationId xmlns:p14="http://schemas.microsoft.com/office/powerpoint/2010/main" val="1415825667"/>
       </p:ext>
     </p:extLst>
   </p:cSld>
@@ -1057,13 +1099,166 @@
           <a:lstStyle/>
           <a:p>
             <a:r>
-              <a:rPr lang="en-US" dirty="0" err="1"/>
-              <a:t>Df</a:t>
-            </a:r>
-            <a:r>
-              <a:rPr lang="en-US" dirty="0"/>
-              <a:t>=3 gives heavy tails to give less influence</a:t>
-            </a:r>
+              <a:rPr lang="en-US" sz="1200" kern="1200" dirty="0">
+                <a:solidFill>
+                  <a:schemeClr val="tx1"/>
+                </a:solidFill>
+                <a:effectLst/>
+                <a:latin typeface="+mn-lt"/>
+                <a:ea typeface="+mn-ea"/>
+                <a:cs typeface="+mn-cs"/>
+              </a:rPr>
+              <a:t>The initial dataset contained 715 HIV-infected men initiating HAART from the MAC study.</a:t>
+            </a:r>
+          </a:p>
+          <a:p>
+            <a:br>
+              <a:rPr lang="en-US" sz="1200" kern="1200" dirty="0">
+                <a:solidFill>
+                  <a:schemeClr val="tx1"/>
+                </a:solidFill>
+                <a:effectLst/>
+                <a:latin typeface="+mn-lt"/>
+                <a:ea typeface="+mn-ea"/>
+                <a:cs typeface="+mn-cs"/>
+              </a:rPr>
+            </a:br>
+            <a:r>
+              <a:rPr lang="en-US" sz="1200" kern="1200" dirty="0">
+                <a:solidFill>
+                  <a:schemeClr val="tx1"/>
+                </a:solidFill>
+                <a:effectLst/>
+                <a:latin typeface="+mn-lt"/>
+                <a:ea typeface="+mn-ea"/>
+                <a:cs typeface="+mn-cs"/>
+              </a:rPr>
+              <a:t>Of these, 463 had complete baseline and Year 2 data and were included in all regression analyses.</a:t>
+            </a:r>
+          </a:p>
+          <a:p>
+            <a:br>
+              <a:rPr lang="en-US" sz="1200" kern="1200" dirty="0">
+                <a:solidFill>
+                  <a:schemeClr val="tx1"/>
+                </a:solidFill>
+                <a:effectLst/>
+                <a:latin typeface="+mn-lt"/>
+                <a:ea typeface="+mn-ea"/>
+                <a:cs typeface="+mn-cs"/>
+              </a:rPr>
+            </a:br>
+            <a:r>
+              <a:rPr lang="en-US" sz="1200" kern="1200" dirty="0">
+                <a:solidFill>
+                  <a:schemeClr val="tx1"/>
+                </a:solidFill>
+                <a:effectLst/>
+                <a:latin typeface="+mn-lt"/>
+                <a:ea typeface="+mn-ea"/>
+                <a:cs typeface="+mn-cs"/>
+              </a:rPr>
+              <a:t>Viral load was log10-transformed due to skewness, while CD4 and QOL measures were analyzed on their original scales.</a:t>
+            </a:r>
+          </a:p>
+          <a:p>
+            <a:br>
+              <a:rPr lang="en-US" sz="1200" kern="1200" dirty="0">
+                <a:solidFill>
+                  <a:schemeClr val="tx1"/>
+                </a:solidFill>
+                <a:effectLst/>
+                <a:latin typeface="+mn-lt"/>
+                <a:ea typeface="+mn-ea"/>
+                <a:cs typeface="+mn-cs"/>
+              </a:rPr>
+            </a:br>
+            <a:r>
+              <a:rPr lang="en-US" sz="1200" kern="1200" dirty="0">
+                <a:solidFill>
+                  <a:schemeClr val="tx1"/>
+                </a:solidFill>
+                <a:effectLst/>
+                <a:latin typeface="+mn-lt"/>
+                <a:ea typeface="+mn-ea"/>
+                <a:cs typeface="+mn-cs"/>
+              </a:rPr>
+              <a:t>Hard drug use and adherence were both coded as binary variables.</a:t>
+            </a:r>
+          </a:p>
+          <a:p>
+            <a:pPr marL="171450" indent="-171450">
+              <a:buFont typeface="Arial" panose="020B0604020202020204" pitchFamily="34" charset="0"/>
+              <a:buChar char="•"/>
+            </a:pPr>
+            <a:r>
+              <a:rPr lang="en-US" sz="1200" kern="1200" dirty="0">
+                <a:solidFill>
+                  <a:schemeClr val="tx1"/>
+                </a:solidFill>
+                <a:effectLst/>
+                <a:latin typeface="+mn-lt"/>
+                <a:ea typeface="+mn-ea"/>
+                <a:cs typeface="+mn-cs"/>
+              </a:rPr>
+              <a:t>All but one of the hard drug users had adherence below 95%</a:t>
+            </a:r>
+          </a:p>
+          <a:p>
+            <a:br>
+              <a:rPr lang="en-US" sz="1200" kern="1200" dirty="0">
+                <a:solidFill>
+                  <a:schemeClr val="tx1"/>
+                </a:solidFill>
+                <a:effectLst/>
+                <a:latin typeface="+mn-lt"/>
+                <a:ea typeface="+mn-ea"/>
+                <a:cs typeface="+mn-cs"/>
+              </a:rPr>
+            </a:br>
+            <a:r>
+              <a:rPr lang="en-US" sz="1200" kern="1200" dirty="0">
+                <a:solidFill>
+                  <a:schemeClr val="tx1"/>
+                </a:solidFill>
+                <a:effectLst/>
+                <a:latin typeface="+mn-lt"/>
+                <a:ea typeface="+mn-ea"/>
+                <a:cs typeface="+mn-cs"/>
+              </a:rPr>
+              <a:t>At Baseline hard drug users reported lower physical and mental QOL scores and lower CD4 counts compared with non-users. Viral load and other </a:t>
+            </a:r>
+            <a:r>
+              <a:rPr lang="en-US" sz="1200" kern="1200" dirty="0" err="1">
+                <a:solidFill>
+                  <a:schemeClr val="tx1"/>
+                </a:solidFill>
+                <a:effectLst/>
+                <a:latin typeface="+mn-lt"/>
+                <a:ea typeface="+mn-ea"/>
+                <a:cs typeface="+mn-cs"/>
+              </a:rPr>
+              <a:t>covriate</a:t>
+            </a:r>
+            <a:r>
+              <a:rPr lang="en-US" sz="1200" kern="1200" dirty="0">
+                <a:solidFill>
+                  <a:schemeClr val="tx1"/>
+                </a:solidFill>
+                <a:effectLst/>
+                <a:latin typeface="+mn-lt"/>
+                <a:ea typeface="+mn-ea"/>
+                <a:cs typeface="+mn-cs"/>
+              </a:rPr>
+              <a:t> distributions were similar between groups.</a:t>
+            </a:r>
+            <a:r>
+              <a:rPr lang="en-US" dirty="0">
+                <a:effectLst/>
+              </a:rPr>
+              <a:t> </a:t>
+            </a:r>
+            <a:endParaRPr lang="en-US" dirty="0"/>
           </a:p>
         </p:txBody>
       </p:sp>
@@ -1093,7 +1288,7 @@
     </p:spTree>
     <p:extLst>
       <p:ext uri="{BB962C8B-B14F-4D97-AF65-F5344CB8AC3E}">
-        <p14:creationId xmlns:p14="http://schemas.microsoft.com/office/powerpoint/2010/main" val="1144915537"/>
+        <p14:creationId xmlns:p14="http://schemas.microsoft.com/office/powerpoint/2010/main" val="774045196"/>
       </p:ext>
     </p:extLst>
   </p:cSld>
@@ -1157,19 +1352,123 @@
                 <a:ea typeface="+mn-ea"/>
                 <a:cs typeface="+mn-cs"/>
               </a:rPr>
-              <a:t>As for results</a:t>
-            </a:r>
-          </a:p>
-          <a:p>
-            <a:endParaRPr lang="en-US" sz="1200" kern="1200" dirty="0">
-              <a:solidFill>
-                <a:schemeClr val="tx1"/>
-              </a:solidFill>
-              <a:effectLst/>
-              <a:latin typeface="+mn-lt"/>
-              <a:ea typeface="+mn-ea"/>
-              <a:cs typeface="+mn-cs"/>
-            </a:endParaRPr>
+              <a:t>First, to assess treatment response at Year 2, Bayesian regression was fitted using weakly-informative priors for each outcome</a:t>
+            </a:r>
+          </a:p>
+          <a:p>
+            <a:br>
+              <a:rPr lang="en-US" sz="1200" kern="1200" dirty="0">
+                <a:solidFill>
+                  <a:schemeClr val="tx1"/>
+                </a:solidFill>
+                <a:effectLst/>
+                <a:latin typeface="+mn-lt"/>
+                <a:ea typeface="+mn-ea"/>
+                <a:cs typeface="+mn-cs"/>
+              </a:rPr>
+            </a:br>
+            <a:r>
+              <a:rPr lang="en-US" sz="1200" kern="1200" dirty="0">
+                <a:solidFill>
+                  <a:schemeClr val="tx1"/>
+                </a:solidFill>
+                <a:effectLst/>
+                <a:latin typeface="+mn-lt"/>
+                <a:ea typeface="+mn-ea"/>
+                <a:cs typeface="+mn-cs"/>
+              </a:rPr>
+              <a:t>All models adjusted for the corresponding baseline outcome value and covariates</a:t>
+            </a:r>
+          </a:p>
+          <a:p>
+            <a:br>
+              <a:rPr lang="en-US" sz="1200" kern="1200" dirty="0">
+                <a:solidFill>
+                  <a:schemeClr val="tx1"/>
+                </a:solidFill>
+                <a:effectLst/>
+                <a:latin typeface="+mn-lt"/>
+                <a:ea typeface="+mn-ea"/>
+                <a:cs typeface="+mn-cs"/>
+              </a:rPr>
+            </a:br>
+            <a:r>
+              <a:rPr lang="en-US" sz="1200" kern="1200" dirty="0">
+                <a:solidFill>
+                  <a:schemeClr val="tx1"/>
+                </a:solidFill>
+                <a:effectLst/>
+                <a:latin typeface="+mn-lt"/>
+                <a:ea typeface="+mn-ea"/>
+                <a:cs typeface="+mn-cs"/>
+              </a:rPr>
+              <a:t>parallel frequentist models with identical covariate structure was also fit for comparison.</a:t>
+            </a:r>
+          </a:p>
+          <a:p>
+            <a:br>
+              <a:rPr lang="en-US" sz="1200" kern="1200" dirty="0">
+                <a:solidFill>
+                  <a:schemeClr val="tx1"/>
+                </a:solidFill>
+                <a:effectLst/>
+                <a:latin typeface="+mn-lt"/>
+                <a:ea typeface="+mn-ea"/>
+                <a:cs typeface="+mn-cs"/>
+              </a:rPr>
+            </a:br>
+            <a:r>
+              <a:rPr lang="en-US" sz="1200" kern="1200" dirty="0">
+                <a:solidFill>
+                  <a:schemeClr val="tx1"/>
+                </a:solidFill>
+                <a:effectLst/>
+                <a:latin typeface="+mn-lt"/>
+                <a:ea typeface="+mn-ea"/>
+                <a:cs typeface="+mn-cs"/>
+              </a:rPr>
+              <a:t>For adherence, the variable was dichotomized into less than 95% and greater than/equal to 95%</a:t>
+            </a:r>
+          </a:p>
+          <a:p>
+            <a:r>
+              <a:rPr lang="en-US" sz="1200" kern="1200" dirty="0">
+                <a:solidFill>
+                  <a:schemeClr val="tx1"/>
+                </a:solidFill>
+                <a:effectLst/>
+                <a:latin typeface="+mn-lt"/>
+                <a:ea typeface="+mn-ea"/>
+                <a:cs typeface="+mn-cs"/>
+              </a:rPr>
+              <a:t>Models were compared with and without adherence to see whether including adherence meaningfully changed the estimated hard drug association.</a:t>
+            </a:r>
+          </a:p>
+          <a:p>
+            <a:br>
+              <a:rPr lang="en-US" sz="1200" kern="1200" dirty="0">
+                <a:solidFill>
+                  <a:schemeClr val="tx1"/>
+                </a:solidFill>
+                <a:effectLst/>
+                <a:latin typeface="+mn-lt"/>
+                <a:ea typeface="+mn-ea"/>
+                <a:cs typeface="+mn-cs"/>
+              </a:rPr>
+            </a:br>
+            <a:r>
+              <a:rPr lang="en-US" sz="1200" kern="1200" dirty="0">
+                <a:solidFill>
+                  <a:schemeClr val="tx1"/>
+                </a:solidFill>
+                <a:effectLst/>
+                <a:latin typeface="+mn-lt"/>
+                <a:ea typeface="+mn-ea"/>
+                <a:cs typeface="+mn-cs"/>
+              </a:rPr>
+              <a:t>Finally, for analyzing drop-out rates, Baseline characteristics between participants with complete measurements and those missing Year 2 were compared using non-parametric tests and I also fit a logistic regression model using baseline outcome and covariate measures as predictors of dropout</a:t>
+            </a:r>
+            <a:endParaRPr lang="en-US" dirty="0"/>
           </a:p>
         </p:txBody>
       </p:sp>
@@ -1199,7 +1498,7 @@
     </p:spTree>
     <p:extLst>
       <p:ext uri="{BB962C8B-B14F-4D97-AF65-F5344CB8AC3E}">
-        <p14:creationId xmlns:p14="http://schemas.microsoft.com/office/powerpoint/2010/main" val="826435084"/>
+        <p14:creationId xmlns:p14="http://schemas.microsoft.com/office/powerpoint/2010/main" val="1144915537"/>
       </p:ext>
     </p:extLst>
   </p:cSld>
@@ -1253,22 +1552,124 @@
           <a:bodyPr/>
           <a:lstStyle/>
           <a:p>
-            <a:pPr marL="171450" indent="-171450">
-              <a:buFont typeface="Arial" panose="020B0604020202020204" pitchFamily="34" charset="0"/>
-              <a:buChar char="•"/>
-            </a:pPr>
-            <a:r>
-              <a:rPr lang="en-US" dirty="0"/>
-              <a:t>Loss to follow-up was associated with lower baseline physical QOL scores within both hard drug users and non-</a:t>
-            </a:r>
-            <a:r>
-              <a:rPr lang="en-US" dirty="0" err="1"/>
-              <a:t>busers</a:t>
-            </a:r>
-            <a:r>
-              <a:rPr lang="en-US" dirty="0"/>
-              <a:t> but not associated with baseline laboratory measures</a:t>
-            </a:r>
+            <a:r>
+              <a:rPr lang="en-US" sz="1200" kern="1200" dirty="0">
+                <a:solidFill>
+                  <a:schemeClr val="tx1"/>
+                </a:solidFill>
+                <a:effectLst/>
+                <a:latin typeface="+mn-lt"/>
+                <a:ea typeface="+mn-ea"/>
+                <a:cs typeface="+mn-cs"/>
+              </a:rPr>
+              <a:t>On average, hard drug users had approximately 164 fewer CD4 cells compared with non-users with a </a:t>
+            </a:r>
+            <a:br>
+              <a:rPr lang="en-US" sz="1200" kern="1200" dirty="0">
+                <a:solidFill>
+                  <a:schemeClr val="tx1"/>
+                </a:solidFill>
+                <a:effectLst/>
+                <a:latin typeface="+mn-lt"/>
+                <a:ea typeface="+mn-ea"/>
+                <a:cs typeface="+mn-cs"/>
+              </a:rPr>
+            </a:br>
+            <a:r>
+              <a:rPr lang="en-US" sz="1200" kern="1200" dirty="0">
+                <a:solidFill>
+                  <a:schemeClr val="tx1"/>
+                </a:solidFill>
+                <a:effectLst/>
+                <a:latin typeface="+mn-lt"/>
+                <a:ea typeface="+mn-ea"/>
+                <a:cs typeface="+mn-cs"/>
+              </a:rPr>
+              <a:t>posterior probability of 99.5% that this difference exceeded the clinically meaningful threshold of 50 cells</a:t>
+            </a:r>
+          </a:p>
+          <a:p>
+            <a:br>
+              <a:rPr lang="en-US" sz="1200" kern="1200" dirty="0">
+                <a:solidFill>
+                  <a:schemeClr val="tx1"/>
+                </a:solidFill>
+                <a:effectLst/>
+                <a:latin typeface="+mn-lt"/>
+                <a:ea typeface="+mn-ea"/>
+                <a:cs typeface="+mn-cs"/>
+              </a:rPr>
+            </a:br>
+            <a:r>
+              <a:rPr lang="en-US" sz="1200" kern="1200" dirty="0">
+                <a:solidFill>
+                  <a:schemeClr val="tx1"/>
+                </a:solidFill>
+                <a:effectLst/>
+                <a:latin typeface="+mn-lt"/>
+                <a:ea typeface="+mn-ea"/>
+                <a:cs typeface="+mn-cs"/>
+              </a:rPr>
+              <a:t>In contrast, we found no significant difference in viral or mental QOL scores between groups.</a:t>
+            </a:r>
+          </a:p>
+          <a:p>
+            <a:br>
+              <a:rPr lang="en-US" sz="1200" kern="1200" dirty="0">
+                <a:solidFill>
+                  <a:schemeClr val="tx1"/>
+                </a:solidFill>
+                <a:effectLst/>
+                <a:latin typeface="+mn-lt"/>
+                <a:ea typeface="+mn-ea"/>
+                <a:cs typeface="+mn-cs"/>
+              </a:rPr>
+            </a:br>
+            <a:r>
+              <a:rPr lang="en-US" sz="1200" kern="1200" dirty="0">
+                <a:solidFill>
+                  <a:schemeClr val="tx1"/>
+                </a:solidFill>
+                <a:effectLst/>
+                <a:latin typeface="+mn-lt"/>
+                <a:ea typeface="+mn-ea"/>
+                <a:cs typeface="+mn-cs"/>
+              </a:rPr>
+              <a:t>Physical quality of life was also lower among hard drug users by approximately 3.3 points, and had a posterior probability of 83% that the difference exceeded the clinical threshold of 2 points</a:t>
+            </a:r>
+          </a:p>
+          <a:p>
+            <a:br>
+              <a:rPr lang="en-US" sz="1200" kern="1200" dirty="0">
+                <a:solidFill>
+                  <a:schemeClr val="tx1"/>
+                </a:solidFill>
+                <a:effectLst/>
+                <a:latin typeface="+mn-lt"/>
+                <a:ea typeface="+mn-ea"/>
+                <a:cs typeface="+mn-cs"/>
+              </a:rPr>
+            </a:br>
+            <a:endParaRPr lang="en-US" sz="1200" kern="1200" dirty="0">
+              <a:solidFill>
+                <a:schemeClr val="tx1"/>
+              </a:solidFill>
+              <a:effectLst/>
+              <a:latin typeface="+mn-lt"/>
+              <a:ea typeface="+mn-ea"/>
+              <a:cs typeface="+mn-cs"/>
+            </a:endParaRPr>
+          </a:p>
+          <a:p>
+            <a:endParaRPr lang="en-US" sz="1200" kern="1200" dirty="0">
+              <a:solidFill>
+                <a:schemeClr val="tx1"/>
+              </a:solidFill>
+              <a:effectLst/>
+              <a:latin typeface="+mn-lt"/>
+              <a:ea typeface="+mn-ea"/>
+              <a:cs typeface="+mn-cs"/>
+            </a:endParaRPr>
           </a:p>
         </p:txBody>
       </p:sp>
@@ -1298,6 +1699,215 @@
     </p:spTree>
     <p:extLst>
       <p:ext uri="{BB962C8B-B14F-4D97-AF65-F5344CB8AC3E}">
+        <p14:creationId xmlns:p14="http://schemas.microsoft.com/office/powerpoint/2010/main" val="826435084"/>
+      </p:ext>
+    </p:extLst>
+  </p:cSld>
+  <p:clrMapOvr>
+    <a:masterClrMapping/>
+  </p:clrMapOvr>
+</p:notes>
+</file>
+
+<file path=ppt/notesSlides/notesSlide7.xml><?xml version="1.0" encoding="utf-8"?>
+<p:notes xmlns:a="http://schemas.openxmlformats.org/drawingml/2006/main" xmlns:r="http://schemas.openxmlformats.org/officeDocument/2006/relationships" xmlns:p="http://schemas.openxmlformats.org/presentationml/2006/main">
+  <p:cSld>
+    <p:spTree>
+      <p:nvGrpSpPr>
+        <p:cNvPr id="1" name=""/>
+        <p:cNvGrpSpPr/>
+        <p:nvPr/>
+      </p:nvGrpSpPr>
+      <p:grpSpPr>
+        <a:xfrm>
+          <a:off x="0" y="0"/>
+          <a:ext cx="0" cy="0"/>
+          <a:chOff x="0" y="0"/>
+          <a:chExt cx="0" cy="0"/>
+        </a:xfrm>
+      </p:grpSpPr>
+      <p:sp>
+        <p:nvSpPr>
+          <p:cNvPr id="2" name="Slide Image Placeholder 1"/>
+          <p:cNvSpPr>
+            <a:spLocks noGrp="1" noRot="1" noChangeAspect="1"/>
+          </p:cNvSpPr>
+          <p:nvPr>
+            <p:ph type="sldImg"/>
+          </p:nvPr>
+        </p:nvSpPr>
+        <p:spPr/>
+      </p:sp>
+      <p:sp>
+        <p:nvSpPr>
+          <p:cNvPr id="3" name="Notes Placeholder 2"/>
+          <p:cNvSpPr>
+            <a:spLocks noGrp="1"/>
+          </p:cNvSpPr>
+          <p:nvPr>
+            <p:ph type="body" idx="1"/>
+          </p:nvPr>
+        </p:nvSpPr>
+        <p:spPr/>
+        <p:txBody>
+          <a:bodyPr/>
+          <a:lstStyle/>
+          <a:p>
+            <a:r>
+              <a:rPr lang="en-US" sz="1200" kern="1200" dirty="0">
+                <a:solidFill>
+                  <a:schemeClr val="tx1"/>
+                </a:solidFill>
+                <a:effectLst/>
+                <a:latin typeface="+mn-lt"/>
+                <a:ea typeface="+mn-ea"/>
+                <a:cs typeface="+mn-cs"/>
+              </a:rPr>
+              <a:t>To evaluate adherence, two models were fit – one with and without the binary adherence variable</a:t>
+            </a:r>
+          </a:p>
+          <a:p>
+            <a:endParaRPr lang="en-US" sz="1200" kern="1200" dirty="0">
+              <a:solidFill>
+                <a:schemeClr val="tx1"/>
+              </a:solidFill>
+              <a:effectLst/>
+              <a:latin typeface="+mn-lt"/>
+              <a:ea typeface="+mn-ea"/>
+              <a:cs typeface="+mn-cs"/>
+            </a:endParaRPr>
+          </a:p>
+          <a:p>
+            <a:r>
+              <a:rPr lang="en-US" sz="1200" kern="1200" dirty="0">
+                <a:solidFill>
+                  <a:schemeClr val="tx1"/>
+                </a:solidFill>
+                <a:effectLst/>
+                <a:latin typeface="+mn-lt"/>
+                <a:ea typeface="+mn-ea"/>
+                <a:cs typeface="+mn-cs"/>
+              </a:rPr>
+              <a:t>When adherence was included in the models, the hard drug coefficient slightly increased in magnitude across all outcomes</a:t>
+            </a:r>
+          </a:p>
+          <a:p>
+            <a:endParaRPr lang="en-US" sz="1200" kern="1200" dirty="0">
+              <a:solidFill>
+                <a:schemeClr val="tx1"/>
+              </a:solidFill>
+              <a:effectLst/>
+              <a:latin typeface="+mn-lt"/>
+              <a:ea typeface="+mn-ea"/>
+              <a:cs typeface="+mn-cs"/>
+            </a:endParaRPr>
+          </a:p>
+          <a:p>
+            <a:r>
+              <a:rPr lang="en-US" sz="1200" kern="1200" dirty="0">
+                <a:solidFill>
+                  <a:schemeClr val="tx1"/>
+                </a:solidFill>
+                <a:effectLst/>
+                <a:latin typeface="+mn-lt"/>
+                <a:ea typeface="+mn-ea"/>
+                <a:cs typeface="+mn-cs"/>
+              </a:rPr>
+              <a:t>Which resulted in negative proportion mediated estimates and ultimately inconsistent mediation.  This was likely due to sparse data in the adherence category.</a:t>
+            </a:r>
+          </a:p>
+          <a:p>
+            <a:pPr marL="171450" indent="-171450">
+              <a:buFont typeface="Arial" panose="020B0604020202020204" pitchFamily="34" charset="0"/>
+              <a:buChar char="•"/>
+            </a:pPr>
+            <a:r>
+              <a:rPr lang="en-US" sz="1200" kern="1200" dirty="0">
+                <a:solidFill>
+                  <a:schemeClr val="tx1"/>
+                </a:solidFill>
+                <a:effectLst/>
+                <a:latin typeface="+mn-lt"/>
+                <a:ea typeface="+mn-ea"/>
+                <a:cs typeface="+mn-cs"/>
+              </a:rPr>
+              <a:t>Only </a:t>
+            </a:r>
+            <a:r>
+              <a:rPr lang="en-US" sz="1200" kern="1200">
+                <a:solidFill>
+                  <a:schemeClr val="tx1"/>
+                </a:solidFill>
+                <a:effectLst/>
+                <a:latin typeface="+mn-lt"/>
+                <a:ea typeface="+mn-ea"/>
+                <a:cs typeface="+mn-cs"/>
+              </a:rPr>
+              <a:t>one subject was in the less than 95% grouping</a:t>
+            </a:r>
+            <a:endParaRPr lang="en-US" sz="1200" kern="1200" dirty="0">
+              <a:solidFill>
+                <a:schemeClr val="tx1"/>
+              </a:solidFill>
+              <a:effectLst/>
+              <a:latin typeface="+mn-lt"/>
+              <a:ea typeface="+mn-ea"/>
+              <a:cs typeface="+mn-cs"/>
+            </a:endParaRPr>
+          </a:p>
+          <a:p>
+            <a:endParaRPr lang="en-US" sz="1200" kern="1200" dirty="0">
+              <a:solidFill>
+                <a:schemeClr val="tx1"/>
+              </a:solidFill>
+              <a:effectLst/>
+              <a:latin typeface="+mn-lt"/>
+              <a:ea typeface="+mn-ea"/>
+              <a:cs typeface="+mn-cs"/>
+            </a:endParaRPr>
+          </a:p>
+          <a:p>
+            <a:r>
+              <a:rPr lang="en-US" sz="1200" kern="1200" dirty="0">
+                <a:solidFill>
+                  <a:schemeClr val="tx1"/>
+                </a:solidFill>
+                <a:effectLst/>
+                <a:latin typeface="+mn-lt"/>
+                <a:ea typeface="+mn-ea"/>
+                <a:cs typeface="+mn-cs"/>
+              </a:rPr>
+              <a:t>Overall, there was little evidence that adherence explained the association.</a:t>
+            </a:r>
+          </a:p>
+        </p:txBody>
+      </p:sp>
+      <p:sp>
+        <p:nvSpPr>
+          <p:cNvPr id="4" name="Slide Number Placeholder 3"/>
+          <p:cNvSpPr>
+            <a:spLocks noGrp="1"/>
+          </p:cNvSpPr>
+          <p:nvPr>
+            <p:ph type="sldNum" sz="quarter" idx="5"/>
+          </p:nvPr>
+        </p:nvSpPr>
+        <p:spPr/>
+        <p:txBody>
+          <a:bodyPr/>
+          <a:lstStyle/>
+          <a:p>
+            <a:fld id="{8055A014-AA40-5B4A-A5FD-4F58A1D7AE4A}" type="slidenum">
+              <a:rPr lang="en-US" smtClean="0"/>
+              <a:t>7</a:t>
+            </a:fld>
+            <a:endParaRPr lang="en-US"/>
+          </a:p>
+        </p:txBody>
+      </p:sp>
+    </p:spTree>
+    <p:extLst>
+      <p:ext uri="{BB962C8B-B14F-4D97-AF65-F5344CB8AC3E}">
         <p14:creationId xmlns:p14="http://schemas.microsoft.com/office/powerpoint/2010/main" val="3152127465"/>
       </p:ext>
     </p:extLst>
@@ -1308,7 +1918,7 @@
 </p:notes>
 </file>
 
-<file path=ppt/notesSlides/notesSlide7.xml><?xml version="1.0" encoding="utf-8"?>
+<file path=ppt/notesSlides/notesSlide8.xml><?xml version="1.0" encoding="utf-8"?>
 <p:notes xmlns:a="http://schemas.openxmlformats.org/drawingml/2006/main" xmlns:r="http://schemas.openxmlformats.org/officeDocument/2006/relationships" xmlns:p="http://schemas.openxmlformats.org/presentationml/2006/main">
   <p:cSld>
     <p:spTree>
@@ -1370,9 +1980,22 @@
           <a:bodyPr/>
           <a:lstStyle/>
           <a:p>
-            <a:pPr marL="0" indent="0">
+            <a:pPr marL="0" marR="0" lvl="0" indent="0" algn="l" defTabSz="914400" rtl="0" eaLnBrk="1" fontAlgn="auto" latinLnBrk="0" hangingPunct="1">
+              <a:lnSpc>
+                <a:spcPct val="100000"/>
+              </a:lnSpc>
+              <a:spcBef>
+                <a:spcPts val="0"/>
+              </a:spcBef>
+              <a:spcAft>
+                <a:spcPts val="0"/>
+              </a:spcAft>
+              <a:buClrTx/>
+              <a:buSzTx/>
               <a:buFont typeface="Arial" panose="020B0604020202020204" pitchFamily="34" charset="0"/>
               <a:buNone/>
+              <a:tabLst/>
+              <a:defRPr/>
             </a:pPr>
             <a:r>
               <a:rPr lang="en-US" sz="1200" kern="1200" dirty="0">
@@ -1384,32 +2007,145 @@
                 <a:ea typeface="+mn-ea"/>
                 <a:cs typeface="+mn-cs"/>
               </a:rPr>
-              <a:t>Baseline lab and quality-of-life measures between participants by whether they had complete measurements or not, and stratified by baseline hard drug use</a:t>
-            </a:r>
-            <a:r>
-              <a:rPr lang="en-US" dirty="0">
+              <a:t>Of the 715 participants, 252 were missing Year 2 data or 35%.</a:t>
+            </a:r>
+          </a:p>
+          <a:p>
+            <a:pPr marL="0" marR="0" lvl="0" indent="0" algn="l" defTabSz="914400" rtl="0" eaLnBrk="1" fontAlgn="auto" latinLnBrk="0" hangingPunct="1">
+              <a:lnSpc>
+                <a:spcPct val="100000"/>
+              </a:lnSpc>
+              <a:spcBef>
+                <a:spcPts val="0"/>
+              </a:spcBef>
+              <a:spcAft>
+                <a:spcPts val="0"/>
+              </a:spcAft>
+              <a:buClrTx/>
+              <a:buSzTx/>
+              <a:buFont typeface="Arial" panose="020B0604020202020204" pitchFamily="34" charset="0"/>
+              <a:buNone/>
+              <a:tabLst/>
+              <a:defRPr/>
+            </a:pPr>
+            <a:endParaRPr lang="en-US" sz="1200" kern="1200" dirty="0">
+              <a:solidFill>
+                <a:schemeClr val="tx1"/>
+              </a:solidFill>
+              <a:effectLst/>
+              <a:latin typeface="+mn-lt"/>
+              <a:ea typeface="+mn-ea"/>
+              <a:cs typeface="+mn-cs"/>
+            </a:endParaRPr>
+          </a:p>
+          <a:p>
+            <a:pPr marL="0" marR="0" lvl="0" indent="0" algn="l" defTabSz="914400" rtl="0" eaLnBrk="1" fontAlgn="auto" latinLnBrk="0" hangingPunct="1">
+              <a:lnSpc>
+                <a:spcPct val="100000"/>
+              </a:lnSpc>
+              <a:spcBef>
+                <a:spcPts val="0"/>
+              </a:spcBef>
+              <a:spcAft>
+                <a:spcPts val="0"/>
+              </a:spcAft>
+              <a:buClrTx/>
+              <a:buSzTx/>
+              <a:buFont typeface="Arial" panose="020B0604020202020204" pitchFamily="34" charset="0"/>
+              <a:buNone/>
+              <a:tabLst/>
+              <a:defRPr/>
+            </a:pPr>
+            <a:r>
+              <a:rPr lang="en-US" sz="1200" kern="1200" dirty="0">
+                <a:solidFill>
+                  <a:schemeClr val="tx1"/>
+                </a:solidFill>
                 <a:effectLst/>
-              </a:rPr>
-              <a:t> </a:t>
-            </a:r>
-            <a:endParaRPr lang="en-US" dirty="0"/>
+                <a:latin typeface="+mn-lt"/>
+                <a:ea typeface="+mn-ea"/>
+                <a:cs typeface="+mn-cs"/>
+              </a:rPr>
+              <a:t>Baseline physical QOL scores were shown to be significantly lower among participants lost to follow-up for both hard drug users and non-users. It was particularly  noticeable in the drug users' group that was 5x lower than the clinically meaningful difference of 2 points</a:t>
+            </a:r>
+          </a:p>
+          <a:p>
+            <a:pPr marL="0" marR="0" lvl="0" indent="0" algn="l" defTabSz="914400" rtl="0" eaLnBrk="1" fontAlgn="auto" latinLnBrk="0" hangingPunct="1">
+              <a:lnSpc>
+                <a:spcPct val="100000"/>
+              </a:lnSpc>
+              <a:spcBef>
+                <a:spcPts val="0"/>
+              </a:spcBef>
+              <a:spcAft>
+                <a:spcPts val="0"/>
+              </a:spcAft>
+              <a:buClrTx/>
+              <a:buSzTx/>
+              <a:buFont typeface="Arial" panose="020B0604020202020204" pitchFamily="34" charset="0"/>
+              <a:buNone/>
+              <a:tabLst/>
+              <a:defRPr/>
+            </a:pPr>
+            <a:endParaRPr lang="en-US" sz="1200" kern="1200" dirty="0">
+              <a:solidFill>
+                <a:schemeClr val="tx1"/>
+              </a:solidFill>
+              <a:effectLst/>
+              <a:latin typeface="+mn-lt"/>
+              <a:ea typeface="+mn-ea"/>
+              <a:cs typeface="+mn-cs"/>
+            </a:endParaRPr>
+          </a:p>
+          <a:p>
+            <a:pPr marL="0" marR="0" lvl="0" indent="0" algn="l" defTabSz="914400" rtl="0" eaLnBrk="1" fontAlgn="auto" latinLnBrk="0" hangingPunct="1">
+              <a:lnSpc>
+                <a:spcPct val="100000"/>
+              </a:lnSpc>
+              <a:spcBef>
+                <a:spcPts val="0"/>
+              </a:spcBef>
+              <a:spcAft>
+                <a:spcPts val="0"/>
+              </a:spcAft>
+              <a:buClrTx/>
+              <a:buSzTx/>
+              <a:buFont typeface="Arial" panose="020B0604020202020204" pitchFamily="34" charset="0"/>
+              <a:buNone/>
+              <a:tabLst/>
+              <a:defRPr/>
+            </a:pPr>
+            <a:r>
+              <a:rPr lang="en-US" sz="1200" kern="1200" dirty="0">
+                <a:solidFill>
+                  <a:schemeClr val="tx1"/>
+                </a:solidFill>
+                <a:effectLst/>
+                <a:latin typeface="+mn-lt"/>
+                <a:ea typeface="+mn-ea"/>
+                <a:cs typeface="+mn-cs"/>
+              </a:rPr>
+              <a:t>Logistic regression modelling confirmed that lower baseline physical QOL scores and younger age were associated with lower odds of dropout.</a:t>
+            </a:r>
           </a:p>
           <a:p>
             <a:pPr marL="171450" indent="-171450">
               <a:buFont typeface="Arial" panose="020B0604020202020204" pitchFamily="34" charset="0"/>
               <a:buChar char="•"/>
             </a:pPr>
-            <a:endParaRPr lang="en-US" dirty="0"/>
-          </a:p>
-          <a:p>
-            <a:pPr marL="171450" indent="-171450">
-              <a:buFont typeface="Arial" panose="020B0604020202020204" pitchFamily="34" charset="0"/>
-              <a:buChar char="•"/>
-            </a:pPr>
-            <a:r>
-              <a:rPr lang="en-US" dirty="0"/>
-              <a:t>Loss to follow-up appeared to be most associated with lower baseline physical QOL scores within both hard drug users and non-users but not so with baseline laboratory measures</a:t>
-            </a:r>
+            <a:r>
+              <a:rPr lang="en-US" sz="1200" i="0" kern="1200" dirty="0">
+                <a:solidFill>
+                  <a:schemeClr val="tx1"/>
+                </a:solidFill>
+                <a:effectLst/>
+                <a:latin typeface="+mn-lt"/>
+                <a:ea typeface="+mn-ea"/>
+                <a:cs typeface="+mn-cs"/>
+              </a:rPr>
+              <a:t>For each additional year there was an approximate 3.4% reduction in the odds and for each one-point increase in baseline physical QOL there was 4.4% reduction in the odds of dropout. </a:t>
+            </a:r>
+            <a:endParaRPr lang="en-US" i="0" dirty="0"/>
           </a:p>
           <a:p>
             <a:pPr marL="171450" indent="-171450">
@@ -1463,7 +2199,7 @@
           <a:p>
             <a:fld id="{8055A014-AA40-5B4A-A5FD-4F58A1D7AE4A}" type="slidenum">
               <a:rPr lang="en-US" smtClean="0"/>
-              <a:t>7</a:t>
+              <a:t>8</a:t>
             </a:fld>
             <a:endParaRPr lang="en-US"/>
           </a:p>
@@ -1482,7 +2218,7 @@
 </p:notes>
 </file>
 
-<file path=ppt/notesSlides/notesSlide8.xml><?xml version="1.0" encoding="utf-8"?>
+<file path=ppt/notesSlides/notesSlide9.xml><?xml version="1.0" encoding="utf-8"?>
 <p:notes xmlns:a="http://schemas.openxmlformats.org/drawingml/2006/main" xmlns:r="http://schemas.openxmlformats.org/officeDocument/2006/relationships" xmlns:p="http://schemas.openxmlformats.org/presentationml/2006/main">
   <p:cSld>
     <p:spTree>
@@ -1526,45 +2262,6 @@
           <a:bodyPr/>
           <a:lstStyle/>
           <a:p>
-            <a:r>
-              <a:rPr lang="en-US" sz="1200" kern="1200" dirty="0">
-                <a:solidFill>
-                  <a:schemeClr val="tx1"/>
-                </a:solidFill>
-                <a:effectLst/>
-                <a:latin typeface="+mn-lt"/>
-                <a:ea typeface="+mn-ea"/>
-                <a:cs typeface="+mn-cs"/>
-              </a:rPr>
-              <a:t>In summary,</a:t>
-            </a:r>
-          </a:p>
-          <a:p>
-            <a:endParaRPr lang="en-US" sz="1200" kern="1200" dirty="0">
-              <a:solidFill>
-                <a:schemeClr val="tx1"/>
-              </a:solidFill>
-              <a:effectLst/>
-              <a:latin typeface="+mn-lt"/>
-              <a:ea typeface="+mn-ea"/>
-              <a:cs typeface="+mn-cs"/>
-            </a:endParaRPr>
-          </a:p>
-          <a:p>
-            <a:r>
-              <a:rPr lang="en-US" sz="1200" kern="1200" dirty="0">
-                <a:solidFill>
-                  <a:schemeClr val="tx1"/>
-                </a:solidFill>
-                <a:effectLst/>
-                <a:latin typeface="+mn-lt"/>
-                <a:ea typeface="+mn-ea"/>
-                <a:cs typeface="+mn-cs"/>
-              </a:rPr>
-              <a:t>At year 2:</a:t>
-            </a:r>
-          </a:p>
-          <a:p>
             <a:pPr marL="0" marR="0" lvl="0" indent="0" algn="l" defTabSz="914400" rtl="0" eaLnBrk="1" fontAlgn="auto" latinLnBrk="0" hangingPunct="1">
               <a:lnSpc>
                 <a:spcPct val="100000"/>
@@ -1592,7 +2289,7 @@
                 <a:ea typeface="+mn-ea"/>
                 <a:cs typeface="+mn-cs"/>
               </a:rPr>
-              <a:t>Overall, these findings suggest that baseline hard drug use is associated with poorer immunologic recovery and lower physical quality of life following HAART initiation, but adherence does not appear to meaningfully mediate these associations.</a:t>
+              <a:t>Overall, these findings suggest that baseline hard drug use is associated with poorer immunologic recovery and lower physical QOL following HAART initiation, but adherence does not appear to meaningfully mediate these associations. Loss to follow-up indicated the age and physical health was associated with dropout</a:t>
             </a:r>
           </a:p>
           <a:p>
@@ -1607,24 +2304,9 @@
             </a:endParaRPr>
           </a:p>
           <a:p>
-            <a:endParaRPr lang="en-US" dirty="0"/>
-          </a:p>
-          <a:p>
             <a:r>
               <a:rPr lang="en-US" dirty="0"/>
               <a:t>Limitations:</a:t>
-            </a:r>
-          </a:p>
-          <a:p>
-            <a:r>
-              <a:rPr lang="en-US" dirty="0"/>
-              <a:t>Study can suffer bias from lack of randomization and unmeasured variables</a:t>
-            </a:r>
-          </a:p>
-          <a:p>
-            <a:r>
-              <a:rPr lang="en-US" dirty="0"/>
-              <a:t>Adherence was coded as binary – which may be too simplistic for classification. </a:t>
             </a:r>
           </a:p>
           <a:p>
@@ -1634,7 +2316,7 @@
             </a:pPr>
             <a:r>
               <a:rPr lang="en-US" dirty="0"/>
-              <a:t>Because of this classification and the negative proportion mediated, Adherence overall should be interpretated as more descriptive rather than a formal mediation approach</a:t>
+              <a:t>Observational studies typically suffer bias from lack of randomization and unmeasured variables</a:t>
             </a:r>
           </a:p>
           <a:p>
@@ -1644,16 +2326,24 @@
             </a:pPr>
             <a:r>
               <a:rPr lang="en-US" dirty="0"/>
-              <a:t>It also has strong confounding assumptions which can never be fully verified with observation studies </a:t>
-            </a:r>
-          </a:p>
-          <a:p>
+              <a:t>Adherence was coded as binary and only had one observation for hard drug user with less than 95% this was likely a reason for the negative proportion mediated, so Adherence could not be reliably estimated.</a:t>
+            </a:r>
+          </a:p>
+          <a:p>
+            <a:pPr marL="171450" indent="-171450">
+              <a:buFont typeface="Arial" panose="020B0604020202020204" pitchFamily="34" charset="0"/>
+              <a:buChar char="•"/>
+            </a:pPr>
             <a:r>
               <a:rPr lang="en-US" dirty="0"/>
               <a:t>Hard drug user group was relatively small so we may not have had enough to power to make precise comparisons</a:t>
             </a:r>
           </a:p>
           <a:p>
+            <a:pPr marL="171450" indent="-171450">
+              <a:buFont typeface="Arial" panose="020B0604020202020204" pitchFamily="34" charset="0"/>
+              <a:buChar char="•"/>
+            </a:pPr>
             <a:r>
               <a:rPr lang="en-US" dirty="0"/>
               <a:t>SF-36 scores are limited in interpretation because it typically requires comparisons matched on </a:t>
@@ -1668,6 +2358,10 @@
             </a:r>
           </a:p>
           <a:p>
+            <a:pPr marL="171450" indent="-171450">
+              <a:buFont typeface="Arial" panose="020B0604020202020204" pitchFamily="34" charset="0"/>
+              <a:buChar char="•"/>
+            </a:pPr>
             <a:r>
               <a:rPr lang="en-US" dirty="0"/>
               <a:t>Lastly, missingness appeared to be associated with age and physical health, which were observed, but it may depend on some unmeasured factor that we did not model. So it suggests MAR but doesn’t prove it</a:t>
@@ -1692,7 +2386,7 @@
           <a:p>
             <a:fld id="{8055A014-AA40-5B4A-A5FD-4F58A1D7AE4A}" type="slidenum">
               <a:rPr lang="en-US" smtClean="0"/>
-              <a:t>8</a:t>
+              <a:t>9</a:t>
             </a:fld>
             <a:endParaRPr lang="en-US"/>
           </a:p>
@@ -2448,7 +3142,7 @@
         </p:nvSpPr>
         <p:spPr>
           <a:xfrm>
-            <a:off x="-17029" y="16706"/>
+            <a:off x="0" y="-9309"/>
             <a:ext cx="12192000" cy="6858000"/>
           </a:xfrm>
           <a:prstGeom prst="rect">
@@ -2799,7 +3493,7 @@
             </a:r>
             <a:r>
               <a:rPr lang="en-US" sz="2000" dirty="0"/>
-              <a:t>: Baseline characteristics differ between participants with complete and incomplete cases</a:t>
+              <a:t>: Baseline outcomes differ between participants with complete and incomplete cases</a:t>
             </a:r>
             <a:endParaRPr lang="en-US" dirty="0">
               <a:solidFill>
@@ -2826,6 +3520,360 @@
 </file>
 
 <file path=ppt/slides/slide3.xml><?xml version="1.0" encoding="utf-8"?>
+<p:sld xmlns:a="http://schemas.openxmlformats.org/drawingml/2006/main" xmlns:r="http://schemas.openxmlformats.org/officeDocument/2006/relationships" xmlns:p="http://schemas.openxmlformats.org/presentationml/2006/main">
+  <p:cSld>
+    <p:spTree>
+      <p:nvGrpSpPr>
+        <p:cNvPr id="1" name="">
+          <a:extLst>
+            <a:ext uri="{FF2B5EF4-FFF2-40B4-BE49-F238E27FC236}">
+              <a16:creationId xmlns:a16="http://schemas.microsoft.com/office/drawing/2014/main" id="{ADE9220A-E907-696F-E178-950E13497494}"/>
+            </a:ext>
+          </a:extLst>
+        </p:cNvPr>
+        <p:cNvGrpSpPr/>
+        <p:nvPr/>
+      </p:nvGrpSpPr>
+      <p:grpSpPr>
+        <a:xfrm>
+          <a:off x="0" y="0"/>
+          <a:ext cx="0" cy="0"/>
+          <a:chOff x="0" y="0"/>
+          <a:chExt cx="0" cy="0"/>
+        </a:xfrm>
+      </p:grpSpPr>
+      <p:sp>
+        <p:nvSpPr>
+          <p:cNvPr id="2" name="object 1">
+            <a:extLst>
+              <a:ext uri="{FF2B5EF4-FFF2-40B4-BE49-F238E27FC236}">
+                <a16:creationId xmlns:a16="http://schemas.microsoft.com/office/drawing/2014/main" id="{1DE5CAE3-8C9D-5530-AE7E-1A8DEBA08D3C}"/>
+              </a:ext>
+            </a:extLst>
+          </p:cNvPr>
+          <p:cNvSpPr/>
+          <p:nvPr/>
+        </p:nvSpPr>
+        <p:spPr>
+          <a:xfrm>
+            <a:off x="-17029" y="16706"/>
+            <a:ext cx="12192000" cy="6858000"/>
+          </a:xfrm>
+          <a:prstGeom prst="rect">
+            <a:avLst/>
+          </a:prstGeom>
+          <a:blipFill>
+            <a:blip r:embed="rId3" cstate="print"/>
+            <a:stretch>
+              <a:fillRect/>
+            </a:stretch>
+          </a:blipFill>
+        </p:spPr>
+        <p:txBody>
+          <a:bodyPr wrap="square" lIns="0" tIns="0" rIns="0" bIns="0" rtlCol="0">
+            <a:spAutoFit/>
+          </a:bodyPr>
+          <a:lstStyle/>
+          <a:p>
+            <a:endParaRPr dirty="0"/>
+          </a:p>
+        </p:txBody>
+      </p:sp>
+      <p:sp>
+        <p:nvSpPr>
+          <p:cNvPr id="3" name="object 3">
+            <a:extLst>
+              <a:ext uri="{FF2B5EF4-FFF2-40B4-BE49-F238E27FC236}">
+                <a16:creationId xmlns:a16="http://schemas.microsoft.com/office/drawing/2014/main" id="{DD84BD69-C59D-462F-793D-BE03654A65BC}"/>
+              </a:ext>
+            </a:extLst>
+          </p:cNvPr>
+          <p:cNvSpPr txBox="1"/>
+          <p:nvPr/>
+        </p:nvSpPr>
+        <p:spPr>
+          <a:xfrm>
+            <a:off x="1199456" y="181814"/>
+            <a:ext cx="5065008" cy="641201"/>
+          </a:xfrm>
+          <a:prstGeom prst="rect">
+            <a:avLst/>
+          </a:prstGeom>
+        </p:spPr>
+        <p:txBody>
+          <a:bodyPr vert="horz" wrap="square" lIns="0" tIns="0" rIns="0" bIns="0" rtlCol="0">
+            <a:spAutoFit/>
+          </a:bodyPr>
+          <a:lstStyle/>
+          <a:p>
+            <a:pPr marL="0" marR="0">
+              <a:lnSpc>
+                <a:spcPts val="4979"/>
+              </a:lnSpc>
+              <a:spcBef>
+                <a:spcPts val="0"/>
+              </a:spcBef>
+              <a:spcAft>
+                <a:spcPts val="0"/>
+              </a:spcAft>
+            </a:pPr>
+            <a:r>
+              <a:rPr sz="4400" spc="-21" dirty="0">
+                <a:solidFill>
+                  <a:srgbClr val="181A0D"/>
+                </a:solidFill>
+                <a:cs typeface="KDMFEK+FranklinGothic-Book"/>
+              </a:rPr>
+              <a:t>Research</a:t>
+            </a:r>
+            <a:r>
+              <a:rPr sz="4400" spc="21" dirty="0">
+                <a:solidFill>
+                  <a:srgbClr val="181A0D"/>
+                </a:solidFill>
+                <a:cs typeface="KDMFEK+FranklinGothic-Book"/>
+              </a:rPr>
+              <a:t> </a:t>
+            </a:r>
+            <a:r>
+              <a:rPr sz="4400" dirty="0">
+                <a:solidFill>
+                  <a:srgbClr val="181A0D"/>
+                </a:solidFill>
+                <a:cs typeface="KDMFEK+FranklinGothic-Book"/>
+              </a:rPr>
+              <a:t>Question</a:t>
+            </a:r>
+            <a:r>
+              <a:rPr lang="en-US" sz="4400" dirty="0">
+                <a:solidFill>
+                  <a:srgbClr val="181A0D"/>
+                </a:solidFill>
+                <a:cs typeface="KDMFEK+FranklinGothic-Book"/>
+              </a:rPr>
+              <a:t>s</a:t>
+            </a:r>
+            <a:endParaRPr sz="4400" dirty="0">
+              <a:solidFill>
+                <a:srgbClr val="181A0D"/>
+              </a:solidFill>
+              <a:cs typeface="KDMFEK+FranklinGothic-Book"/>
+            </a:endParaRPr>
+          </a:p>
+        </p:txBody>
+      </p:sp>
+      <p:sp>
+        <p:nvSpPr>
+          <p:cNvPr id="6" name="TextBox 5">
+            <a:extLst>
+              <a:ext uri="{FF2B5EF4-FFF2-40B4-BE49-F238E27FC236}">
+                <a16:creationId xmlns:a16="http://schemas.microsoft.com/office/drawing/2014/main" id="{47E80CB9-394E-7C5A-F83C-EFCE2F949673}"/>
+              </a:ext>
+            </a:extLst>
+          </p:cNvPr>
+          <p:cNvSpPr txBox="1"/>
+          <p:nvPr/>
+        </p:nvSpPr>
+        <p:spPr>
+          <a:xfrm>
+            <a:off x="1055440" y="1122180"/>
+            <a:ext cx="10801200" cy="5539978"/>
+          </a:xfrm>
+          <a:prstGeom prst="rect">
+            <a:avLst/>
+          </a:prstGeom>
+          <a:noFill/>
+        </p:spPr>
+        <p:txBody>
+          <a:bodyPr wrap="square">
+            <a:spAutoFit/>
+          </a:bodyPr>
+          <a:lstStyle/>
+          <a:p>
+            <a:pPr marL="342900" indent="-342900">
+              <a:buFont typeface="Wingdings" pitchFamily="2" charset="2"/>
+              <a:buChar char="q"/>
+            </a:pPr>
+            <a:r>
+              <a:rPr lang="en-US" sz="2000" b="1" dirty="0"/>
+              <a:t>Does baseline hard drug use affect treatment response two years after initiating HAART?</a:t>
+            </a:r>
+            <a:endParaRPr lang="en-US" sz="2000" b="1" dirty="0">
+              <a:solidFill>
+                <a:srgbClr val="181A0D"/>
+              </a:solidFill>
+            </a:endParaRPr>
+          </a:p>
+          <a:p>
+            <a:pPr marL="742950" lvl="1" indent="-285750">
+              <a:buFont typeface="Wingdings" pitchFamily="2" charset="2"/>
+              <a:buChar char="Ø"/>
+            </a:pPr>
+            <a:r>
+              <a:rPr lang="en-US" sz="2000" dirty="0"/>
+              <a:t>Viral load (HIV RNA copies/mL)</a:t>
+            </a:r>
+          </a:p>
+          <a:p>
+            <a:pPr marL="742950" lvl="1" indent="-285750">
+              <a:buFont typeface="Wingdings" pitchFamily="2" charset="2"/>
+              <a:buChar char="Ø"/>
+            </a:pPr>
+            <a:r>
+              <a:rPr lang="en-US" sz="2000" dirty="0"/>
+              <a:t>CD4 T-cell count</a:t>
+            </a:r>
+          </a:p>
+          <a:p>
+            <a:pPr marL="742950" lvl="1" indent="-285750">
+              <a:buFont typeface="Wingdings" pitchFamily="2" charset="2"/>
+              <a:buChar char="Ø"/>
+            </a:pPr>
+            <a:r>
+              <a:rPr lang="en-US" sz="2000" dirty="0"/>
+              <a:t>Physical QOL (0-100)</a:t>
+            </a:r>
+          </a:p>
+          <a:p>
+            <a:pPr marL="742950" lvl="1" indent="-285750">
+              <a:buFont typeface="Wingdings" pitchFamily="2" charset="2"/>
+              <a:buChar char="Ø"/>
+            </a:pPr>
+            <a:r>
+              <a:rPr lang="en-US" sz="2000" dirty="0"/>
+              <a:t>Mental QOL (0-100)</a:t>
+            </a:r>
+          </a:p>
+          <a:p>
+            <a:pPr marL="742950" lvl="1" indent="-285750">
+              <a:buFont typeface="Wingdings" pitchFamily="2" charset="2"/>
+              <a:buChar char="Ø"/>
+            </a:pPr>
+            <a:r>
+              <a:rPr lang="en-US" sz="2000" i="1" dirty="0"/>
+              <a:t>Hypotheses: </a:t>
+            </a:r>
+            <a:r>
+              <a:rPr lang="en-US" sz="2000" dirty="0"/>
+              <a:t>Year-2 outcomes differ between baseline hard drug users and non-users</a:t>
+            </a:r>
+          </a:p>
+          <a:p>
+            <a:pPr lvl="1"/>
+            <a:endParaRPr lang="en-US" dirty="0"/>
+          </a:p>
+          <a:p>
+            <a:pPr lvl="1"/>
+            <a:endParaRPr lang="en-US" dirty="0"/>
+          </a:p>
+          <a:p>
+            <a:pPr marL="285750" indent="-285750">
+              <a:buFont typeface="Wingdings" pitchFamily="2" charset="2"/>
+              <a:buChar char="q"/>
+            </a:pPr>
+            <a:r>
+              <a:rPr lang="en-US" sz="2000" b="1" dirty="0">
+                <a:solidFill>
+                  <a:srgbClr val="181A0D"/>
+                </a:solidFill>
+              </a:rPr>
+              <a:t>Does adherence mediate the association between hard drug use and year-2 outcomes?</a:t>
+            </a:r>
+          </a:p>
+          <a:p>
+            <a:pPr marL="800100" lvl="1" indent="-342900">
+              <a:buFont typeface="Wingdings" pitchFamily="2" charset="2"/>
+              <a:buChar char="Ø"/>
+            </a:pPr>
+            <a:r>
+              <a:rPr lang="en-US" sz="2000" i="1" dirty="0"/>
+              <a:t>Hypothesis</a:t>
+            </a:r>
+            <a:r>
+              <a:rPr lang="en-US" sz="2000" dirty="0"/>
+              <a:t>: The association between hard drug use and treatment response will be weaker after accounting for adherence.</a:t>
+            </a:r>
+          </a:p>
+          <a:p>
+            <a:pPr lvl="0"/>
+            <a:endParaRPr lang="en-US" sz="2000" b="1" dirty="0">
+              <a:solidFill>
+                <a:srgbClr val="181A0D"/>
+              </a:solidFill>
+            </a:endParaRPr>
+          </a:p>
+          <a:p>
+            <a:pPr lvl="0"/>
+            <a:endParaRPr lang="en-US" sz="2000" b="1" dirty="0">
+              <a:solidFill>
+                <a:srgbClr val="181A0D"/>
+              </a:solidFill>
+            </a:endParaRPr>
+          </a:p>
+          <a:p>
+            <a:pPr marL="285750" indent="-285750">
+              <a:buFont typeface="Wingdings" pitchFamily="2" charset="2"/>
+              <a:buChar char="q"/>
+            </a:pPr>
+            <a:r>
+              <a:rPr lang="en-US" sz="2000" b="1" dirty="0"/>
+              <a:t>What are the dropout rates between hard drug users and non-users?</a:t>
+            </a:r>
+          </a:p>
+          <a:p>
+            <a:pPr marL="742950" lvl="1" indent="-285750">
+              <a:buFont typeface="Wingdings" pitchFamily="2" charset="2"/>
+              <a:buChar char="Ø"/>
+            </a:pPr>
+            <a:r>
+              <a:rPr lang="en-US" sz="2000" i="1" dirty="0"/>
+              <a:t>Hypothesis</a:t>
+            </a:r>
+            <a:r>
+              <a:rPr lang="en-US" sz="2000" dirty="0"/>
+              <a:t>: Baseline outcomes differ between participants with complete and incomplete cases</a:t>
+            </a:r>
+            <a:endParaRPr lang="en-US" dirty="0">
+              <a:solidFill>
+                <a:srgbClr val="181A0D"/>
+              </a:solidFill>
+              <a:cs typeface="OAGDQN+FranklinGothic-BookItalic"/>
+            </a:endParaRPr>
+          </a:p>
+          <a:p>
+            <a:pPr marL="285750" lvl="0" indent="-285750">
+              <a:buFont typeface="Wingdings" pitchFamily="2" charset="2"/>
+              <a:buChar char="q"/>
+            </a:pPr>
+            <a:endParaRPr lang="en-US" sz="2000" b="1" dirty="0">
+              <a:solidFill>
+                <a:srgbClr val="181A0D"/>
+              </a:solidFill>
+            </a:endParaRPr>
+          </a:p>
+          <a:p>
+            <a:pPr marL="285750" indent="-285750">
+              <a:buFont typeface="Wingdings" pitchFamily="2" charset="2"/>
+              <a:buChar char="q"/>
+            </a:pPr>
+            <a:endParaRPr lang="en-US" dirty="0"/>
+          </a:p>
+        </p:txBody>
+      </p:sp>
+    </p:spTree>
+    <p:extLst>
+      <p:ext uri="{BB962C8B-B14F-4D97-AF65-F5344CB8AC3E}">
+        <p14:creationId xmlns:p14="http://schemas.microsoft.com/office/powerpoint/2010/main" val="1544130030"/>
+      </p:ext>
+    </p:extLst>
+  </p:cSld>
+  <p:clrMapOvr>
+    <a:masterClrMapping/>
+  </p:clrMapOvr>
+</p:sld>
+</file>
+
+<file path=ppt/slides/slide4.xml><?xml version="1.0" encoding="utf-8"?>
 <p:sld xmlns:a="http://schemas.openxmlformats.org/drawingml/2006/main" xmlns:r="http://schemas.openxmlformats.org/officeDocument/2006/relationships" xmlns:p="http://schemas.openxmlformats.org/presentationml/2006/main" showMasterSp="0">
   <p:cSld>
     <p:spTree>
@@ -2946,8 +3994,8 @@
         </p:nvSpPr>
         <p:spPr>
           <a:xfrm>
-            <a:off x="839416" y="1340768"/>
-            <a:ext cx="3672408" cy="6124754"/>
+            <a:off x="899653" y="905008"/>
+            <a:ext cx="3672408" cy="6955750"/>
           </a:xfrm>
           <a:prstGeom prst="rect">
             <a:avLst/>
@@ -3128,6 +4176,24 @@
           <a:p>
             <a:pPr marL="285750" indent="-285750">
               <a:buFont typeface="Wingdings" pitchFamily="2" charset="2"/>
+              <a:buChar char="q"/>
+            </a:pPr>
+            <a:r>
+              <a:rPr lang="en-US" b="1" dirty="0"/>
+              <a:t>Hard drug use and adherence coded as binary</a:t>
+            </a:r>
+            <a:endParaRPr lang="en-US" dirty="0"/>
+          </a:p>
+          <a:p>
+            <a:pPr marL="742950" lvl="1" indent="-285750">
+              <a:buFont typeface="Wingdings" pitchFamily="2" charset="2"/>
+              <a:buChar char="Ø"/>
+            </a:pPr>
+            <a:endParaRPr lang="en-US" dirty="0"/>
+          </a:p>
+          <a:p>
+            <a:pPr marL="285750" indent="-285750">
+              <a:buFont typeface="Wingdings" pitchFamily="2" charset="2"/>
               <a:buChar char="Ø"/>
             </a:pPr>
             <a:endParaRPr lang="en-US" dirty="0"/>
@@ -3158,10 +4224,10 @@
       </p:sp>
       <p:pic>
         <p:nvPicPr>
-          <p:cNvPr id="4" name="Picture 3">
+          <p:cNvPr id="5" name="Picture 4">
             <a:extLst>
               <a:ext uri="{FF2B5EF4-FFF2-40B4-BE49-F238E27FC236}">
-                <a16:creationId xmlns:a16="http://schemas.microsoft.com/office/drawing/2014/main" id="{696B5A69-3CE0-0868-E452-383521A26C4B}"/>
+                <a16:creationId xmlns:a16="http://schemas.microsoft.com/office/drawing/2014/main" id="{34F9E3E6-3B52-9F5B-7D2C-EEA89A8243B3}"/>
               </a:ext>
             </a:extLst>
           </p:cNvPr>
@@ -3178,8 +4244,8 @@
         </p:blipFill>
         <p:spPr>
           <a:xfrm>
-            <a:off x="6312024" y="-3713"/>
-            <a:ext cx="4964426" cy="6858000"/>
+            <a:off x="6581716" y="0"/>
+            <a:ext cx="4710631" cy="6858000"/>
           </a:xfrm>
           <a:prstGeom prst="rect">
             <a:avLst/>
@@ -3194,7 +4260,7 @@
 </p:sld>
 </file>
 
-<file path=ppt/slides/slide4.xml><?xml version="1.0" encoding="utf-8"?>
+<file path=ppt/slides/slide5.xml><?xml version="1.0" encoding="utf-8"?>
 <p:sld xmlns:a="http://schemas.openxmlformats.org/drawingml/2006/main" xmlns:r="http://schemas.openxmlformats.org/officeDocument/2006/relationships" xmlns:p="http://schemas.openxmlformats.org/presentationml/2006/main" showMasterSp="0">
   <p:cSld>
     <p:spTree>
@@ -3297,7 +4363,7 @@
             <p:spPr>
               <a:xfrm>
                 <a:off x="1092464" y="1054471"/>
-                <a:ext cx="11089232" cy="6488956"/>
+                <a:ext cx="11089232" cy="6783908"/>
               </a:xfrm>
               <a:prstGeom prst="rect">
                 <a:avLst/>
@@ -3329,17 +4395,14 @@
                     </a:solidFill>
                     <a:cs typeface="OAGDQN+FranklinGothic-BookItalic"/>
                   </a:rPr>
-                  <a:t>Treatment response after 2yrs of HAART</a:t>
+                  <a:t>Primary: Year-2 Response</a:t>
                 </a:r>
-                <a:r>
-                  <a:rPr lang="en-US" sz="2000" spc="-25" dirty="0">
-                    <a:solidFill>
-                      <a:srgbClr val="181A0D"/>
-                    </a:solidFill>
-                    <a:cs typeface="OAGDQN+FranklinGothic-BookItalic"/>
-                  </a:rPr>
-                  <a:t> </a:t>
-                </a:r>
+                <a:endParaRPr lang="en-US" sz="2000" spc="-25" dirty="0">
+                  <a:solidFill>
+                    <a:srgbClr val="181A0D"/>
+                  </a:solidFill>
+                  <a:cs typeface="OAGDQN+FranklinGothic-BookItalic"/>
+                </a:endParaRPr>
               </a:p>
               <a:p>
                 <a:pPr marL="800100" lvl="1" indent="-342900">
@@ -3356,34 +4419,24 @@
                     </a:solidFill>
                     <a:cs typeface="OAGDQN+FranklinGothic-BookItalic"/>
                   </a:rPr>
-                  <a:t>Bayesian linear regression using </a:t>
-                </a:r>
-                <a:r>
-                  <a:rPr lang="en-US" sz="2000" spc="-25" dirty="0" err="1">
-                    <a:solidFill>
-                      <a:srgbClr val="181A0D"/>
-                    </a:solidFill>
-                    <a:cs typeface="OAGDQN+FranklinGothic-BookItalic"/>
-                  </a:rPr>
-                  <a:t>brm</a:t>
+                  <a:t>Bayesian </a:t>
                 </a:r>
                 <a:r>
                   <a:rPr lang="en-US" sz="2000" spc="-25" dirty="0">
                     <a:solidFill>
                       <a:srgbClr val="181A0D"/>
                     </a:solidFill>
-                    <a:cs typeface="OAGDQN+FranklinGothic-BookItalic"/>
                   </a:rPr>
-                  <a:t>() package for each treatment response</a:t>
+                  <a:t>regression (brms, HMC-NUTS) + parallel Frequentist regression</a:t>
                 </a:r>
               </a:p>
               <a:p>
-                <a:pPr marL="1257300" lvl="2" indent="-342900">
+                <a:pPr marL="800100" lvl="1" indent="-342900">
                   <a:lnSpc>
                     <a:spcPts val="2258"/>
                   </a:lnSpc>
-                  <a:buFont typeface="Courier New" panose="02070309020205020404" pitchFamily="49" charset="0"/>
-                  <a:buChar char="o"/>
+                  <a:buFont typeface="Wingdings" pitchFamily="2" charset="2"/>
+                  <a:buChar char="Ø"/>
                 </a:pPr>
                 <a:r>
                   <a:rPr lang="en-US" sz="2000" spc="-25" dirty="0">
@@ -3539,7 +4592,7 @@
                     </a:solidFill>
                     <a:cs typeface="OAGDQN+FranklinGothic-BookItalic"/>
                   </a:rPr>
-                  <a:t> on residual variance.</a:t>
+                  <a:t> on residual variance</a:t>
                 </a:r>
               </a:p>
               <a:p>
@@ -3557,7 +4610,7 @@
                     </a:solidFill>
                     <a:cs typeface="OAGDQN+FranklinGothic-BookItalic"/>
                   </a:rPr>
-                  <a:t>Each outcome was modeled as a function of baseline outcome values and covariates</a:t>
+                  <a:t>Adjusted for:</a:t>
                 </a:r>
               </a:p>
               <a:p>
@@ -3570,7 +4623,7 @@
                 </a:pPr>
                 <a:r>
                   <a:rPr lang="en-US" sz="2000" dirty="0"/>
-                  <a:t>Age, BMI, smoking status, education, race/ethnicity </a:t>
+                  <a:t>Baseline outcome value, Age, BMI, smoking status, education, race/ethnicity </a:t>
                 </a:r>
                 <a:endParaRPr lang="en-US" sz="2000" spc="-25" dirty="0">
                   <a:solidFill>
@@ -3580,22 +4633,17 @@
                 </a:endParaRPr>
               </a:p>
               <a:p>
-                <a:pPr marL="800100" lvl="1" indent="-342900">
+                <a:pPr lvl="1">
                   <a:lnSpc>
                     <a:spcPts val="2258"/>
                   </a:lnSpc>
-                  <a:buFont typeface="Wingdings" pitchFamily="2" charset="2"/>
-                  <a:buChar char="Ø"/>
                 </a:pPr>
-                <a:r>
-                  <a:rPr lang="en-US" sz="2000" spc="-25" dirty="0">
-                    <a:solidFill>
-                      <a:srgbClr val="181A0D"/>
-                    </a:solidFill>
-                    <a:cs typeface="OAGDQN+FranklinGothic-BookItalic"/>
-                  </a:rPr>
-                  <a:t>Log10 transformed viral load – others on original scale</a:t>
-                </a:r>
+                <a:endParaRPr lang="en-US" sz="2000" spc="-25" dirty="0">
+                  <a:solidFill>
+                    <a:srgbClr val="181A0D"/>
+                  </a:solidFill>
+                  <a:cs typeface="OAGDQN+FranklinGothic-BookItalic"/>
+                </a:endParaRPr>
               </a:p>
               <a:p>
                 <a:pPr lvl="1">
@@ -3631,7 +4679,7 @@
                     </a:solidFill>
                     <a:cs typeface="OAGDQN+FranklinGothic-BookItalic"/>
                   </a:rPr>
-                  <a:t>Adherence</a:t>
+                  <a:t>Secondary: Adherence</a:t>
                 </a:r>
                 <a:r>
                   <a:rPr lang="en-US" sz="2000" spc="-25" dirty="0">
@@ -3658,25 +4706,7 @@
                     </a:solidFill>
                     <a:cs typeface="OAGDQN+FranklinGothic-BookItalic"/>
                   </a:rPr>
-                  <a:t>Bayesian linear regression using </a:t>
-                </a:r>
-                <a:r>
-                  <a:rPr lang="en-US" sz="2000" spc="-25" dirty="0" err="1">
-                    <a:solidFill>
-                      <a:srgbClr val="181A0D"/>
-                    </a:solidFill>
-                    <a:cs typeface="OAGDQN+FranklinGothic-BookItalic"/>
-                  </a:rPr>
-                  <a:t>brm</a:t>
-                </a:r>
-                <a:r>
-                  <a:rPr lang="en-US" sz="2000" spc="-25" dirty="0">
-                    <a:solidFill>
-                      <a:srgbClr val="181A0D"/>
-                    </a:solidFill>
-                    <a:cs typeface="OAGDQN+FranklinGothic-BookItalic"/>
-                  </a:rPr>
-                  <a:t>() package for each treatment response</a:t>
+                  <a:t>Adherence dichotomized (&lt;95%, ≥95%) used to test association between hard drug users and response</a:t>
                 </a:r>
               </a:p>
               <a:p>
@@ -3687,33 +4717,12 @@
                   <a:buFont typeface="Wingdings" pitchFamily="2" charset="2"/>
                   <a:buChar char="Ø"/>
                 </a:pPr>
-                <a:r>
-                  <a:rPr lang="en-US" sz="2000" spc="-25" dirty="0">
-                    <a:solidFill>
-                      <a:srgbClr val="181A0D"/>
-                    </a:solidFill>
-                    <a:cs typeface="OAGDQN+FranklinGothic-BookItalic"/>
-                  </a:rPr>
-                  <a:t>Same priors</a:t>
-                </a:r>
-              </a:p>
-              <a:p>
-                <a:pPr marL="800100" lvl="1" indent="-342900">
-                  <a:lnSpc>
-                    <a:spcPts val="2258"/>
-                  </a:lnSpc>
-                  <a:buFont typeface="Wingdings" pitchFamily="2" charset="2"/>
-                  <a:buChar char="Ø"/>
-                </a:pPr>
-                <a:r>
-                  <a:rPr lang="en-US" sz="2000" spc="-25" dirty="0">
-                    <a:solidFill>
-                      <a:srgbClr val="181A0D"/>
-                    </a:solidFill>
-                    <a:cs typeface="OAGDQN+FranklinGothic-BookItalic"/>
-                  </a:rPr>
-                  <a:t>Binary adherence (&lt;95%, ≥95%) used to test association between hard drug users and response</a:t>
-                </a:r>
+                <a:endParaRPr lang="en-US" sz="2000" spc="-25" dirty="0">
+                  <a:solidFill>
+                    <a:srgbClr val="181A0D"/>
+                  </a:solidFill>
+                  <a:cs typeface="OAGDQN+FranklinGothic-BookItalic"/>
+                </a:endParaRPr>
               </a:p>
               <a:p>
                 <a:pPr marL="342900" marR="0" indent="-342900">
@@ -3757,7 +4766,7 @@
                     </a:solidFill>
                     <a:cs typeface="OAGDQN+FranklinGothic-BookItalic"/>
                   </a:rPr>
-                  <a:t>Dropout Rates</a:t>
+                  <a:t>Secondary: Dropout Rates</a:t>
                 </a:r>
                 <a:r>
                   <a:rPr lang="en-US" sz="2000" spc="-25" dirty="0">
@@ -3784,7 +4793,7 @@
                     </a:solidFill>
                     <a:cs typeface="OAGDQN+FranklinGothic-BookItalic"/>
                   </a:rPr>
-                  <a:t>Complete cases vs incomplete (missing year2), stratified by hard drug users and non-users</a:t>
+                  <a:t>Complete (Baseline+Year-2) vs Missing Year-2</a:t>
                 </a:r>
               </a:p>
               <a:p>
@@ -3802,7 +4811,7 @@
                     </a:solidFill>
                     <a:cs typeface="OAGDQN+FranklinGothic-BookItalic"/>
                   </a:rPr>
-                  <a:t>Wilcoxon rank sum test</a:t>
+                  <a:t>Nonparametric (Wilcoxon)</a:t>
                 </a:r>
               </a:p>
               <a:p>
@@ -3820,22 +4829,31 @@
                     </a:solidFill>
                     <a:cs typeface="OAGDQN+FranklinGothic-BookItalic"/>
                   </a:rPr>
-                  <a:t>Logistic regression w/complete measurements = 0 &amp; missing = 1</a:t>
+                  <a:t>Logistic regression: </a:t>
+                </a:r>
+                <a:r>
+                  <a:rPr lang="en-US" sz="2000" dirty="0"/>
+                  <a:t> Follow-up Status (Missing Year 2 = 1 vs complete = 0)</a:t>
                 </a:r>
               </a:p>
               <a:p>
-                <a:pPr marL="342900" marR="0" indent="-342900">
+                <a:pPr marL="1257300" lvl="2" indent="-342900">
                   <a:lnSpc>
                     <a:spcPts val="2258"/>
                   </a:lnSpc>
-                  <a:spcBef>
-                    <a:spcPts val="0"/>
-                  </a:spcBef>
-                  <a:spcAft>
-                    <a:spcPts val="0"/>
-                  </a:spcAft>
-                  <a:buFont typeface="Wingdings" pitchFamily="2" charset="2"/>
-                  <a:buChar char="q"/>
+                  <a:buFont typeface="Courier New" panose="02070309020205020404" pitchFamily="49" charset="0"/>
+                  <a:buChar char="o"/>
+                </a:pPr>
+                <a:r>
+                  <a:rPr lang="en-US" sz="2000" dirty="0"/>
+                  <a:t>Function of baseline outcome and covariate measures</a:t>
+                </a:r>
+              </a:p>
+              <a:p>
+                <a:pPr lvl="1">
+                  <a:lnSpc>
+                    <a:spcPts val="2258"/>
+                  </a:lnSpc>
                 </a:pPr>
                 <a:endParaRPr lang="en-US" sz="2000" spc="-25" dirty="0">
                   <a:solidFill>
@@ -3922,7 +4940,7 @@
             <p:spPr>
               <a:xfrm>
                 <a:off x="1092464" y="1054471"/>
-                <a:ext cx="11089232" cy="6488956"/>
+                <a:ext cx="11089232" cy="6783908"/>
               </a:xfrm>
               <a:prstGeom prst="rect">
                 <a:avLst/>
@@ -3930,7 +4948,7 @@
               <a:blipFill>
                 <a:blip r:embed="rId4"/>
                 <a:stretch>
-                  <a:fillRect l="-1486" t="-2544"/>
+                  <a:fillRect l="-1486" t="-2430"/>
                 </a:stretch>
               </a:blipFill>
             </p:spPr>
@@ -3957,7 +4975,7 @@
 </p:sld>
 </file>
 
-<file path=ppt/slides/slide5.xml><?xml version="1.0" encoding="utf-8"?>
+<file path=ppt/slides/slide6.xml><?xml version="1.0" encoding="utf-8"?>
 <p:sld xmlns:a="http://schemas.openxmlformats.org/drawingml/2006/main" xmlns:r="http://schemas.openxmlformats.org/officeDocument/2006/relationships" xmlns:p="http://schemas.openxmlformats.org/presentationml/2006/main" showMasterSp="0">
   <p:cSld>
     <p:spTree>
@@ -3982,7 +5000,7 @@
         </p:nvSpPr>
         <p:spPr>
           <a:xfrm>
-            <a:off x="0" y="6820"/>
+            <a:off x="0" y="0"/>
             <a:ext cx="12192000" cy="6858000"/>
           </a:xfrm>
           <a:prstGeom prst="rect">
@@ -4001,7 +5019,7 @@
           </a:bodyPr>
           <a:lstStyle/>
           <a:p>
-            <a:endParaRPr/>
+            <a:endParaRPr dirty="0"/>
           </a:p>
         </p:txBody>
       </p:sp>
@@ -4078,8 +5096,8 @@
         </p:nvSpPr>
         <p:spPr>
           <a:xfrm>
-            <a:off x="1703512" y="4853634"/>
-            <a:ext cx="4392488" cy="4129336"/>
+            <a:off x="911424" y="814400"/>
+            <a:ext cx="3960440" cy="7086555"/>
           </a:xfrm>
           <a:prstGeom prst="rect">
             <a:avLst/>
@@ -4091,89 +5109,50 @@
           </a:bodyPr>
           <a:lstStyle/>
           <a:p>
-            <a:pPr marL="342900" indent="-342900">
-              <a:lnSpc>
-                <a:spcPts val="2258"/>
-              </a:lnSpc>
+            <a:pPr marL="800100" lvl="1" indent="-342900">
+              <a:lnSpc>
+                <a:spcPts val="2258"/>
+              </a:lnSpc>
+              <a:buFont typeface="Wingdings" pitchFamily="2" charset="2"/>
+              <a:buChar char="Ø"/>
+            </a:pPr>
+            <a:endParaRPr lang="en-US" sz="2000" spc="-25" dirty="0">
+              <a:solidFill>
+                <a:srgbClr val="181A0D"/>
+              </a:solidFill>
+              <a:cs typeface="OAGDQN+FranklinGothic-BookItalic"/>
+            </a:endParaRPr>
+          </a:p>
+          <a:p>
+            <a:pPr marL="285750" indent="-285750">
               <a:buFont typeface="Wingdings" pitchFamily="2" charset="2"/>
               <a:buChar char="q"/>
             </a:pPr>
             <a:r>
-              <a:rPr lang="en-US" sz="2000" b="1" spc="-25" dirty="0">
-                <a:solidFill>
-                  <a:srgbClr val="181A0D"/>
-                </a:solidFill>
-                <a:cs typeface="OAGDQN+FranklinGothic-BookItalic"/>
-              </a:rPr>
-              <a:t>Treatment response after 2yrs of HAART:</a:t>
-            </a:r>
-          </a:p>
-          <a:p>
-            <a:pPr marL="342900" marR="0" indent="-342900">
-              <a:lnSpc>
-                <a:spcPts val="2258"/>
-              </a:lnSpc>
-              <a:spcBef>
-                <a:spcPts val="0"/>
-              </a:spcBef>
-              <a:spcAft>
-                <a:spcPts val="0"/>
-              </a:spcAft>
+              <a:rPr lang="en-US" b="1" dirty="0"/>
+              <a:t>CD4</a:t>
+            </a:r>
+            <a:endParaRPr lang="en-US" dirty="0"/>
+          </a:p>
+          <a:p>
+            <a:pPr marL="285750" lvl="0" indent="-285750">
               <a:buFont typeface="Wingdings" pitchFamily="2" charset="2"/>
               <a:buChar char="Ø"/>
             </a:pPr>
             <a:r>
-              <a:rPr lang="en-US" sz="2000" spc="-25" dirty="0">
-                <a:solidFill>
-                  <a:srgbClr val="181A0D"/>
-                </a:solidFill>
-                <a:cs typeface="OAGDQN+FranklinGothic-BookItalic"/>
-              </a:rPr>
-              <a:t>Controlling for baseline outcome and covariates:</a:t>
-            </a:r>
-          </a:p>
-          <a:p>
-            <a:pPr marL="800100" lvl="1" indent="-342900">
-              <a:lnSpc>
-                <a:spcPts val="2258"/>
-              </a:lnSpc>
+              <a:rPr lang="en-US" dirty="0"/>
+              <a:t>−164 cells/mm³ (95% HDI: −263 to −103)</a:t>
+            </a:r>
+          </a:p>
+          <a:p>
+            <a:pPr marL="285750" lvl="0" indent="-285750">
               <a:buFont typeface="Wingdings" pitchFamily="2" charset="2"/>
               <a:buChar char="Ø"/>
             </a:pPr>
-            <a:endParaRPr lang="en-US" sz="2000" spc="-25" dirty="0">
-              <a:solidFill>
-                <a:srgbClr val="181A0D"/>
-              </a:solidFill>
-              <a:cs typeface="OAGDQN+FranklinGothic-BookItalic"/>
-            </a:endParaRPr>
-          </a:p>
-          <a:p>
-            <a:pPr lvl="1">
-              <a:lnSpc>
-                <a:spcPts val="2258"/>
-              </a:lnSpc>
-            </a:pPr>
-            <a:endParaRPr lang="en-US" sz="2000" spc="-25" dirty="0">
-              <a:solidFill>
-                <a:srgbClr val="181A0D"/>
-              </a:solidFill>
-              <a:cs typeface="OAGDQN+FranklinGothic-BookItalic"/>
-            </a:endParaRPr>
-          </a:p>
-          <a:p>
-            <a:pPr marL="342900" indent="-342900">
-              <a:lnSpc>
-                <a:spcPts val="2258"/>
-              </a:lnSpc>
-              <a:buFont typeface="Wingdings" pitchFamily="2" charset="2"/>
-              <a:buChar char="Ø"/>
-            </a:pPr>
-            <a:endParaRPr lang="en-US" sz="2000" spc="-25" dirty="0">
-              <a:solidFill>
-                <a:srgbClr val="181A0D"/>
-              </a:solidFill>
-              <a:cs typeface="OAGDQN+FranklinGothic-BookItalic"/>
-            </a:endParaRPr>
+            <a:r>
+              <a:rPr lang="en-US" dirty="0"/>
+              <a:t>99.5% probability exceeds 50-cell clinical threshold</a:t>
+            </a:r>
           </a:p>
           <a:p>
             <a:pPr marL="800100" lvl="1" indent="-342900">
@@ -4189,6 +5168,110 @@
               </a:solidFill>
               <a:cs typeface="OAGDQN+FranklinGothic-BookItalic"/>
             </a:endParaRPr>
+          </a:p>
+          <a:p>
+            <a:pPr marL="285750" indent="-285750">
+              <a:buFont typeface="Wingdings" pitchFamily="2" charset="2"/>
+              <a:buChar char="q"/>
+            </a:pPr>
+            <a:r>
+              <a:rPr lang="en-US" b="1" dirty="0"/>
+              <a:t>Viral Load</a:t>
+            </a:r>
+            <a:endParaRPr lang="en-US" dirty="0"/>
+          </a:p>
+          <a:p>
+            <a:pPr marL="285750" lvl="0" indent="-285750">
+              <a:buFont typeface="Wingdings" pitchFamily="2" charset="2"/>
+              <a:buChar char="Ø"/>
+            </a:pPr>
+            <a:r>
+              <a:rPr lang="en-US" dirty="0"/>
+              <a:t>No meaningful difference</a:t>
+            </a:r>
+          </a:p>
+          <a:p>
+            <a:pPr marL="285750" lvl="0" indent="-285750">
+              <a:buFont typeface="Wingdings" pitchFamily="2" charset="2"/>
+              <a:buChar char="Ø"/>
+            </a:pPr>
+            <a:r>
+              <a:rPr lang="en-US" dirty="0"/>
+              <a:t>2.3% probability exceeds 0.5 log threshold</a:t>
+            </a:r>
+          </a:p>
+          <a:p>
+            <a:pPr marL="342900" indent="-342900">
+              <a:lnSpc>
+                <a:spcPts val="2258"/>
+              </a:lnSpc>
+              <a:buFont typeface="Wingdings" pitchFamily="2" charset="2"/>
+              <a:buChar char="q"/>
+            </a:pPr>
+            <a:endParaRPr lang="en-US" sz="2000" spc="-25" dirty="0">
+              <a:solidFill>
+                <a:srgbClr val="181A0D"/>
+              </a:solidFill>
+              <a:cs typeface="OAGDQN+FranklinGothic-BookItalic"/>
+            </a:endParaRPr>
+          </a:p>
+          <a:p>
+            <a:pPr marL="285750" indent="-285750">
+              <a:buFont typeface="Wingdings" pitchFamily="2" charset="2"/>
+              <a:buChar char="q"/>
+            </a:pPr>
+            <a:r>
+              <a:rPr lang="en-US" b="1" dirty="0"/>
+              <a:t>Physical QOL</a:t>
+            </a:r>
+            <a:endParaRPr lang="en-US" dirty="0"/>
+          </a:p>
+          <a:p>
+            <a:pPr marL="285750" lvl="0" indent="-285750">
+              <a:buFont typeface="Wingdings" pitchFamily="2" charset="2"/>
+              <a:buChar char="Ø"/>
+            </a:pPr>
+            <a:r>
+              <a:rPr lang="en-US" dirty="0"/>
+              <a:t>−3.3 points</a:t>
+            </a:r>
+          </a:p>
+          <a:p>
+            <a:pPr marL="285750" lvl="0" indent="-285750">
+              <a:buFont typeface="Wingdings" pitchFamily="2" charset="2"/>
+              <a:buChar char="Ø"/>
+            </a:pPr>
+            <a:r>
+              <a:rPr lang="en-US" dirty="0"/>
+              <a:t>83% probability exceeds 2-point threshold</a:t>
+            </a:r>
+          </a:p>
+          <a:p>
+            <a:r>
+              <a:rPr lang="en-US" dirty="0"/>
+              <a:t> </a:t>
+            </a:r>
+          </a:p>
+          <a:p>
+            <a:pPr marL="285750" indent="-285750">
+              <a:buFont typeface="Wingdings" pitchFamily="2" charset="2"/>
+              <a:buChar char="q"/>
+            </a:pPr>
+            <a:r>
+              <a:rPr lang="en-US" b="1" dirty="0"/>
+              <a:t>Mental QOL</a:t>
+            </a:r>
+            <a:endParaRPr lang="en-US" dirty="0"/>
+          </a:p>
+          <a:p>
+            <a:pPr marL="285750" lvl="0" indent="-285750">
+              <a:buFont typeface="Wingdings" pitchFamily="2" charset="2"/>
+              <a:buChar char="Ø"/>
+            </a:pPr>
+            <a:r>
+              <a:rPr lang="en-US" dirty="0"/>
+              <a:t>No meaningful difference</a:t>
+            </a:r>
           </a:p>
           <a:p>
             <a:pPr marL="342900" indent="-342900">
@@ -4328,8 +5411,8 @@
         </p:blipFill>
         <p:spPr>
           <a:xfrm>
-            <a:off x="2207568" y="934019"/>
-            <a:ext cx="8593371" cy="3799996"/>
+            <a:off x="4511824" y="2132856"/>
+            <a:ext cx="7490643" cy="3312368"/>
           </a:xfrm>
           <a:prstGeom prst="rect">
             <a:avLst/>
@@ -4344,7 +5427,7 @@
 </p:sld>
 </file>
 
-<file path=ppt/slides/slide6.xml><?xml version="1.0" encoding="utf-8"?>
+<file path=ppt/slides/slide7.xml><?xml version="1.0" encoding="utf-8"?>
 <p:sld xmlns:a="http://schemas.openxmlformats.org/drawingml/2006/main" xmlns:r="http://schemas.openxmlformats.org/officeDocument/2006/relationships" xmlns:p="http://schemas.openxmlformats.org/presentationml/2006/main" showMasterSp="0">
   <p:cSld>
     <p:spTree>
@@ -4787,14 +5870,248 @@
         </p:blipFill>
         <p:spPr>
           <a:xfrm>
-            <a:off x="1760800" y="1089432"/>
-            <a:ext cx="9073120" cy="4206981"/>
+            <a:off x="3863752" y="1452933"/>
+            <a:ext cx="8151671" cy="3779728"/>
           </a:xfrm>
           <a:prstGeom prst="rect">
             <a:avLst/>
           </a:prstGeom>
         </p:spPr>
       </p:pic>
+      <p:sp>
+        <p:nvSpPr>
+          <p:cNvPr id="6" name="object 4">
+            <a:extLst>
+              <a:ext uri="{FF2B5EF4-FFF2-40B4-BE49-F238E27FC236}">
+                <a16:creationId xmlns:a16="http://schemas.microsoft.com/office/drawing/2014/main" id="{3AB54E8C-A2D6-6F7F-7472-2EF4711E11D4}"/>
+              </a:ext>
+            </a:extLst>
+          </p:cNvPr>
+          <p:cNvSpPr txBox="1"/>
+          <p:nvPr/>
+        </p:nvSpPr>
+        <p:spPr>
+          <a:xfrm>
+            <a:off x="867913" y="1212744"/>
+            <a:ext cx="2973409" cy="6989093"/>
+          </a:xfrm>
+          <a:prstGeom prst="rect">
+            <a:avLst/>
+          </a:prstGeom>
+        </p:spPr>
+        <p:txBody>
+          <a:bodyPr vert="horz" wrap="square" lIns="0" tIns="0" rIns="0" bIns="0" rtlCol="0">
+            <a:spAutoFit/>
+          </a:bodyPr>
+          <a:lstStyle/>
+          <a:p>
+            <a:pPr marL="800100" lvl="1" indent="-342900">
+              <a:lnSpc>
+                <a:spcPts val="2258"/>
+              </a:lnSpc>
+              <a:buFont typeface="Wingdings" pitchFamily="2" charset="2"/>
+              <a:buChar char="Ø"/>
+            </a:pPr>
+            <a:endParaRPr lang="en-US" sz="2000" spc="-25" dirty="0">
+              <a:solidFill>
+                <a:srgbClr val="181A0D"/>
+              </a:solidFill>
+              <a:cs typeface="OAGDQN+FranklinGothic-BookItalic"/>
+            </a:endParaRPr>
+          </a:p>
+          <a:p>
+            <a:pPr marL="342900" indent="-342900">
+              <a:buFont typeface="Wingdings" pitchFamily="2" charset="2"/>
+              <a:buChar char="q"/>
+            </a:pPr>
+            <a:r>
+              <a:rPr lang="en-US" sz="2000" dirty="0"/>
+              <a:t>Inclusion of adherence increased magnitude of hard drug coefficient</a:t>
+            </a:r>
+          </a:p>
+          <a:p>
+            <a:pPr marL="800100" lvl="1" indent="-342900">
+              <a:buFont typeface="Wingdings" pitchFamily="2" charset="2"/>
+              <a:buChar char="Ø"/>
+            </a:pPr>
+            <a:r>
+              <a:rPr lang="en-US" sz="2000" dirty="0"/>
+              <a:t>&lt;95% vs ≥95%</a:t>
+            </a:r>
+          </a:p>
+          <a:p>
+            <a:pPr marL="342900" indent="-342900">
+              <a:buFont typeface="Wingdings" pitchFamily="2" charset="2"/>
+              <a:buChar char="q"/>
+            </a:pPr>
+            <a:endParaRPr lang="en-US" sz="2000" dirty="0"/>
+          </a:p>
+          <a:p>
+            <a:endParaRPr lang="en-US" sz="2000" dirty="0"/>
+          </a:p>
+          <a:p>
+            <a:pPr marL="342900" indent="-342900">
+              <a:buFont typeface="Wingdings" pitchFamily="2" charset="2"/>
+              <a:buChar char="q"/>
+            </a:pPr>
+            <a:r>
+              <a:rPr lang="en-US" sz="2000" dirty="0"/>
+              <a:t>Proportion mediated negative</a:t>
+            </a:r>
+          </a:p>
+          <a:p>
+            <a:pPr marL="342900" indent="-342900">
+              <a:buFont typeface="Wingdings" pitchFamily="2" charset="2"/>
+              <a:buChar char="q"/>
+            </a:pPr>
+            <a:endParaRPr lang="en-US" sz="2000" dirty="0"/>
+          </a:p>
+          <a:p>
+            <a:endParaRPr lang="en-US" sz="2000" dirty="0"/>
+          </a:p>
+          <a:p>
+            <a:pPr marL="342900" indent="-342900">
+              <a:buFont typeface="Wingdings" pitchFamily="2" charset="2"/>
+              <a:buChar char="q"/>
+            </a:pPr>
+            <a:r>
+              <a:rPr lang="en-US" sz="2000" dirty="0"/>
+              <a:t>No evidence of meaningful mediation</a:t>
+            </a:r>
+          </a:p>
+          <a:p>
+            <a:pPr marL="342900" indent="-342900">
+              <a:buFont typeface="Wingdings" pitchFamily="2" charset="2"/>
+              <a:buChar char="q"/>
+            </a:pPr>
+            <a:endParaRPr lang="en-US" sz="2000" dirty="0"/>
+          </a:p>
+          <a:p>
+            <a:pPr marL="342900" indent="-342900">
+              <a:buFont typeface="Wingdings" pitchFamily="2" charset="2"/>
+              <a:buChar char="q"/>
+            </a:pPr>
+            <a:r>
+              <a:rPr lang="en-US" sz="2000" dirty="0"/>
+              <a:t>Analysis limited by sparse data in adherence categories</a:t>
+            </a:r>
+          </a:p>
+          <a:p>
+            <a:pPr marL="342900" indent="-342900">
+              <a:lnSpc>
+                <a:spcPts val="2258"/>
+              </a:lnSpc>
+              <a:buFont typeface="Wingdings" pitchFamily="2" charset="2"/>
+              <a:buChar char="q"/>
+            </a:pPr>
+            <a:endParaRPr lang="en-US" sz="2000" spc="-25" dirty="0">
+              <a:solidFill>
+                <a:srgbClr val="181A0D"/>
+              </a:solidFill>
+              <a:cs typeface="OAGDQN+FranklinGothic-BookItalic"/>
+            </a:endParaRPr>
+          </a:p>
+          <a:p>
+            <a:pPr marL="342900" indent="-342900">
+              <a:lnSpc>
+                <a:spcPts val="2258"/>
+              </a:lnSpc>
+              <a:buFont typeface="Wingdings" pitchFamily="2" charset="2"/>
+              <a:buChar char="Ø"/>
+            </a:pPr>
+            <a:endParaRPr lang="en-US" sz="2000" spc="-25" dirty="0">
+              <a:solidFill>
+                <a:srgbClr val="181A0D"/>
+              </a:solidFill>
+              <a:cs typeface="OAGDQN+FranklinGothic-BookItalic"/>
+            </a:endParaRPr>
+          </a:p>
+          <a:p>
+            <a:pPr marL="342900" marR="0" indent="-342900">
+              <a:lnSpc>
+                <a:spcPts val="2258"/>
+              </a:lnSpc>
+              <a:spcBef>
+                <a:spcPts val="0"/>
+              </a:spcBef>
+              <a:spcAft>
+                <a:spcPts val="0"/>
+              </a:spcAft>
+              <a:buFont typeface="Wingdings" pitchFamily="2" charset="2"/>
+              <a:buChar char="q"/>
+            </a:pPr>
+            <a:endParaRPr lang="en-US" sz="2000" spc="-25" dirty="0">
+              <a:solidFill>
+                <a:srgbClr val="181A0D"/>
+              </a:solidFill>
+              <a:cs typeface="OAGDQN+FranklinGothic-BookItalic"/>
+            </a:endParaRPr>
+          </a:p>
+          <a:p>
+            <a:pPr marL="342900" marR="0" indent="-342900">
+              <a:lnSpc>
+                <a:spcPts val="2258"/>
+              </a:lnSpc>
+              <a:spcBef>
+                <a:spcPts val="0"/>
+              </a:spcBef>
+              <a:spcAft>
+                <a:spcPts val="0"/>
+              </a:spcAft>
+              <a:buFont typeface="Wingdings" pitchFamily="2" charset="2"/>
+              <a:buChar char="q"/>
+            </a:pPr>
+            <a:endParaRPr lang="en-US" sz="2000" spc="-25" dirty="0">
+              <a:solidFill>
+                <a:srgbClr val="181A0D"/>
+              </a:solidFill>
+              <a:cs typeface="OAGDQN+FranklinGothic-BookItalic"/>
+            </a:endParaRPr>
+          </a:p>
+          <a:p>
+            <a:pPr marL="342900" marR="0" indent="-342900">
+              <a:lnSpc>
+                <a:spcPts val="2258"/>
+              </a:lnSpc>
+              <a:spcBef>
+                <a:spcPts val="0"/>
+              </a:spcBef>
+              <a:spcAft>
+                <a:spcPts val="0"/>
+              </a:spcAft>
+              <a:buFont typeface="Wingdings" pitchFamily="2" charset="2"/>
+              <a:buChar char="q"/>
+            </a:pPr>
+            <a:endParaRPr lang="en-US" sz="2000" spc="-25" dirty="0">
+              <a:solidFill>
+                <a:srgbClr val="181A0D"/>
+              </a:solidFill>
+              <a:cs typeface="OAGDQN+FranklinGothic-BookItalic"/>
+            </a:endParaRPr>
+          </a:p>
+          <a:p>
+            <a:pPr marL="342900" marR="0" indent="-342900">
+              <a:lnSpc>
+                <a:spcPts val="2258"/>
+              </a:lnSpc>
+              <a:spcBef>
+                <a:spcPts val="0"/>
+              </a:spcBef>
+              <a:spcAft>
+                <a:spcPts val="0"/>
+              </a:spcAft>
+              <a:buFont typeface="Wingdings" pitchFamily="2" charset="2"/>
+              <a:buChar char="q"/>
+            </a:pPr>
+            <a:endParaRPr sz="2000" spc="-25" dirty="0">
+              <a:solidFill>
+                <a:srgbClr val="181A0D"/>
+              </a:solidFill>
+              <a:cs typeface="OAGDQN+FranklinGothic-BookItalic"/>
+            </a:endParaRPr>
+          </a:p>
+        </p:txBody>
+      </p:sp>
     </p:spTree>
   </p:cSld>
   <p:clrMapOvr>
@@ -4803,7 +6120,7 @@
 </p:sld>
 </file>
 
-<file path=ppt/slides/slide7.xml><?xml version="1.0" encoding="utf-8"?>
+<file path=ppt/slides/slide8.xml><?xml version="1.0" encoding="utf-8"?>
 <p:sld xmlns:a="http://schemas.openxmlformats.org/drawingml/2006/main" xmlns:r="http://schemas.openxmlformats.org/officeDocument/2006/relationships" xmlns:p="http://schemas.openxmlformats.org/presentationml/2006/main">
   <p:cSld>
     <p:spTree>
@@ -4942,8 +6259,8 @@
         </p:nvSpPr>
         <p:spPr>
           <a:xfrm>
-            <a:off x="875244" y="980779"/>
-            <a:ext cx="4811155" cy="4424288"/>
+            <a:off x="962944" y="1340768"/>
+            <a:ext cx="2905849" cy="6783908"/>
           </a:xfrm>
           <a:prstGeom prst="rect">
             <a:avLst/>
@@ -5018,6 +6335,20 @@
             </a:endParaRPr>
           </a:p>
           <a:p>
+            <a:pPr marL="342900" indent="-342900">
+              <a:lnSpc>
+                <a:spcPts val="2258"/>
+              </a:lnSpc>
+              <a:buFont typeface="Wingdings" pitchFamily="2" charset="2"/>
+              <a:buChar char="q"/>
+            </a:pPr>
+            <a:r>
+              <a:rPr lang="en-US" b="1" dirty="0"/>
+              <a:t>252 participants were missing Year 2 data (≈35%)</a:t>
+            </a:r>
+            <a:endParaRPr lang="en-US" dirty="0"/>
+          </a:p>
+          <a:p>
             <a:pPr marL="342900" marR="0" indent="-342900">
               <a:lnSpc>
                 <a:spcPts val="2258"/>
@@ -5037,6 +6368,42 @@
               </a:solidFill>
               <a:cs typeface="OAGDQN+FranklinGothic-BookItalic"/>
             </a:endParaRPr>
+          </a:p>
+          <a:p>
+            <a:pPr marL="342900" indent="-342900">
+              <a:lnSpc>
+                <a:spcPts val="2258"/>
+              </a:lnSpc>
+              <a:buFont typeface="Wingdings" pitchFamily="2" charset="2"/>
+              <a:buChar char="q"/>
+            </a:pPr>
+            <a:r>
+              <a:rPr lang="en-US" b="1" dirty="0"/>
+              <a:t>Lower baseline physical QOL associated with dropout</a:t>
+            </a:r>
+          </a:p>
+          <a:p>
+            <a:pPr marL="342900" indent="-342900">
+              <a:lnSpc>
+                <a:spcPts val="2258"/>
+              </a:lnSpc>
+              <a:buFont typeface="Wingdings" pitchFamily="2" charset="2"/>
+              <a:buChar char="q"/>
+            </a:pPr>
+            <a:endParaRPr lang="en-US" b="1" dirty="0"/>
+          </a:p>
+          <a:p>
+            <a:pPr marL="342900" indent="-342900">
+              <a:lnSpc>
+                <a:spcPts val="2258"/>
+              </a:lnSpc>
+              <a:buFont typeface="Wingdings" pitchFamily="2" charset="2"/>
+              <a:buChar char="q"/>
+            </a:pPr>
+            <a:r>
+              <a:rPr lang="en-US" b="1" dirty="0"/>
+              <a:t>Younger age also associated with dropout</a:t>
+            </a:r>
           </a:p>
           <a:p>
             <a:pPr marL="342900" marR="0" indent="-342900">
@@ -5255,8 +6622,38 @@
         </p:blipFill>
         <p:spPr>
           <a:xfrm>
-            <a:off x="2567608" y="1007371"/>
-            <a:ext cx="9449909" cy="5242882"/>
+            <a:off x="4187660" y="826193"/>
+            <a:ext cx="7923482" cy="4396008"/>
+          </a:xfrm>
+          <a:prstGeom prst="rect">
+            <a:avLst/>
+          </a:prstGeom>
+        </p:spPr>
+      </p:pic>
+      <p:pic>
+        <p:nvPicPr>
+          <p:cNvPr id="7" name="Picture 6" descr="A screenshot of a computer&#10;&#10;AI-generated content may be incorrect.">
+            <a:extLst>
+              <a:ext uri="{FF2B5EF4-FFF2-40B4-BE49-F238E27FC236}">
+                <a16:creationId xmlns:a16="http://schemas.microsoft.com/office/drawing/2014/main" id="{906C3A0D-869F-920A-2F61-71B4D8843D52}"/>
+              </a:ext>
+            </a:extLst>
+          </p:cNvPr>
+          <p:cNvPicPr>
+            <a:picLocks noChangeAspect="1"/>
+          </p:cNvPicPr>
+          <p:nvPr/>
+        </p:nvPicPr>
+        <p:blipFill>
+          <a:blip r:embed="rId5"/>
+          <a:stretch>
+            <a:fillRect/>
+          </a:stretch>
+        </p:blipFill>
+        <p:spPr>
+          <a:xfrm>
+            <a:off x="4187660" y="5266454"/>
+            <a:ext cx="7865278" cy="1418439"/>
           </a:xfrm>
           <a:prstGeom prst="rect">
             <a:avLst/>
@@ -5276,7 +6673,7 @@
 </p:sld>
 </file>
 
-<file path=ppt/slides/slide8.xml><?xml version="1.0" encoding="utf-8"?>
+<file path=ppt/slides/slide9.xml><?xml version="1.0" encoding="utf-8"?>
 <p:sld xmlns:a="http://schemas.openxmlformats.org/drawingml/2006/main" xmlns:r="http://schemas.openxmlformats.org/officeDocument/2006/relationships" xmlns:p="http://schemas.openxmlformats.org/presentationml/2006/main" showMasterSp="0">
   <p:cSld>
     <p:spTree>
@@ -5388,7 +6785,7 @@
         </p:nvSpPr>
         <p:spPr>
           <a:xfrm>
-            <a:off x="1415480" y="901849"/>
+            <a:off x="1127448" y="1132209"/>
             <a:ext cx="10297144" cy="6194003"/>
           </a:xfrm>
           <a:prstGeom prst="rect">
@@ -5408,6 +6805,114 @@
               <a:buFont typeface="Wingdings" pitchFamily="2" charset="2"/>
               <a:buChar char="q"/>
             </a:pPr>
+            <a:r>
+              <a:rPr lang="en-US" sz="2000" b="1" spc="-25" dirty="0">
+                <a:solidFill>
+                  <a:srgbClr val="181A0D"/>
+                </a:solidFill>
+                <a:cs typeface="OAGDQN+FranklinGothic-BookItalic"/>
+              </a:rPr>
+              <a:t>Findings:</a:t>
+            </a:r>
+          </a:p>
+          <a:p>
+            <a:pPr marL="800100" lvl="1" indent="-342900">
+              <a:lnSpc>
+                <a:spcPts val="2258"/>
+              </a:lnSpc>
+              <a:buFont typeface="Wingdings" pitchFamily="2" charset="2"/>
+              <a:buChar char="Ø"/>
+            </a:pPr>
+            <a:r>
+              <a:rPr lang="en-US" sz="2000" spc="-25" dirty="0">
+                <a:solidFill>
+                  <a:srgbClr val="181A0D"/>
+                </a:solidFill>
+                <a:cs typeface="OAGDQN+FranklinGothic-BookItalic"/>
+              </a:rPr>
+              <a:t>Lower CD4 T-cell counts among baseline hard drug users</a:t>
+            </a:r>
+          </a:p>
+          <a:p>
+            <a:pPr marL="800100" lvl="1" indent="-342900">
+              <a:lnSpc>
+                <a:spcPts val="2258"/>
+              </a:lnSpc>
+              <a:buFont typeface="Wingdings" pitchFamily="2" charset="2"/>
+              <a:buChar char="Ø"/>
+            </a:pPr>
+            <a:r>
+              <a:rPr lang="en-US" sz="2000" spc="-25" dirty="0">
+                <a:solidFill>
+                  <a:srgbClr val="181A0D"/>
+                </a:solidFill>
+                <a:cs typeface="OAGDQN+FranklinGothic-BookItalic"/>
+              </a:rPr>
+              <a:t>Lower physical QOL scores</a:t>
+            </a:r>
+          </a:p>
+          <a:p>
+            <a:pPr marL="800100" lvl="1" indent="-342900">
+              <a:lnSpc>
+                <a:spcPts val="2258"/>
+              </a:lnSpc>
+              <a:buFont typeface="Wingdings" pitchFamily="2" charset="2"/>
+              <a:buChar char="Ø"/>
+            </a:pPr>
+            <a:r>
+              <a:rPr lang="en-US" sz="2000" spc="-25" dirty="0">
+                <a:solidFill>
+                  <a:srgbClr val="181A0D"/>
+                </a:solidFill>
+                <a:cs typeface="OAGDQN+FranklinGothic-BookItalic"/>
+              </a:rPr>
+              <a:t>No meaningful differences in viral load or mental QOL</a:t>
+            </a:r>
+          </a:p>
+          <a:p>
+            <a:pPr marL="800100" lvl="1" indent="-342900">
+              <a:lnSpc>
+                <a:spcPts val="2258"/>
+              </a:lnSpc>
+              <a:buFont typeface="Wingdings" pitchFamily="2" charset="2"/>
+              <a:buChar char="Ø"/>
+            </a:pPr>
+            <a:r>
+              <a:rPr lang="en-US" sz="2000" spc="-25" dirty="0">
+                <a:solidFill>
+                  <a:srgbClr val="181A0D"/>
+                </a:solidFill>
+                <a:cs typeface="OAGDQN+FranklinGothic-BookItalic"/>
+              </a:rPr>
+              <a:t>Adherence wasn’t meaningful</a:t>
+            </a:r>
+          </a:p>
+          <a:p>
+            <a:pPr marL="800100" lvl="1" indent="-342900">
+              <a:lnSpc>
+                <a:spcPts val="2258"/>
+              </a:lnSpc>
+              <a:buFont typeface="Wingdings" pitchFamily="2" charset="2"/>
+              <a:buChar char="Ø"/>
+            </a:pPr>
+            <a:r>
+              <a:rPr lang="en-US" sz="2000" spc="-25" dirty="0">
+                <a:solidFill>
+                  <a:srgbClr val="181A0D"/>
+                </a:solidFill>
+                <a:cs typeface="OAGDQN+FranklinGothic-BookItalic"/>
+              </a:rPr>
+              <a:t>Younger age and physical QOL was associated with dropout</a:t>
+            </a:r>
+          </a:p>
+          <a:p>
+            <a:pPr marL="342900" indent="-342900">
+              <a:lnSpc>
+                <a:spcPts val="2258"/>
+              </a:lnSpc>
+              <a:buFont typeface="Wingdings" pitchFamily="2" charset="2"/>
+              <a:buChar char="q"/>
+            </a:pPr>
             <a:endParaRPr lang="en-US" sz="2000" spc="-25" dirty="0">
               <a:solidFill>
                 <a:srgbClr val="181A0D"/>
@@ -5423,6 +6928,39 @@
               <a:buFont typeface="Wingdings" pitchFamily="2" charset="2"/>
               <a:buChar char="q"/>
             </a:pPr>
+            <a:endParaRPr lang="en-US" sz="2000" spc="-25" dirty="0">
+              <a:solidFill>
+                <a:srgbClr val="181A0D"/>
+              </a:solidFill>
+              <a:cs typeface="OAGDQN+FranklinGothic-BookItalic"/>
+            </a:endParaRPr>
+          </a:p>
+          <a:p>
+            <a:pPr marL="342900" indent="-342900">
+              <a:lnSpc>
+                <a:spcPts val="2258"/>
+              </a:lnSpc>
+              <a:buFont typeface="Wingdings" pitchFamily="2" charset="2"/>
+              <a:buChar char="q"/>
+            </a:pPr>
+            <a:r>
+              <a:rPr lang="en-US" sz="2000" b="1" spc="-25" dirty="0">
+                <a:solidFill>
+                  <a:srgbClr val="181A0D"/>
+                </a:solidFill>
+                <a:cs typeface="OAGDQN+FranklinGothic-BookItalic"/>
+              </a:rPr>
+              <a:t>Limitations:</a:t>
+            </a:r>
+          </a:p>
+          <a:p>
+            <a:pPr marL="800100" lvl="1" indent="-342900">
+              <a:lnSpc>
+                <a:spcPts val="2258"/>
+              </a:lnSpc>
+              <a:buFont typeface="Wingdings" pitchFamily="2" charset="2"/>
+              <a:buChar char="Ø"/>
+            </a:pPr>
             <a:r>
               <a:rPr lang="en-US" sz="2000" spc="-25" dirty="0">
                 <a:solidFill>
@@ -5430,16 +6968,16 @@
                 </a:solidFill>
                 <a:cs typeface="OAGDQN+FranklinGothic-BookItalic"/>
               </a:rPr>
-              <a:t>Lower CD4 T-cell counts among baseline hard drug users</a:t>
-            </a:r>
-          </a:p>
-          <a:p>
-            <a:pPr marL="342900" indent="-342900">
-              <a:lnSpc>
-                <a:spcPts val="2258"/>
-              </a:lnSpc>
-              <a:buFont typeface="Wingdings" pitchFamily="2" charset="2"/>
-              <a:buChar char="q"/>
+              <a:t>Observational study design</a:t>
+            </a:r>
+          </a:p>
+          <a:p>
+            <a:pPr marL="800100" lvl="1" indent="-342900">
+              <a:lnSpc>
+                <a:spcPts val="2258"/>
+              </a:lnSpc>
+              <a:buFont typeface="Wingdings" pitchFamily="2" charset="2"/>
+              <a:buChar char="Ø"/>
             </a:pPr>
             <a:r>
               <a:rPr lang="en-US" sz="2000" spc="-25" dirty="0">
@@ -5448,16 +6986,16 @@
                 </a:solidFill>
                 <a:cs typeface="OAGDQN+FranklinGothic-BookItalic"/>
               </a:rPr>
-              <a:t>Lower physical QOL scores</a:t>
-            </a:r>
-          </a:p>
-          <a:p>
-            <a:pPr marL="342900" indent="-342900">
-              <a:lnSpc>
-                <a:spcPts val="2258"/>
-              </a:lnSpc>
-              <a:buFont typeface="Wingdings" pitchFamily="2" charset="2"/>
-              <a:buChar char="q"/>
+              <a:t>Adherence coded as binary (&lt;95% vs ≥95%)</a:t>
+            </a:r>
+          </a:p>
+          <a:p>
+            <a:pPr marL="800100" lvl="1" indent="-342900">
+              <a:lnSpc>
+                <a:spcPts val="2258"/>
+              </a:lnSpc>
+              <a:buFont typeface="Wingdings" pitchFamily="2" charset="2"/>
+              <a:buChar char="Ø"/>
             </a:pPr>
             <a:r>
               <a:rPr lang="en-US" sz="2000" spc="-25" dirty="0">
@@ -5466,16 +7004,16 @@
                 </a:solidFill>
                 <a:cs typeface="OAGDQN+FranklinGothic-BookItalic"/>
               </a:rPr>
-              <a:t>No meaningful differences in viral load or mental QOL</a:t>
-            </a:r>
-          </a:p>
-          <a:p>
-            <a:pPr marL="342900" indent="-342900">
-              <a:lnSpc>
-                <a:spcPts val="2258"/>
-              </a:lnSpc>
-              <a:buFont typeface="Wingdings" pitchFamily="2" charset="2"/>
-              <a:buChar char="q"/>
+              <a:t>Mediation = exploratory </a:t>
+            </a:r>
+          </a:p>
+          <a:p>
+            <a:pPr marL="800100" lvl="1" indent="-342900">
+              <a:lnSpc>
+                <a:spcPts val="2258"/>
+              </a:lnSpc>
+              <a:buFont typeface="Wingdings" pitchFamily="2" charset="2"/>
+              <a:buChar char="Ø"/>
             </a:pPr>
             <a:r>
               <a:rPr lang="en-US" sz="2000" spc="-25" dirty="0">
@@ -5484,38 +7022,8 @@
                 </a:solidFill>
                 <a:cs typeface="OAGDQN+FranklinGothic-BookItalic"/>
               </a:rPr>
-              <a:t>Adherence wasn’t meaningful</a:t>
-            </a:r>
-          </a:p>
-          <a:p>
-            <a:pPr marL="342900" indent="-342900">
-              <a:lnSpc>
-                <a:spcPts val="2258"/>
-              </a:lnSpc>
-              <a:buFont typeface="Wingdings" pitchFamily="2" charset="2"/>
-              <a:buChar char="q"/>
-            </a:pPr>
-            <a:endParaRPr lang="en-US" sz="2000" spc="-25" dirty="0">
-              <a:solidFill>
-                <a:srgbClr val="181A0D"/>
-              </a:solidFill>
-              <a:cs typeface="OAGDQN+FranklinGothic-BookItalic"/>
-            </a:endParaRPr>
-          </a:p>
-          <a:p>
-            <a:pPr marL="342900" indent="-342900">
-              <a:lnSpc>
-                <a:spcPts val="2258"/>
-              </a:lnSpc>
-              <a:buFont typeface="Wingdings" pitchFamily="2" charset="2"/>
-              <a:buChar char="q"/>
-            </a:pPr>
-            <a:endParaRPr lang="en-US" sz="2000" spc="-25" dirty="0">
-              <a:solidFill>
-                <a:srgbClr val="181A0D"/>
-              </a:solidFill>
-              <a:cs typeface="OAGDQN+FranklinGothic-BookItalic"/>
-            </a:endParaRPr>
+              <a:t>Hard drug user group was relatively small (36)</a:t>
+            </a:r>
           </a:p>
           <a:p>
             <a:pPr marL="800100" lvl="1" indent="-342900">
@@ -5523,31 +7031,16 @@
                 <a:spcPts val="2258"/>
               </a:lnSpc>
               <a:buFont typeface="Wingdings" pitchFamily="2" charset="2"/>
-              <a:buChar char="q"/>
-            </a:pPr>
-            <a:endParaRPr lang="en-US" sz="2000" spc="-25" dirty="0">
-              <a:solidFill>
-                <a:srgbClr val="181A0D"/>
-              </a:solidFill>
-              <a:cs typeface="OAGDQN+FranklinGothic-BookItalic"/>
-            </a:endParaRPr>
-          </a:p>
-          <a:p>
-            <a:pPr marL="342900" indent="-342900">
-              <a:lnSpc>
-                <a:spcPts val="2258"/>
-              </a:lnSpc>
-              <a:buFont typeface="Wingdings" pitchFamily="2" charset="2"/>
-              <a:buChar char="q"/>
-            </a:pPr>
-            <a:r>
-              <a:rPr lang="en-US" sz="2000" b="1" spc="-25" dirty="0">
+              <a:buChar char="Ø"/>
+            </a:pPr>
+            <a:r>
+              <a:rPr lang="en-US" sz="2000" spc="-25" dirty="0">
                 <a:solidFill>
                   <a:srgbClr val="181A0D"/>
                 </a:solidFill>
                 <a:cs typeface="OAGDQN+FranklinGothic-BookItalic"/>
               </a:rPr>
-              <a:t>Limitations:</a:t>
+              <a:t>SF-36 Scores comparisons are limited</a:t>
             </a:r>
           </a:p>
           <a:p>
@@ -5565,97 +7058,7 @@
                 </a:solidFill>
                 <a:cs typeface="OAGDQN+FranklinGothic-BookItalic"/>
               </a:rPr>
-              <a:t>Observational study design</a:t>
-            </a:r>
-          </a:p>
-          <a:p>
-            <a:pPr marL="800100" lvl="1" indent="-342900">
-              <a:lnSpc>
-                <a:spcPts val="2258"/>
-              </a:lnSpc>
-              <a:buFont typeface="Wingdings" pitchFamily="2" charset="2"/>
-              <a:buChar char="Ø"/>
-            </a:pPr>
-            <a:r>
-              <a:rPr lang="en-US" sz="2000" spc="-25" dirty="0">
-                <a:solidFill>
-                  <a:srgbClr val="181A0D"/>
-                </a:solidFill>
-                <a:cs typeface="OAGDQN+FranklinGothic-BookItalic"/>
-              </a:rPr>
-              <a:t>Adherence coded as binary (&lt;95% vs ≥95%)</a:t>
-            </a:r>
-          </a:p>
-          <a:p>
-            <a:pPr marL="800100" lvl="1" indent="-342900">
-              <a:lnSpc>
-                <a:spcPts val="2258"/>
-              </a:lnSpc>
-              <a:buFont typeface="Wingdings" pitchFamily="2" charset="2"/>
-              <a:buChar char="Ø"/>
-            </a:pPr>
-            <a:r>
-              <a:rPr lang="en-US" sz="2000" spc="-25" dirty="0">
-                <a:solidFill>
-                  <a:srgbClr val="181A0D"/>
-                </a:solidFill>
-                <a:cs typeface="OAGDQN+FranklinGothic-BookItalic"/>
-              </a:rPr>
-              <a:t>Mediation = exploratory </a:t>
-            </a:r>
-          </a:p>
-          <a:p>
-            <a:pPr marL="800100" lvl="1" indent="-342900">
-              <a:lnSpc>
-                <a:spcPts val="2258"/>
-              </a:lnSpc>
-              <a:buFont typeface="Wingdings" pitchFamily="2" charset="2"/>
-              <a:buChar char="Ø"/>
-            </a:pPr>
-            <a:r>
-              <a:rPr lang="en-US" sz="2000" spc="-25" dirty="0">
-                <a:solidFill>
-                  <a:srgbClr val="181A0D"/>
-                </a:solidFill>
-                <a:cs typeface="OAGDQN+FranklinGothic-BookItalic"/>
-              </a:rPr>
-              <a:t>Hard drug user group was relatively small (36)</a:t>
-            </a:r>
-          </a:p>
-          <a:p>
-            <a:pPr marL="800100" lvl="1" indent="-342900">
-              <a:lnSpc>
-                <a:spcPts val="2258"/>
-              </a:lnSpc>
-              <a:buFont typeface="Wingdings" pitchFamily="2" charset="2"/>
-              <a:buChar char="Ø"/>
-            </a:pPr>
-            <a:r>
-              <a:rPr lang="en-US" sz="2000" spc="-25" dirty="0">
-                <a:solidFill>
-                  <a:srgbClr val="181A0D"/>
-                </a:solidFill>
-                <a:cs typeface="OAGDQN+FranklinGothic-BookItalic"/>
-              </a:rPr>
-              <a:t>SF-36 Scores comparisons are limited</a:t>
-            </a:r>
-          </a:p>
-          <a:p>
-            <a:pPr marL="800100" lvl="1" indent="-342900">
-              <a:lnSpc>
-                <a:spcPts val="2258"/>
-              </a:lnSpc>
-              <a:buFont typeface="Wingdings" pitchFamily="2" charset="2"/>
-              <a:buChar char="Ø"/>
-            </a:pPr>
-            <a:r>
-              <a:rPr lang="en-US" sz="2000" spc="-25" dirty="0">
-                <a:solidFill>
-                  <a:srgbClr val="181A0D"/>
-                </a:solidFill>
-                <a:cs typeface="OAGDQN+FranklinGothic-BookItalic"/>
-              </a:rPr>
-              <a:t>Missing data – biases if missingness depended on unobserved events</a:t>
+              <a:t>Missing data suggests MAR but not proven</a:t>
             </a:r>
           </a:p>
           <a:p>

</xml_diff>

<commit_message>
Final edits to report, presentation, and code.
</commit_message>
<xml_diff>
--- a/Project1/Reports/Project1_Presentation_summers.pptx
+++ b/Project1/Reports/Project1_Presentation_summers.pptx
@@ -5,57 +5,56 @@
     <p:sldMasterId id="2147483648" r:id="rId1"/>
   </p:sldMasterIdLst>
   <p:notesMasterIdLst>
-    <p:notesMasterId r:id="rId11"/>
+    <p:notesMasterId r:id="rId10"/>
   </p:notesMasterIdLst>
   <p:sldIdLst>
     <p:sldId id="260" r:id="rId2"/>
-    <p:sldId id="261" r:id="rId3"/>
-    <p:sldId id="268" r:id="rId4"/>
-    <p:sldId id="262" r:id="rId5"/>
-    <p:sldId id="263" r:id="rId6"/>
-    <p:sldId id="264" r:id="rId7"/>
-    <p:sldId id="265" r:id="rId8"/>
-    <p:sldId id="267" r:id="rId9"/>
-    <p:sldId id="266" r:id="rId10"/>
+    <p:sldId id="268" r:id="rId3"/>
+    <p:sldId id="262" r:id="rId4"/>
+    <p:sldId id="263" r:id="rId5"/>
+    <p:sldId id="264" r:id="rId6"/>
+    <p:sldId id="265" r:id="rId7"/>
+    <p:sldId id="267" r:id="rId8"/>
+    <p:sldId id="266" r:id="rId9"/>
   </p:sldIdLst>
   <p:sldSz cx="12192000" cy="6858000"/>
   <p:notesSz cx="12192000" cy="6858000"/>
   <p:embeddedFontLst>
     <p:embeddedFont>
       <p:font typeface="Cambria Math" panose="02040503050406030204" pitchFamily="18" charset="0"/>
+      <p:regular r:id="rId11"/>
+    </p:embeddedFont>
+    <p:embeddedFont>
+      <p:font typeface="GEHAIV+FranklinGothic-Book" panose="02000500000000000000" pitchFamily="2" charset="0"/>
       <p:regular r:id="rId12"/>
     </p:embeddedFont>
     <p:embeddedFont>
-      <p:font typeface="GEHAIV+FranklinGothic-Book" panose="02000500000000000000" pitchFamily="2" charset="0"/>
+      <p:font typeface="KDMFEK+FranklinGothic-Book" panose="02000500000000000000" pitchFamily="2" charset="0"/>
       <p:regular r:id="rId13"/>
     </p:embeddedFont>
     <p:embeddedFont>
-      <p:font typeface="KDMFEK+FranklinGothic-Book" panose="02000500000000000000" pitchFamily="2" charset="0"/>
+      <p:font typeface="LVLFDH+FranklinGothic-Book" panose="02000500000000000000" pitchFamily="2" charset="0"/>
       <p:regular r:id="rId14"/>
     </p:embeddedFont>
     <p:embeddedFont>
-      <p:font typeface="LVLFDH+FranklinGothic-Book" panose="02000500000000000000" pitchFamily="2" charset="0"/>
+      <p:font typeface="MPIRPG+FranklinGothic-Book" panose="02000500000000000000" pitchFamily="2" charset="0"/>
       <p:regular r:id="rId15"/>
     </p:embeddedFont>
     <p:embeddedFont>
-      <p:font typeface="MPIRPG+FranklinGothic-Book" panose="02000500000000000000" pitchFamily="2" charset="0"/>
+      <p:font typeface="NOOILK+FranklinGothic-Book" panose="02000500000000000000" pitchFamily="2" charset="0"/>
       <p:regular r:id="rId16"/>
     </p:embeddedFont>
     <p:embeddedFont>
-      <p:font typeface="NOOILK+FranklinGothic-Book" panose="02000500000000000000" pitchFamily="2" charset="0"/>
+      <p:font typeface="OAGDQN+FranklinGothic-BookItalic" panose="02000500000000000000" pitchFamily="2" charset="0"/>
       <p:regular r:id="rId17"/>
     </p:embeddedFont>
     <p:embeddedFont>
-      <p:font typeface="OAGDQN+FranklinGothic-BookItalic" panose="02000500000000000000" pitchFamily="2" charset="0"/>
+      <p:font typeface="VTCKGD+FranklinGothic-Book" panose="02000500000000000000" pitchFamily="2" charset="0"/>
       <p:regular r:id="rId18"/>
     </p:embeddedFont>
     <p:embeddedFont>
-      <p:font typeface="VTCKGD+FranklinGothic-Book" panose="02000500000000000000" pitchFamily="2" charset="0"/>
+      <p:font typeface="WPQCJM+FranklinGothic-Book" panose="02000500000000000000" pitchFamily="2" charset="0"/>
       <p:regular r:id="rId19"/>
-    </p:embeddedFont>
-    <p:embeddedFont>
-      <p:font typeface="WPQCJM+FranklinGothic-Book" panose="02000500000000000000" pitchFamily="2" charset="0"/>
-      <p:regular r:id="rId20"/>
     </p:embeddedFont>
   </p:embeddedFontLst>
   <p:defaultTextStyle>
@@ -627,238 +626,6 @@
   <p:cSld>
     <p:spTree>
       <p:nvGrpSpPr>
-        <p:cNvPr id="1" name=""/>
-        <p:cNvGrpSpPr/>
-        <p:nvPr/>
-      </p:nvGrpSpPr>
-      <p:grpSpPr>
-        <a:xfrm>
-          <a:off x="0" y="0"/>
-          <a:ext cx="0" cy="0"/>
-          <a:chOff x="0" y="0"/>
-          <a:chExt cx="0" cy="0"/>
-        </a:xfrm>
-      </p:grpSpPr>
-      <p:sp>
-        <p:nvSpPr>
-          <p:cNvPr id="2" name="Slide Image Placeholder 1"/>
-          <p:cNvSpPr>
-            <a:spLocks noGrp="1" noRot="1" noChangeAspect="1"/>
-          </p:cNvSpPr>
-          <p:nvPr>
-            <p:ph type="sldImg"/>
-          </p:nvPr>
-        </p:nvSpPr>
-        <p:spPr/>
-      </p:sp>
-      <p:sp>
-        <p:nvSpPr>
-          <p:cNvPr id="3" name="Notes Placeholder 2"/>
-          <p:cNvSpPr>
-            <a:spLocks noGrp="1"/>
-          </p:cNvSpPr>
-          <p:nvPr>
-            <p:ph type="body" idx="1"/>
-          </p:nvPr>
-        </p:nvSpPr>
-        <p:spPr/>
-        <p:txBody>
-          <a:bodyPr/>
-          <a:lstStyle/>
-          <a:p>
-            <a:r>
-              <a:rPr lang="en-US" sz="1200" kern="1200" dirty="0">
-                <a:solidFill>
-                  <a:schemeClr val="tx1"/>
-                </a:solidFill>
-                <a:effectLst/>
-                <a:latin typeface="+mn-lt"/>
-                <a:ea typeface="+mn-ea"/>
-                <a:cs typeface="+mn-cs"/>
-              </a:rPr>
-              <a:t>The primary objective of this project was to determine whether baseline hard drug use was associated with differences in treatment response two years after initiating HAART.</a:t>
-            </a:r>
-          </a:p>
-          <a:p>
-            <a:endParaRPr lang="en-US" sz="1200" kern="1200" dirty="0">
-              <a:solidFill>
-                <a:schemeClr val="tx1"/>
-              </a:solidFill>
-              <a:effectLst/>
-              <a:latin typeface="+mn-lt"/>
-              <a:ea typeface="+mn-ea"/>
-              <a:cs typeface="+mn-cs"/>
-            </a:endParaRPr>
-          </a:p>
-          <a:p>
-            <a:r>
-              <a:rPr lang="en-US" sz="1200" kern="1200" dirty="0">
-                <a:solidFill>
-                  <a:schemeClr val="tx1"/>
-                </a:solidFill>
-                <a:effectLst/>
-                <a:latin typeface="+mn-lt"/>
-                <a:ea typeface="+mn-ea"/>
-                <a:cs typeface="+mn-cs"/>
-              </a:rPr>
-              <a:t>First question is addressing whether there will be decrease in viral load and an increase in CD4 counts at year-2 check up.</a:t>
-            </a:r>
-          </a:p>
-          <a:p>
-            <a:pPr marL="171450" indent="-171450">
-              <a:buFont typeface="Arial" panose="020B0604020202020204" pitchFamily="34" charset="0"/>
-              <a:buChar char="•"/>
-            </a:pPr>
-            <a:r>
-              <a:rPr lang="en-US" sz="1200" kern="1200" dirty="0">
-                <a:solidFill>
-                  <a:schemeClr val="tx1"/>
-                </a:solidFill>
-                <a:effectLst/>
-                <a:latin typeface="+mn-lt"/>
-                <a:ea typeface="+mn-ea"/>
-                <a:cs typeface="+mn-cs"/>
-              </a:rPr>
-              <a:t>Its hypothesized that Year 2 viral load will be higher among hard drug users as compared to non-users and CD4 counts lower</a:t>
-            </a:r>
-          </a:p>
-          <a:p>
-            <a:br>
-              <a:rPr lang="en-US" sz="1200" kern="1200" dirty="0">
-                <a:solidFill>
-                  <a:schemeClr val="tx1"/>
-                </a:solidFill>
-                <a:effectLst/>
-                <a:latin typeface="+mn-lt"/>
-                <a:ea typeface="+mn-ea"/>
-                <a:cs typeface="+mn-cs"/>
-              </a:rPr>
-            </a:br>
-            <a:r>
-              <a:rPr lang="en-US" sz="1200" kern="1200" dirty="0">
-                <a:solidFill>
-                  <a:schemeClr val="tx1"/>
-                </a:solidFill>
-                <a:effectLst/>
-                <a:latin typeface="+mn-lt"/>
-                <a:ea typeface="+mn-ea"/>
-                <a:cs typeface="+mn-cs"/>
-              </a:rPr>
-              <a:t>Second question is looking at physical and mental QOL metrics.</a:t>
-            </a:r>
-          </a:p>
-          <a:p>
-            <a:pPr marL="171450" indent="-171450">
-              <a:buFont typeface="Arial" panose="020B0604020202020204" pitchFamily="34" charset="0"/>
-              <a:buChar char="•"/>
-            </a:pPr>
-            <a:r>
-              <a:rPr lang="en-US" sz="1200" kern="1200" dirty="0">
-                <a:solidFill>
-                  <a:schemeClr val="tx1"/>
-                </a:solidFill>
-                <a:effectLst/>
-                <a:latin typeface="+mn-lt"/>
-                <a:ea typeface="+mn-ea"/>
-                <a:cs typeface="+mn-cs"/>
-              </a:rPr>
-              <a:t>Hypothesis is addressing any differences between hard drug users and non-users</a:t>
-            </a:r>
-          </a:p>
-          <a:p>
-            <a:br>
-              <a:rPr lang="en-US" sz="1200" kern="1200" dirty="0">
-                <a:solidFill>
-                  <a:schemeClr val="tx1"/>
-                </a:solidFill>
-                <a:effectLst/>
-                <a:latin typeface="+mn-lt"/>
-                <a:ea typeface="+mn-ea"/>
-                <a:cs typeface="+mn-cs"/>
-              </a:rPr>
-            </a:br>
-            <a:r>
-              <a:rPr lang="en-US" sz="1200" kern="1200" dirty="0">
-                <a:solidFill>
-                  <a:schemeClr val="tx1"/>
-                </a:solidFill>
-                <a:effectLst/>
-                <a:latin typeface="+mn-lt"/>
-                <a:ea typeface="+mn-ea"/>
-                <a:cs typeface="+mn-cs"/>
-              </a:rPr>
-              <a:t>Third question is determining adherence mediates the association between hard drug use and year-2 outcomes</a:t>
-            </a:r>
-          </a:p>
-          <a:p>
-            <a:endParaRPr lang="en-US" sz="1200" kern="1200" dirty="0">
-              <a:solidFill>
-                <a:schemeClr val="tx1"/>
-              </a:solidFill>
-              <a:effectLst/>
-              <a:latin typeface="+mn-lt"/>
-              <a:ea typeface="+mn-ea"/>
-              <a:cs typeface="+mn-cs"/>
-            </a:endParaRPr>
-          </a:p>
-          <a:p>
-            <a:r>
-              <a:rPr lang="en-US" sz="1200" kern="1200" dirty="0">
-                <a:solidFill>
-                  <a:schemeClr val="tx1"/>
-                </a:solidFill>
-                <a:effectLst/>
-                <a:latin typeface="+mn-lt"/>
-                <a:ea typeface="+mn-ea"/>
-                <a:cs typeface="+mn-cs"/>
-              </a:rPr>
-              <a:t>Lastly, we are determining if there is a difference in drop out rates between users and non-users</a:t>
-            </a:r>
-            <a:endParaRPr lang="en-US" dirty="0"/>
-          </a:p>
-        </p:txBody>
-      </p:sp>
-      <p:sp>
-        <p:nvSpPr>
-          <p:cNvPr id="4" name="Slide Number Placeholder 3"/>
-          <p:cNvSpPr>
-            <a:spLocks noGrp="1"/>
-          </p:cNvSpPr>
-          <p:nvPr>
-            <p:ph type="sldNum" sz="quarter" idx="5"/>
-          </p:nvPr>
-        </p:nvSpPr>
-        <p:spPr/>
-        <p:txBody>
-          <a:bodyPr/>
-          <a:lstStyle/>
-          <a:p>
-            <a:fld id="{8055A014-AA40-5B4A-A5FD-4F58A1D7AE4A}" type="slidenum">
-              <a:rPr lang="en-US" smtClean="0"/>
-              <a:t>2</a:t>
-            </a:fld>
-            <a:endParaRPr lang="en-US"/>
-          </a:p>
-        </p:txBody>
-      </p:sp>
-    </p:spTree>
-    <p:extLst>
-      <p:ext uri="{BB962C8B-B14F-4D97-AF65-F5344CB8AC3E}">
-        <p14:creationId xmlns:p14="http://schemas.microsoft.com/office/powerpoint/2010/main" val="2469612651"/>
-      </p:ext>
-    </p:extLst>
-  </p:cSld>
-  <p:clrMapOvr>
-    <a:masterClrMapping/>
-  </p:clrMapOvr>
-</p:notes>
-</file>
-
-<file path=ppt/notesSlides/notesSlide3.xml><?xml version="1.0" encoding="utf-8"?>
-<p:notes xmlns:a="http://schemas.openxmlformats.org/drawingml/2006/main" xmlns:r="http://schemas.openxmlformats.org/officeDocument/2006/relationships" xmlns:p="http://schemas.openxmlformats.org/presentationml/2006/main">
-  <p:cSld>
-    <p:spTree>
-      <p:nvGrpSpPr>
         <p:cNvPr id="1" name="">
           <a:extLst>
             <a:ext uri="{FF2B5EF4-FFF2-40B4-BE49-F238E27FC236}">
@@ -943,10 +710,27 @@
                 <a:ea typeface="+mn-ea"/>
                 <a:cs typeface="+mn-cs"/>
               </a:rPr>
-              <a:t>The primary research question was whether baseline hard drug use was associated with differences in treatment response two years after initiating HAART</a:t>
-            </a:r>
-          </a:p>
-          <a:p>
+              <a:t>The primary objective of this project was to determine whether baseline hard drug use was associated with differences in treatment response two years after initiating HAART</a:t>
+            </a:r>
+          </a:p>
+          <a:p>
+            <a:pPr marL="0" marR="0" lvl="0" indent="0" algn="l" defTabSz="914400" rtl="0" eaLnBrk="1" fontAlgn="auto" latinLnBrk="0" hangingPunct="1">
+              <a:lnSpc>
+                <a:spcPct val="100000"/>
+              </a:lnSpc>
+              <a:spcBef>
+                <a:spcPts val="0"/>
+              </a:spcBef>
+              <a:spcAft>
+                <a:spcPts val="0"/>
+              </a:spcAft>
+              <a:buClrTx/>
+              <a:buSzTx/>
+              <a:buFontTx/>
+              <a:buNone/>
+              <a:tabLst/>
+              <a:defRPr/>
+            </a:pPr>
             <a:endParaRPr lang="en-US" sz="1200" kern="1200" dirty="0">
               <a:solidFill>
                 <a:schemeClr val="tx1"/>
@@ -958,6 +742,23 @@
             </a:endParaRPr>
           </a:p>
           <a:p>
+            <a:pPr marL="0" marR="0" lvl="0" indent="0" algn="l" defTabSz="914400" rtl="0" eaLnBrk="1" fontAlgn="auto" latinLnBrk="0" hangingPunct="1">
+              <a:lnSpc>
+                <a:spcPct val="100000"/>
+              </a:lnSpc>
+              <a:spcBef>
+                <a:spcPts val="0"/>
+              </a:spcBef>
+              <a:spcAft>
+                <a:spcPts val="0"/>
+              </a:spcAft>
+              <a:buClrTx/>
+              <a:buSzTx/>
+              <a:buFontTx/>
+              <a:buNone/>
+              <a:tabLst/>
+              <a:defRPr/>
+            </a:pPr>
             <a:r>
               <a:rPr lang="en-US" sz="1200" kern="1200" dirty="0">
                 <a:solidFill>
@@ -968,7 +769,7 @@
                 <a:ea typeface="+mn-ea"/>
                 <a:cs typeface="+mn-cs"/>
               </a:rPr>
-              <a:t>Secondary objectives are to test whether adherence mediates the association between hard drug use and year-2 outcomes </a:t>
+              <a:t>The treatment responses being evaluated are: viral load, CD4 count, physical quality of life, and mental quality of life.</a:t>
             </a:r>
           </a:p>
           <a:p>
@@ -993,7 +794,32 @@
                 <a:ea typeface="+mn-ea"/>
                 <a:cs typeface="+mn-cs"/>
               </a:rPr>
-              <a:t>And to evaluate whether dropout rates differ between hard drug users and non-user</a:t>
+              <a:t>Secondary objectives are to test whether adherence mediates the association between hard drug use and year-2 outcomes </a:t>
+            </a:r>
+          </a:p>
+          <a:p>
+            <a:endParaRPr lang="en-US" sz="1200" kern="1200" dirty="0">
+              <a:solidFill>
+                <a:schemeClr val="tx1"/>
+              </a:solidFill>
+              <a:effectLst/>
+              <a:latin typeface="+mn-lt"/>
+              <a:ea typeface="+mn-ea"/>
+              <a:cs typeface="+mn-cs"/>
+            </a:endParaRPr>
+          </a:p>
+          <a:p>
+            <a:r>
+              <a:rPr lang="en-US" sz="1200" kern="1200" dirty="0">
+                <a:solidFill>
+                  <a:schemeClr val="tx1"/>
+                </a:solidFill>
+                <a:effectLst/>
+                <a:latin typeface="+mn-lt"/>
+                <a:ea typeface="+mn-ea"/>
+                <a:cs typeface="+mn-cs"/>
+              </a:rPr>
+              <a:t>And to evaluate whether there's differences in baseline outcome measures between participants with complete and incomplete data, stratified by drug use.</a:t>
             </a:r>
           </a:p>
           <a:p>
@@ -1035,7 +861,7 @@
           <a:p>
             <a:fld id="{8055A014-AA40-5B4A-A5FD-4F58A1D7AE4A}" type="slidenum">
               <a:rPr lang="en-US" smtClean="0"/>
-              <a:t>3</a:t>
+              <a:t>2</a:t>
             </a:fld>
             <a:endParaRPr lang="en-US"/>
           </a:p>
@@ -1045,6 +871,238 @@
     <p:extLst>
       <p:ext uri="{BB962C8B-B14F-4D97-AF65-F5344CB8AC3E}">
         <p14:creationId xmlns:p14="http://schemas.microsoft.com/office/powerpoint/2010/main" val="1415825667"/>
+      </p:ext>
+    </p:extLst>
+  </p:cSld>
+  <p:clrMapOvr>
+    <a:masterClrMapping/>
+  </p:clrMapOvr>
+</p:notes>
+</file>
+
+<file path=ppt/notesSlides/notesSlide3.xml><?xml version="1.0" encoding="utf-8"?>
+<p:notes xmlns:a="http://schemas.openxmlformats.org/drawingml/2006/main" xmlns:r="http://schemas.openxmlformats.org/officeDocument/2006/relationships" xmlns:p="http://schemas.openxmlformats.org/presentationml/2006/main">
+  <p:cSld>
+    <p:spTree>
+      <p:nvGrpSpPr>
+        <p:cNvPr id="1" name=""/>
+        <p:cNvGrpSpPr/>
+        <p:nvPr/>
+      </p:nvGrpSpPr>
+      <p:grpSpPr>
+        <a:xfrm>
+          <a:off x="0" y="0"/>
+          <a:ext cx="0" cy="0"/>
+          <a:chOff x="0" y="0"/>
+          <a:chExt cx="0" cy="0"/>
+        </a:xfrm>
+      </p:grpSpPr>
+      <p:sp>
+        <p:nvSpPr>
+          <p:cNvPr id="2" name="Slide Image Placeholder 1"/>
+          <p:cNvSpPr>
+            <a:spLocks noGrp="1" noRot="1" noChangeAspect="1"/>
+          </p:cNvSpPr>
+          <p:nvPr>
+            <p:ph type="sldImg"/>
+          </p:nvPr>
+        </p:nvSpPr>
+        <p:spPr/>
+      </p:sp>
+      <p:sp>
+        <p:nvSpPr>
+          <p:cNvPr id="3" name="Notes Placeholder 2"/>
+          <p:cNvSpPr>
+            <a:spLocks noGrp="1"/>
+          </p:cNvSpPr>
+          <p:nvPr>
+            <p:ph type="body" idx="1"/>
+          </p:nvPr>
+        </p:nvSpPr>
+        <p:spPr/>
+        <p:txBody>
+          <a:bodyPr/>
+          <a:lstStyle/>
+          <a:p>
+            <a:r>
+              <a:rPr lang="en-US" sz="1200" kern="1200" dirty="0">
+                <a:solidFill>
+                  <a:schemeClr val="tx1"/>
+                </a:solidFill>
+                <a:effectLst/>
+                <a:latin typeface="+mn-lt"/>
+                <a:ea typeface="+mn-ea"/>
+                <a:cs typeface="+mn-cs"/>
+              </a:rPr>
+              <a:t>The initial dataset contained 715 HIV-infected men initiating HAART from the MAC study.</a:t>
+            </a:r>
+          </a:p>
+          <a:p>
+            <a:br>
+              <a:rPr lang="en-US" sz="1200" kern="1200" dirty="0">
+                <a:solidFill>
+                  <a:schemeClr val="tx1"/>
+                </a:solidFill>
+                <a:effectLst/>
+                <a:latin typeface="+mn-lt"/>
+                <a:ea typeface="+mn-ea"/>
+                <a:cs typeface="+mn-cs"/>
+              </a:rPr>
+            </a:br>
+            <a:r>
+              <a:rPr lang="en-US" sz="1200" kern="1200" dirty="0">
+                <a:solidFill>
+                  <a:schemeClr val="tx1"/>
+                </a:solidFill>
+                <a:effectLst/>
+                <a:latin typeface="+mn-lt"/>
+                <a:ea typeface="+mn-ea"/>
+                <a:cs typeface="+mn-cs"/>
+              </a:rPr>
+              <a:t>Of these, 463 had complete baseline and Year 2 data and these subjects were included in all regression analyses.</a:t>
+            </a:r>
+          </a:p>
+          <a:p>
+            <a:br>
+              <a:rPr lang="en-US" sz="1200" kern="1200" dirty="0">
+                <a:solidFill>
+                  <a:schemeClr val="tx1"/>
+                </a:solidFill>
+                <a:effectLst/>
+                <a:latin typeface="+mn-lt"/>
+                <a:ea typeface="+mn-ea"/>
+                <a:cs typeface="+mn-cs"/>
+              </a:rPr>
+            </a:br>
+            <a:r>
+              <a:rPr lang="en-US" sz="1200" kern="1200" dirty="0">
+                <a:solidFill>
+                  <a:schemeClr val="tx1"/>
+                </a:solidFill>
+                <a:effectLst/>
+                <a:latin typeface="+mn-lt"/>
+                <a:ea typeface="+mn-ea"/>
+                <a:cs typeface="+mn-cs"/>
+              </a:rPr>
+              <a:t>Viral load was log10-transformed due to skewness, while CD4 and QOL measures were analyzed on their original scales.</a:t>
+            </a:r>
+          </a:p>
+          <a:p>
+            <a:br>
+              <a:rPr lang="en-US" sz="1200" kern="1200" dirty="0">
+                <a:solidFill>
+                  <a:schemeClr val="tx1"/>
+                </a:solidFill>
+                <a:effectLst/>
+                <a:latin typeface="+mn-lt"/>
+                <a:ea typeface="+mn-ea"/>
+                <a:cs typeface="+mn-cs"/>
+              </a:rPr>
+            </a:br>
+            <a:r>
+              <a:rPr lang="en-US" sz="1200" kern="1200" dirty="0">
+                <a:solidFill>
+                  <a:schemeClr val="tx1"/>
+                </a:solidFill>
+                <a:effectLst/>
+                <a:latin typeface="+mn-lt"/>
+                <a:ea typeface="+mn-ea"/>
+                <a:cs typeface="+mn-cs"/>
+              </a:rPr>
+              <a:t>Hard drug use and adherence were both coded as binary variables.</a:t>
+            </a:r>
+          </a:p>
+          <a:p>
+            <a:pPr marL="171450" indent="-171450">
+              <a:buFont typeface="Arial" panose="020B0604020202020204" pitchFamily="34" charset="0"/>
+              <a:buChar char="•"/>
+            </a:pPr>
+            <a:r>
+              <a:rPr lang="en-US" sz="1200" kern="1200" dirty="0">
+                <a:solidFill>
+                  <a:schemeClr val="tx1"/>
+                </a:solidFill>
+                <a:effectLst/>
+                <a:latin typeface="+mn-lt"/>
+                <a:ea typeface="+mn-ea"/>
+                <a:cs typeface="+mn-cs"/>
+              </a:rPr>
+              <a:t>All but one of the hard drug users had adherence below 95%</a:t>
+            </a:r>
+          </a:p>
+          <a:p>
+            <a:br>
+              <a:rPr lang="en-US" sz="1200" kern="1200" dirty="0">
+                <a:solidFill>
+                  <a:schemeClr val="tx1"/>
+                </a:solidFill>
+                <a:effectLst/>
+                <a:latin typeface="+mn-lt"/>
+                <a:ea typeface="+mn-ea"/>
+                <a:cs typeface="+mn-cs"/>
+              </a:rPr>
+            </a:br>
+            <a:r>
+              <a:rPr lang="en-US" sz="1200" kern="1200" dirty="0">
+                <a:solidFill>
+                  <a:schemeClr val="tx1"/>
+                </a:solidFill>
+                <a:effectLst/>
+                <a:latin typeface="+mn-lt"/>
+                <a:ea typeface="+mn-ea"/>
+                <a:cs typeface="+mn-cs"/>
+              </a:rPr>
+              <a:t>Generally, Baseline hard drug users reported lower QOL scores and CD4 counts and were more likely to be current smokers as compared to non-users</a:t>
+            </a:r>
+          </a:p>
+          <a:p>
+            <a:pPr marL="171450" indent="-171450">
+              <a:buFont typeface="Arial" panose="020B0604020202020204" pitchFamily="34" charset="0"/>
+              <a:buChar char="•"/>
+            </a:pPr>
+            <a:r>
+              <a:rPr lang="en-US" sz="1200" kern="1200" dirty="0">
+                <a:solidFill>
+                  <a:schemeClr val="tx1"/>
+                </a:solidFill>
+                <a:effectLst/>
+                <a:latin typeface="+mn-lt"/>
+                <a:ea typeface="+mn-ea"/>
+                <a:cs typeface="+mn-cs"/>
+              </a:rPr>
+              <a:t>Viral load and other covariates had similar distributions </a:t>
+            </a:r>
+            <a:endParaRPr lang="en-US" dirty="0"/>
+          </a:p>
+        </p:txBody>
+      </p:sp>
+      <p:sp>
+        <p:nvSpPr>
+          <p:cNvPr id="4" name="Slide Number Placeholder 3"/>
+          <p:cNvSpPr>
+            <a:spLocks noGrp="1"/>
+          </p:cNvSpPr>
+          <p:nvPr>
+            <p:ph type="sldNum" sz="quarter" idx="5"/>
+          </p:nvPr>
+        </p:nvSpPr>
+        <p:spPr/>
+        <p:txBody>
+          <a:bodyPr/>
+          <a:lstStyle/>
+          <a:p>
+            <a:fld id="{8055A014-AA40-5B4A-A5FD-4F58A1D7AE4A}" type="slidenum">
+              <a:rPr lang="en-US" smtClean="0"/>
+              <a:t>3</a:t>
+            </a:fld>
+            <a:endParaRPr lang="en-US"/>
+          </a:p>
+        </p:txBody>
+      </p:sp>
+    </p:spTree>
+    <p:extLst>
+      <p:ext uri="{BB962C8B-B14F-4D97-AF65-F5344CB8AC3E}">
+        <p14:creationId xmlns:p14="http://schemas.microsoft.com/office/powerpoint/2010/main" val="774045196"/>
       </p:ext>
     </p:extLst>
   </p:cSld>
@@ -1108,7 +1166,7 @@
                 <a:ea typeface="+mn-ea"/>
                 <a:cs typeface="+mn-cs"/>
               </a:rPr>
-              <a:t>The initial dataset contained 715 HIV-infected men initiating HAART from the MAC study.</a:t>
+              <a:t>To address the primary question of interest, Bayesian regression models was fit using weakly-informative priors for each outcome</a:t>
             </a:r>
           </a:p>
           <a:p>
@@ -1133,7 +1191,7 @@
                 <a:ea typeface="+mn-ea"/>
                 <a:cs typeface="+mn-cs"/>
               </a:rPr>
-              <a:t>Of these, 463 had complete baseline and Year 2 data and were included in all regression analyses.</a:t>
+              <a:t>All models adjusted for the corresponding baseline outcome measure and covariates</a:t>
             </a:r>
           </a:p>
           <a:p>
@@ -1158,7 +1216,7 @@
                 <a:ea typeface="+mn-ea"/>
                 <a:cs typeface="+mn-cs"/>
               </a:rPr>
-              <a:t>Viral load was log10-transformed due to skewness, while CD4 and QOL measures were analyzed on their original scales.</a:t>
+              <a:t>parallel frequentist models were also fit with identical covariate structure for comparison.</a:t>
             </a:r>
           </a:p>
           <a:p>
@@ -1183,14 +1241,10 @@
                 <a:ea typeface="+mn-ea"/>
                 <a:cs typeface="+mn-cs"/>
               </a:rPr>
-              <a:t>Hard drug use and adherence were both coded as binary variables.</a:t>
-            </a:r>
-          </a:p>
-          <a:p>
-            <a:pPr marL="171450" indent="-171450">
-              <a:buFont typeface="Arial" panose="020B0604020202020204" pitchFamily="34" charset="0"/>
-              <a:buChar char="•"/>
-            </a:pPr>
+              <a:t>For adherence, the variable was dichotomized into less than 95% and greater than/equal to 95%</a:t>
+            </a:r>
+          </a:p>
+          <a:p>
             <a:r>
               <a:rPr lang="en-US" sz="1200" kern="1200" dirty="0">
                 <a:solidFill>
@@ -1201,7 +1255,7 @@
                 <a:ea typeface="+mn-ea"/>
                 <a:cs typeface="+mn-cs"/>
               </a:rPr>
-              <a:t>All but one of the hard drug users had adherence below 95%</a:t>
+              <a:t>Models were compared with and without adherence to see whether there was a meaningfully change in the estimated hard drug association.</a:t>
             </a:r>
           </a:p>
           <a:p>
@@ -1226,10 +1280,23 @@
                 <a:ea typeface="+mn-ea"/>
                 <a:cs typeface="+mn-cs"/>
               </a:rPr>
-              <a:t>At Baseline hard drug users reported lower physical and mental QOL scores and lower CD4 counts compared with non-users. Viral load and other </a:t>
-            </a:r>
-            <a:r>
-              <a:rPr lang="en-US" sz="1200" kern="1200" dirty="0" err="1">
+              <a:t>For analyzing drop-out rates, comparisons of baseline outcomes were made between participants with complete measurements and those missing year-2 using non-parametric Wilcoxon test</a:t>
+            </a:r>
+          </a:p>
+          <a:p>
+            <a:endParaRPr lang="en-US" sz="1200" kern="1200" dirty="0">
+              <a:solidFill>
+                <a:schemeClr val="tx1"/>
+              </a:solidFill>
+              <a:effectLst/>
+              <a:latin typeface="+mn-lt"/>
+              <a:ea typeface="+mn-ea"/>
+              <a:cs typeface="+mn-cs"/>
+            </a:endParaRPr>
+          </a:p>
+          <a:p>
+            <a:r>
+              <a:rPr lang="en-US" sz="1200" kern="1200" dirty="0">
                 <a:solidFill>
                   <a:schemeClr val="tx1"/>
                 </a:solidFill>
@@ -1238,25 +1305,7 @@
                 <a:ea typeface="+mn-ea"/>
                 <a:cs typeface="+mn-cs"/>
               </a:rPr>
-              <a:t>covriate</a:t>
-            </a:r>
-            <a:r>
-              <a:rPr lang="en-US" sz="1200" kern="1200" dirty="0">
-                <a:solidFill>
-                  <a:schemeClr val="tx1"/>
-                </a:solidFill>
-                <a:effectLst/>
-                <a:latin typeface="+mn-lt"/>
-                <a:ea typeface="+mn-ea"/>
-                <a:cs typeface="+mn-cs"/>
-              </a:rPr>
-              <a:t> distributions were similar between groups.</a:t>
-            </a:r>
-            <a:r>
-              <a:rPr lang="en-US" dirty="0">
-                <a:effectLst/>
-              </a:rPr>
-              <a:t> </a:t>
+              <a:t>I also fit a logistic regression model using baseline outcome and covariate measures as potential predictors of dropout</a:t>
             </a:r>
             <a:endParaRPr lang="en-US" dirty="0"/>
           </a:p>
@@ -1288,7 +1337,7 @@
     </p:spTree>
     <p:extLst>
       <p:ext uri="{BB962C8B-B14F-4D97-AF65-F5344CB8AC3E}">
-        <p14:creationId xmlns:p14="http://schemas.microsoft.com/office/powerpoint/2010/main" val="774045196"/>
+        <p14:creationId xmlns:p14="http://schemas.microsoft.com/office/powerpoint/2010/main" val="1144915537"/>
       </p:ext>
     </p:extLst>
   </p:cSld>
@@ -1352,11 +1401,22 @@
                 <a:ea typeface="+mn-ea"/>
                 <a:cs typeface="+mn-cs"/>
               </a:rPr>
-              <a:t>First, to assess treatment response at Year 2, Bayesian regression was fitted using weakly-informative priors for each outcome</a:t>
-            </a:r>
-          </a:p>
-          <a:p>
-            <a:br>
+              <a:t>For primary results: </a:t>
+            </a:r>
+          </a:p>
+          <a:p>
+            <a:endParaRPr lang="en-US" sz="1200" kern="1200" dirty="0">
+              <a:solidFill>
+                <a:schemeClr val="tx1"/>
+              </a:solidFill>
+              <a:effectLst/>
+              <a:latin typeface="+mn-lt"/>
+              <a:ea typeface="+mn-ea"/>
+              <a:cs typeface="+mn-cs"/>
+            </a:endParaRPr>
+          </a:p>
+          <a:p>
+            <a:r>
               <a:rPr lang="en-US" sz="1200" kern="1200" dirty="0">
                 <a:solidFill>
                   <a:schemeClr val="tx1"/>
@@ -1366,8 +1426,11 @@
                 <a:ea typeface="+mn-ea"/>
                 <a:cs typeface="+mn-cs"/>
               </a:rPr>
-            </a:br>
-            <a:r>
+              <a:t>On average, hard drug users had approximately 164 fewer CD4 cell counts as compared with non-users with a </a:t>
+            </a:r>
+          </a:p>
+          <a:p>
+            <a:br>
               <a:rPr lang="en-US" sz="1200" kern="1200" dirty="0">
                 <a:solidFill>
                   <a:schemeClr val="tx1"/>
@@ -1377,11 +1440,8 @@
                 <a:ea typeface="+mn-ea"/>
                 <a:cs typeface="+mn-cs"/>
               </a:rPr>
-              <a:t>All models adjusted for the corresponding baseline outcome value and covariates</a:t>
-            </a:r>
-          </a:p>
-          <a:p>
-            <a:br>
+            </a:br>
+            <a:r>
               <a:rPr lang="en-US" sz="1200" kern="1200" dirty="0">
                 <a:solidFill>
                   <a:schemeClr val="tx1"/>
@@ -1391,8 +1451,11 @@
                 <a:ea typeface="+mn-ea"/>
                 <a:cs typeface="+mn-cs"/>
               </a:rPr>
-            </a:br>
-            <a:r>
+              <a:t>Posterior probability of 99.5% that this difference exceeded the clinically meaningful threshold of 50 cells</a:t>
+            </a:r>
+          </a:p>
+          <a:p>
+            <a:br>
               <a:rPr lang="en-US" sz="1200" kern="1200" dirty="0">
                 <a:solidFill>
                   <a:schemeClr val="tx1"/>
@@ -1402,11 +1465,8 @@
                 <a:ea typeface="+mn-ea"/>
                 <a:cs typeface="+mn-cs"/>
               </a:rPr>
-              <a:t>parallel frequentist models with identical covariate structure was also fit for comparison.</a:t>
-            </a:r>
-          </a:p>
-          <a:p>
-            <a:br>
+            </a:br>
+            <a:r>
               <a:rPr lang="en-US" sz="1200" kern="1200" dirty="0">
                 <a:solidFill>
                   <a:schemeClr val="tx1"/>
@@ -1416,8 +1476,11 @@
                 <a:ea typeface="+mn-ea"/>
                 <a:cs typeface="+mn-cs"/>
               </a:rPr>
-            </a:br>
-            <a:r>
+              <a:t>Physical QOL was also lower among hard drug users by approximately 3.3 points, and had a posterior probability of 83% that the difference exceeded the clinical threshold of 2 points</a:t>
+            </a:r>
+          </a:p>
+          <a:p>
+            <a:br>
               <a:rPr lang="en-US" sz="1200" kern="1200" dirty="0">
                 <a:solidFill>
                   <a:schemeClr val="tx1"/>
@@ -1427,10 +1490,7 @@
                 <a:ea typeface="+mn-ea"/>
                 <a:cs typeface="+mn-cs"/>
               </a:rPr>
-              <a:t>For adherence, the variable was dichotomized into less than 95% and greater than/equal to 95%</a:t>
-            </a:r>
-          </a:p>
-          <a:p>
+            </a:br>
             <a:r>
               <a:rPr lang="en-US" sz="1200" kern="1200" dirty="0">
                 <a:solidFill>
@@ -1441,11 +1501,39 @@
                 <a:ea typeface="+mn-ea"/>
                 <a:cs typeface="+mn-cs"/>
               </a:rPr>
-              <a:t>Models were compared with and without adherence to see whether including adherence meaningfully changed the estimated hard drug association.</a:t>
-            </a:r>
-          </a:p>
-          <a:p>
-            <a:br>
+              <a:t>In contrast, we found no significant difference in viral or mental QOL scores between groups with posterior probabilities of exceeding their clinical threshold being quite low</a:t>
+            </a:r>
+          </a:p>
+          <a:p>
+            <a:endParaRPr lang="en-US" sz="1200" kern="1200" dirty="0">
+              <a:solidFill>
+                <a:schemeClr val="tx1"/>
+              </a:solidFill>
+              <a:effectLst/>
+              <a:latin typeface="+mn-lt"/>
+              <a:ea typeface="+mn-ea"/>
+              <a:cs typeface="+mn-cs"/>
+            </a:endParaRPr>
+          </a:p>
+          <a:p>
+            <a:pPr marL="0" marR="0" lvl="0" indent="0" algn="l" defTabSz="914400" rtl="0" eaLnBrk="1" fontAlgn="auto" latinLnBrk="0" hangingPunct="1">
+              <a:lnSpc>
+                <a:spcPct val="100000"/>
+              </a:lnSpc>
+              <a:spcBef>
+                <a:spcPts val="0"/>
+              </a:spcBef>
+              <a:spcAft>
+                <a:spcPts val="0"/>
+              </a:spcAft>
+              <a:buClrTx/>
+              <a:buSzTx/>
+              <a:buFontTx/>
+              <a:buNone/>
+              <a:tabLst/>
+              <a:defRPr/>
+            </a:pPr>
+            <a:r>
               <a:rPr lang="en-US" sz="1200" kern="1200" dirty="0">
                 <a:solidFill>
                   <a:schemeClr val="tx1"/>
@@ -1455,20 +1543,47 @@
                 <a:ea typeface="+mn-ea"/>
                 <a:cs typeface="+mn-cs"/>
               </a:rPr>
-            </a:br>
-            <a:r>
-              <a:rPr lang="en-US" sz="1200" kern="1200" dirty="0">
-                <a:solidFill>
-                  <a:schemeClr val="tx1"/>
-                </a:solidFill>
-                <a:effectLst/>
-                <a:latin typeface="+mn-lt"/>
-                <a:ea typeface="+mn-ea"/>
-                <a:cs typeface="+mn-cs"/>
-              </a:rPr>
-              <a:t>Finally, for analyzing drop-out rates, Baseline characteristics between participants with complete measurements and those missing Year 2 were compared using non-parametric tests and I also fit a logistic regression model using baseline outcome and covariate measures as predictors of dropout</a:t>
-            </a:r>
-            <a:endParaRPr lang="en-US" dirty="0"/>
+              <a:t>In regard to model fit, there was a large and meaningful reduction in WAIC for CD4, but the other outcomes provided weaker evidence of better fit.</a:t>
+            </a:r>
+          </a:p>
+          <a:p>
+            <a:pPr marL="0" marR="0" lvl="0" indent="0" algn="l" defTabSz="914400" rtl="0" eaLnBrk="1" fontAlgn="auto" latinLnBrk="0" hangingPunct="1">
+              <a:lnSpc>
+                <a:spcPct val="100000"/>
+              </a:lnSpc>
+              <a:spcBef>
+                <a:spcPts val="0"/>
+              </a:spcBef>
+              <a:spcAft>
+                <a:spcPts val="0"/>
+              </a:spcAft>
+              <a:buClrTx/>
+              <a:buSzTx/>
+              <a:buFontTx/>
+              <a:buNone/>
+              <a:tabLst/>
+              <a:defRPr/>
+            </a:pPr>
+            <a:endParaRPr lang="en-US" sz="1200" kern="1200" dirty="0">
+              <a:solidFill>
+                <a:schemeClr val="tx1"/>
+              </a:solidFill>
+              <a:effectLst/>
+              <a:latin typeface="+mn-lt"/>
+              <a:ea typeface="+mn-ea"/>
+              <a:cs typeface="+mn-cs"/>
+            </a:endParaRPr>
+          </a:p>
+          <a:p>
+            <a:endParaRPr lang="en-US" sz="1200" kern="1200" dirty="0">
+              <a:solidFill>
+                <a:schemeClr val="tx1"/>
+              </a:solidFill>
+              <a:effectLst/>
+              <a:latin typeface="+mn-lt"/>
+              <a:ea typeface="+mn-ea"/>
+              <a:cs typeface="+mn-cs"/>
+            </a:endParaRPr>
           </a:p>
         </p:txBody>
       </p:sp>
@@ -1498,7 +1613,7 @@
     </p:spTree>
     <p:extLst>
       <p:ext uri="{BB962C8B-B14F-4D97-AF65-F5344CB8AC3E}">
-        <p14:creationId xmlns:p14="http://schemas.microsoft.com/office/powerpoint/2010/main" val="1144915537"/>
+        <p14:creationId xmlns:p14="http://schemas.microsoft.com/office/powerpoint/2010/main" val="826435084"/>
       </p:ext>
     </p:extLst>
   </p:cSld>
@@ -1562,9 +1677,22 @@
                 <a:ea typeface="+mn-ea"/>
                 <a:cs typeface="+mn-cs"/>
               </a:rPr>
-              <a:t>On average, hard drug users had approximately 164 fewer CD4 cells compared with non-users with a </a:t>
-            </a:r>
-            <a:br>
+              <a:t>To test for mediation, two models were fit – one with and without the binary adherence variable</a:t>
+            </a:r>
+          </a:p>
+          <a:p>
+            <a:endParaRPr lang="en-US" sz="1200" kern="1200" dirty="0">
+              <a:solidFill>
+                <a:schemeClr val="tx1"/>
+              </a:solidFill>
+              <a:effectLst/>
+              <a:latin typeface="+mn-lt"/>
+              <a:ea typeface="+mn-ea"/>
+              <a:cs typeface="+mn-cs"/>
+            </a:endParaRPr>
+          </a:p>
+          <a:p>
+            <a:r>
               <a:rPr lang="en-US" sz="1200" kern="1200" dirty="0">
                 <a:solidFill>
                   <a:schemeClr val="tx1"/>
@@ -1574,7 +1702,21 @@
                 <a:ea typeface="+mn-ea"/>
                 <a:cs typeface="+mn-cs"/>
               </a:rPr>
-            </a:br>
+              <a:t>When adherence was included in the models, the hard drug coefficients slightly increased in magnitude across all outcomes</a:t>
+            </a:r>
+          </a:p>
+          <a:p>
+            <a:endParaRPr lang="en-US" sz="1200" kern="1200" dirty="0">
+              <a:solidFill>
+                <a:schemeClr val="tx1"/>
+              </a:solidFill>
+              <a:effectLst/>
+              <a:latin typeface="+mn-lt"/>
+              <a:ea typeface="+mn-ea"/>
+              <a:cs typeface="+mn-cs"/>
+            </a:endParaRPr>
+          </a:p>
+          <a:p>
             <a:r>
               <a:rPr lang="en-US" sz="1200" kern="1200" dirty="0">
                 <a:solidFill>
@@ -1585,11 +1727,15 @@
                 <a:ea typeface="+mn-ea"/>
                 <a:cs typeface="+mn-cs"/>
               </a:rPr>
-              <a:t>posterior probability of 99.5% that this difference exceeded the clinically meaningful threshold of 50 cells</a:t>
-            </a:r>
-          </a:p>
-          <a:p>
-            <a:br>
+              <a:t>Which resulted in negative proportion mediated estimates and ultimately inconsistent mediation.  This was likely due to sparse data in the adherence category.</a:t>
+            </a:r>
+          </a:p>
+          <a:p>
+            <a:pPr marL="171450" indent="-171450">
+              <a:buFont typeface="Arial" panose="020B0604020202020204" pitchFamily="34" charset="0"/>
+              <a:buChar char="•"/>
+            </a:pPr>
+            <a:r>
               <a:rPr lang="en-US" sz="1200" kern="1200" dirty="0">
                 <a:solidFill>
                   <a:schemeClr val="tx1"/>
@@ -1599,7 +1745,21 @@
                 <a:ea typeface="+mn-ea"/>
                 <a:cs typeface="+mn-cs"/>
               </a:rPr>
-            </a:br>
+              <a:t>Which was shown back in the data overview section where only one subject was in the less than 95% grouping</a:t>
+            </a:r>
+          </a:p>
+          <a:p>
+            <a:endParaRPr lang="en-US" sz="1200" kern="1200" dirty="0">
+              <a:solidFill>
+                <a:schemeClr val="tx1"/>
+              </a:solidFill>
+              <a:effectLst/>
+              <a:latin typeface="+mn-lt"/>
+              <a:ea typeface="+mn-ea"/>
+              <a:cs typeface="+mn-cs"/>
+            </a:endParaRPr>
+          </a:p>
+          <a:p>
             <a:r>
               <a:rPr lang="en-US" sz="1200" kern="1200" dirty="0">
                 <a:solidFill>
@@ -1610,66 +1770,8 @@
                 <a:ea typeface="+mn-ea"/>
                 <a:cs typeface="+mn-cs"/>
               </a:rPr>
-              <a:t>In contrast, we found no significant difference in viral or mental QOL scores between groups.</a:t>
-            </a:r>
-          </a:p>
-          <a:p>
-            <a:br>
-              <a:rPr lang="en-US" sz="1200" kern="1200" dirty="0">
-                <a:solidFill>
-                  <a:schemeClr val="tx1"/>
-                </a:solidFill>
-                <a:effectLst/>
-                <a:latin typeface="+mn-lt"/>
-                <a:ea typeface="+mn-ea"/>
-                <a:cs typeface="+mn-cs"/>
-              </a:rPr>
-            </a:br>
-            <a:r>
-              <a:rPr lang="en-US" sz="1200" kern="1200" dirty="0">
-                <a:solidFill>
-                  <a:schemeClr val="tx1"/>
-                </a:solidFill>
-                <a:effectLst/>
-                <a:latin typeface="+mn-lt"/>
-                <a:ea typeface="+mn-ea"/>
-                <a:cs typeface="+mn-cs"/>
-              </a:rPr>
-              <a:t>Physical quality of life was also lower among hard drug users by approximately 3.3 points, and had a posterior probability of 83% that the difference exceeded the clinical threshold of 2 points</a:t>
-            </a:r>
-          </a:p>
-          <a:p>
-            <a:br>
-              <a:rPr lang="en-US" sz="1200" kern="1200" dirty="0">
-                <a:solidFill>
-                  <a:schemeClr val="tx1"/>
-                </a:solidFill>
-                <a:effectLst/>
-                <a:latin typeface="+mn-lt"/>
-                <a:ea typeface="+mn-ea"/>
-                <a:cs typeface="+mn-cs"/>
-              </a:rPr>
-            </a:br>
-            <a:endParaRPr lang="en-US" sz="1200" kern="1200" dirty="0">
-              <a:solidFill>
-                <a:schemeClr val="tx1"/>
-              </a:solidFill>
-              <a:effectLst/>
-              <a:latin typeface="+mn-lt"/>
-              <a:ea typeface="+mn-ea"/>
-              <a:cs typeface="+mn-cs"/>
-            </a:endParaRPr>
-          </a:p>
-          <a:p>
-            <a:endParaRPr lang="en-US" sz="1200" kern="1200" dirty="0">
-              <a:solidFill>
-                <a:schemeClr val="tx1"/>
-              </a:solidFill>
-              <a:effectLst/>
-              <a:latin typeface="+mn-lt"/>
-              <a:ea typeface="+mn-ea"/>
-              <a:cs typeface="+mn-cs"/>
-            </a:endParaRPr>
+              <a:t>Overall, there was little evidence that adherence explained the association.</a:t>
+            </a:r>
           </a:p>
         </p:txBody>
       </p:sp>
@@ -1699,7 +1801,7 @@
     </p:spTree>
     <p:extLst>
       <p:ext uri="{BB962C8B-B14F-4D97-AF65-F5344CB8AC3E}">
-        <p14:creationId xmlns:p14="http://schemas.microsoft.com/office/powerpoint/2010/main" val="826435084"/>
+        <p14:creationId xmlns:p14="http://schemas.microsoft.com/office/powerpoint/2010/main" val="3152127465"/>
       </p:ext>
     </p:extLst>
   </p:cSld>
@@ -1710,215 +1812,6 @@
 </file>
 
 <file path=ppt/notesSlides/notesSlide7.xml><?xml version="1.0" encoding="utf-8"?>
-<p:notes xmlns:a="http://schemas.openxmlformats.org/drawingml/2006/main" xmlns:r="http://schemas.openxmlformats.org/officeDocument/2006/relationships" xmlns:p="http://schemas.openxmlformats.org/presentationml/2006/main">
-  <p:cSld>
-    <p:spTree>
-      <p:nvGrpSpPr>
-        <p:cNvPr id="1" name=""/>
-        <p:cNvGrpSpPr/>
-        <p:nvPr/>
-      </p:nvGrpSpPr>
-      <p:grpSpPr>
-        <a:xfrm>
-          <a:off x="0" y="0"/>
-          <a:ext cx="0" cy="0"/>
-          <a:chOff x="0" y="0"/>
-          <a:chExt cx="0" cy="0"/>
-        </a:xfrm>
-      </p:grpSpPr>
-      <p:sp>
-        <p:nvSpPr>
-          <p:cNvPr id="2" name="Slide Image Placeholder 1"/>
-          <p:cNvSpPr>
-            <a:spLocks noGrp="1" noRot="1" noChangeAspect="1"/>
-          </p:cNvSpPr>
-          <p:nvPr>
-            <p:ph type="sldImg"/>
-          </p:nvPr>
-        </p:nvSpPr>
-        <p:spPr/>
-      </p:sp>
-      <p:sp>
-        <p:nvSpPr>
-          <p:cNvPr id="3" name="Notes Placeholder 2"/>
-          <p:cNvSpPr>
-            <a:spLocks noGrp="1"/>
-          </p:cNvSpPr>
-          <p:nvPr>
-            <p:ph type="body" idx="1"/>
-          </p:nvPr>
-        </p:nvSpPr>
-        <p:spPr/>
-        <p:txBody>
-          <a:bodyPr/>
-          <a:lstStyle/>
-          <a:p>
-            <a:r>
-              <a:rPr lang="en-US" sz="1200" kern="1200" dirty="0">
-                <a:solidFill>
-                  <a:schemeClr val="tx1"/>
-                </a:solidFill>
-                <a:effectLst/>
-                <a:latin typeface="+mn-lt"/>
-                <a:ea typeface="+mn-ea"/>
-                <a:cs typeface="+mn-cs"/>
-              </a:rPr>
-              <a:t>To evaluate adherence, two models were fit – one with and without the binary adherence variable</a:t>
-            </a:r>
-          </a:p>
-          <a:p>
-            <a:endParaRPr lang="en-US" sz="1200" kern="1200" dirty="0">
-              <a:solidFill>
-                <a:schemeClr val="tx1"/>
-              </a:solidFill>
-              <a:effectLst/>
-              <a:latin typeface="+mn-lt"/>
-              <a:ea typeface="+mn-ea"/>
-              <a:cs typeface="+mn-cs"/>
-            </a:endParaRPr>
-          </a:p>
-          <a:p>
-            <a:r>
-              <a:rPr lang="en-US" sz="1200" kern="1200" dirty="0">
-                <a:solidFill>
-                  <a:schemeClr val="tx1"/>
-                </a:solidFill>
-                <a:effectLst/>
-                <a:latin typeface="+mn-lt"/>
-                <a:ea typeface="+mn-ea"/>
-                <a:cs typeface="+mn-cs"/>
-              </a:rPr>
-              <a:t>When adherence was included in the models, the hard drug coefficient slightly increased in magnitude across all outcomes</a:t>
-            </a:r>
-          </a:p>
-          <a:p>
-            <a:endParaRPr lang="en-US" sz="1200" kern="1200" dirty="0">
-              <a:solidFill>
-                <a:schemeClr val="tx1"/>
-              </a:solidFill>
-              <a:effectLst/>
-              <a:latin typeface="+mn-lt"/>
-              <a:ea typeface="+mn-ea"/>
-              <a:cs typeface="+mn-cs"/>
-            </a:endParaRPr>
-          </a:p>
-          <a:p>
-            <a:r>
-              <a:rPr lang="en-US" sz="1200" kern="1200" dirty="0">
-                <a:solidFill>
-                  <a:schemeClr val="tx1"/>
-                </a:solidFill>
-                <a:effectLst/>
-                <a:latin typeface="+mn-lt"/>
-                <a:ea typeface="+mn-ea"/>
-                <a:cs typeface="+mn-cs"/>
-              </a:rPr>
-              <a:t>Which resulted in negative proportion mediated estimates and ultimately inconsistent mediation.  This was likely due to sparse data in the adherence category.</a:t>
-            </a:r>
-          </a:p>
-          <a:p>
-            <a:pPr marL="171450" indent="-171450">
-              <a:buFont typeface="Arial" panose="020B0604020202020204" pitchFamily="34" charset="0"/>
-              <a:buChar char="•"/>
-            </a:pPr>
-            <a:r>
-              <a:rPr lang="en-US" sz="1200" kern="1200" dirty="0">
-                <a:solidFill>
-                  <a:schemeClr val="tx1"/>
-                </a:solidFill>
-                <a:effectLst/>
-                <a:latin typeface="+mn-lt"/>
-                <a:ea typeface="+mn-ea"/>
-                <a:cs typeface="+mn-cs"/>
-              </a:rPr>
-              <a:t>Only </a:t>
-            </a:r>
-            <a:r>
-              <a:rPr lang="en-US" sz="1200" kern="1200">
-                <a:solidFill>
-                  <a:schemeClr val="tx1"/>
-                </a:solidFill>
-                <a:effectLst/>
-                <a:latin typeface="+mn-lt"/>
-                <a:ea typeface="+mn-ea"/>
-                <a:cs typeface="+mn-cs"/>
-              </a:rPr>
-              <a:t>one subject was in the less than 95% grouping</a:t>
-            </a:r>
-            <a:endParaRPr lang="en-US" sz="1200" kern="1200" dirty="0">
-              <a:solidFill>
-                <a:schemeClr val="tx1"/>
-              </a:solidFill>
-              <a:effectLst/>
-              <a:latin typeface="+mn-lt"/>
-              <a:ea typeface="+mn-ea"/>
-              <a:cs typeface="+mn-cs"/>
-            </a:endParaRPr>
-          </a:p>
-          <a:p>
-            <a:endParaRPr lang="en-US" sz="1200" kern="1200" dirty="0">
-              <a:solidFill>
-                <a:schemeClr val="tx1"/>
-              </a:solidFill>
-              <a:effectLst/>
-              <a:latin typeface="+mn-lt"/>
-              <a:ea typeface="+mn-ea"/>
-              <a:cs typeface="+mn-cs"/>
-            </a:endParaRPr>
-          </a:p>
-          <a:p>
-            <a:r>
-              <a:rPr lang="en-US" sz="1200" kern="1200" dirty="0">
-                <a:solidFill>
-                  <a:schemeClr val="tx1"/>
-                </a:solidFill>
-                <a:effectLst/>
-                <a:latin typeface="+mn-lt"/>
-                <a:ea typeface="+mn-ea"/>
-                <a:cs typeface="+mn-cs"/>
-              </a:rPr>
-              <a:t>Overall, there was little evidence that adherence explained the association.</a:t>
-            </a:r>
-          </a:p>
-        </p:txBody>
-      </p:sp>
-      <p:sp>
-        <p:nvSpPr>
-          <p:cNvPr id="4" name="Slide Number Placeholder 3"/>
-          <p:cNvSpPr>
-            <a:spLocks noGrp="1"/>
-          </p:cNvSpPr>
-          <p:nvPr>
-            <p:ph type="sldNum" sz="quarter" idx="5"/>
-          </p:nvPr>
-        </p:nvSpPr>
-        <p:spPr/>
-        <p:txBody>
-          <a:bodyPr/>
-          <a:lstStyle/>
-          <a:p>
-            <a:fld id="{8055A014-AA40-5B4A-A5FD-4F58A1D7AE4A}" type="slidenum">
-              <a:rPr lang="en-US" smtClean="0"/>
-              <a:t>7</a:t>
-            </a:fld>
-            <a:endParaRPr lang="en-US"/>
-          </a:p>
-        </p:txBody>
-      </p:sp>
-    </p:spTree>
-    <p:extLst>
-      <p:ext uri="{BB962C8B-B14F-4D97-AF65-F5344CB8AC3E}">
-        <p14:creationId xmlns:p14="http://schemas.microsoft.com/office/powerpoint/2010/main" val="3152127465"/>
-      </p:ext>
-    </p:extLst>
-  </p:cSld>
-  <p:clrMapOvr>
-    <a:masterClrMapping/>
-  </p:clrMapOvr>
-</p:notes>
-</file>
-
-<file path=ppt/notesSlides/notesSlide8.xml><?xml version="1.0" encoding="utf-8"?>
 <p:notes xmlns:a="http://schemas.openxmlformats.org/drawingml/2006/main" xmlns:r="http://schemas.openxmlformats.org/officeDocument/2006/relationships" xmlns:p="http://schemas.openxmlformats.org/presentationml/2006/main">
   <p:cSld>
     <p:spTree>
@@ -2007,7 +1900,7 @@
                 <a:ea typeface="+mn-ea"/>
                 <a:cs typeface="+mn-cs"/>
               </a:rPr>
-              <a:t>Of the 715 participants, 252 were missing Year 2 data or 35%.</a:t>
+              <a:t>Of the 715 participants, 252 or 35% of the dataset were missing Year 2 measurements</a:t>
             </a:r>
           </a:p>
           <a:p>
@@ -2066,7 +1959,7 @@
                 <a:ea typeface="+mn-ea"/>
                 <a:cs typeface="+mn-cs"/>
               </a:rPr>
-              <a:t>Baseline physical QOL scores were shown to be significantly lower among participants lost to follow-up for both hard drug users and non-users. It was particularly  noticeable in the drug users' group that was 5x lower than the clinically meaningful difference of 2 points</a:t>
+              <a:t>Baseline physical QOL scores were shown to be significantly lower among participants with missing year-2 data for both hard drug users and non-users. It was particularly  noticeable in the drug users' group which was 10 pts lower or 5x the clinically meaningful difference of 2 points</a:t>
             </a:r>
           </a:p>
           <a:p>
@@ -2125,16 +2018,29 @@
                 <a:ea typeface="+mn-ea"/>
                 <a:cs typeface="+mn-cs"/>
               </a:rPr>
-              <a:t>Logistic regression modelling confirmed that lower baseline physical QOL scores and younger age were associated with lower odds of dropout.</a:t>
-            </a:r>
-          </a:p>
-          <a:p>
-            <a:pPr marL="171450" indent="-171450">
+              <a:t>In addition to lower baseline physical QOL scores, Logistic regression also showed that younger age was associated with higher odds of dropout.</a:t>
+            </a:r>
+          </a:p>
+          <a:p>
+            <a:pPr marL="171450" marR="0" lvl="0" indent="-171450" algn="l" defTabSz="914400" rtl="0" eaLnBrk="1" fontAlgn="auto" latinLnBrk="0" hangingPunct="1">
+              <a:lnSpc>
+                <a:spcPct val="100000"/>
+              </a:lnSpc>
+              <a:spcBef>
+                <a:spcPts val="0"/>
+              </a:spcBef>
+              <a:spcAft>
+                <a:spcPts val="0"/>
+              </a:spcAft>
+              <a:buClrTx/>
+              <a:buSzTx/>
               <a:buFont typeface="Arial" panose="020B0604020202020204" pitchFamily="34" charset="0"/>
               <a:buChar char="•"/>
-            </a:pPr>
-            <a:r>
-              <a:rPr lang="en-US" sz="1200" i="0" kern="1200" dirty="0">
+              <a:tabLst/>
+              <a:defRPr/>
+            </a:pPr>
+            <a:r>
+              <a:rPr lang="en-US" sz="1200" kern="1200" dirty="0">
                 <a:solidFill>
                   <a:schemeClr val="tx1"/>
                 </a:solidFill>
@@ -2143,14 +2049,26 @@
                 <a:ea typeface="+mn-ea"/>
                 <a:cs typeface="+mn-cs"/>
               </a:rPr>
-              <a:t>For each additional year there was an approximate 3.4% reduction in the odds and for each one-point increase in baseline physical QOL there was 4.4% reduction in the odds of dropout. </a:t>
-            </a:r>
-            <a:endParaRPr lang="en-US" i="0" dirty="0"/>
-          </a:p>
-          <a:p>
-            <a:pPr marL="171450" indent="-171450">
+              <a:t>For each additional year in age and increase in QOL score, there's a reduction in odds of dropping out</a:t>
+            </a:r>
+          </a:p>
+          <a:p>
+            <a:pPr marL="171450" marR="0" lvl="0" indent="-171450" algn="l" defTabSz="914400" rtl="0" eaLnBrk="1" fontAlgn="auto" latinLnBrk="0" hangingPunct="1">
+              <a:lnSpc>
+                <a:spcPct val="100000"/>
+              </a:lnSpc>
+              <a:spcBef>
+                <a:spcPts val="0"/>
+              </a:spcBef>
+              <a:spcAft>
+                <a:spcPts val="0"/>
+              </a:spcAft>
+              <a:buClrTx/>
+              <a:buSzTx/>
               <a:buFont typeface="Arial" panose="020B0604020202020204" pitchFamily="34" charset="0"/>
               <a:buChar char="•"/>
+              <a:tabLst/>
+              <a:defRPr/>
             </a:pPr>
             <a:endParaRPr lang="en-US" dirty="0"/>
           </a:p>
@@ -2199,7 +2117,7 @@
           <a:p>
             <a:fld id="{8055A014-AA40-5B4A-A5FD-4F58A1D7AE4A}" type="slidenum">
               <a:rPr lang="en-US" smtClean="0"/>
-              <a:t>8</a:t>
+              <a:t>7</a:t>
             </a:fld>
             <a:endParaRPr lang="en-US"/>
           </a:p>
@@ -2218,7 +2136,7 @@
 </p:notes>
 </file>
 
-<file path=ppt/notesSlides/notesSlide9.xml><?xml version="1.0" encoding="utf-8"?>
+<file path=ppt/notesSlides/notesSlide8.xml><?xml version="1.0" encoding="utf-8"?>
 <p:notes xmlns:a="http://schemas.openxmlformats.org/drawingml/2006/main" xmlns:r="http://schemas.openxmlformats.org/officeDocument/2006/relationships" xmlns:p="http://schemas.openxmlformats.org/presentationml/2006/main">
   <p:cSld>
     <p:spTree>
@@ -2326,7 +2244,7 @@
             </a:pPr>
             <a:r>
               <a:rPr lang="en-US" dirty="0"/>
-              <a:t>Adherence was coded as binary and only had one observation for hard drug user with less than 95% this was likely a reason for the negative proportion mediated, so Adherence could not be reliably estimated.</a:t>
+              <a:t>Adherence was coded as binary and only had one observation for hard drug user with less than 95% this was likely a reason for the negative proportion mediated, so Adherence could not be reliably estimated and should be treated as descriptive </a:t>
             </a:r>
           </a:p>
           <a:p>
@@ -2336,7 +2254,7 @@
             </a:pPr>
             <a:r>
               <a:rPr lang="en-US" dirty="0"/>
-              <a:t>Hard drug user group was relatively small so we may not have had enough to power to make precise comparisons</a:t>
+              <a:t>Further, the Hard drug user group overall was relatively small so we may not have had enough to power to make precise comparisons</a:t>
             </a:r>
           </a:p>
           <a:p>
@@ -2346,25 +2264,7 @@
             </a:pPr>
             <a:r>
               <a:rPr lang="en-US" dirty="0"/>
-              <a:t>SF-36 scores are limited in interpretation because it typically requires comparisons matched on </a:t>
-            </a:r>
-            <a:r>
-              <a:rPr lang="en-US" dirty="0" err="1"/>
-              <a:t>Age,Sex</a:t>
-            </a:r>
-            <a:r>
-              <a:rPr lang="en-US" dirty="0"/>
-              <a:t>, or other demographics, which was not done here</a:t>
-            </a:r>
-          </a:p>
-          <a:p>
-            <a:pPr marL="171450" indent="-171450">
-              <a:buFont typeface="Arial" panose="020B0604020202020204" pitchFamily="34" charset="0"/>
-              <a:buChar char="•"/>
-            </a:pPr>
-            <a:r>
-              <a:rPr lang="en-US" dirty="0"/>
-              <a:t>Lastly, missingness appeared to be associated with age and physical health, which were observed, but it may depend on some unmeasured factor that we did not model. So it suggests MAR but doesn’t prove it</a:t>
+              <a:t>Lastly, while missingness appeared to be associated with age and physical health, which were observed, there may be some dependency on some unmeasured factor that we did not model. So, the missing data mechanism suggests MAR but wasn’t proven</a:t>
             </a:r>
           </a:p>
         </p:txBody>
@@ -2386,7 +2286,7 @@
           <a:p>
             <a:fld id="{8055A014-AA40-5B4A-A5FD-4F58A1D7AE4A}" type="slidenum">
               <a:rPr lang="en-US" smtClean="0"/>
-              <a:t>9</a:t>
+              <a:t>8</a:t>
             </a:fld>
             <a:endParaRPr lang="en-US"/>
           </a:p>
@@ -3118,408 +3018,6 @@
 </file>
 
 <file path=ppt/slides/slide2.xml><?xml version="1.0" encoding="utf-8"?>
-<p:sld xmlns:a="http://schemas.openxmlformats.org/drawingml/2006/main" xmlns:r="http://schemas.openxmlformats.org/officeDocument/2006/relationships" xmlns:p="http://schemas.openxmlformats.org/presentationml/2006/main" showMasterSp="0">
-  <p:cSld>
-    <p:spTree>
-      <p:nvGrpSpPr>
-        <p:cNvPr id="1" name=""/>
-        <p:cNvGrpSpPr/>
-        <p:nvPr/>
-      </p:nvGrpSpPr>
-      <p:grpSpPr>
-        <a:xfrm>
-          <a:off x="0" y="0"/>
-          <a:ext cx="0" cy="0"/>
-          <a:chOff x="0" y="0"/>
-          <a:chExt cx="0" cy="0"/>
-        </a:xfrm>
-      </p:grpSpPr>
-      <p:sp>
-        <p:nvSpPr>
-          <p:cNvPr id="2" name="object 1"/>
-          <p:cNvSpPr/>
-          <p:nvPr/>
-        </p:nvSpPr>
-        <p:spPr>
-          <a:xfrm>
-            <a:off x="0" y="-9309"/>
-            <a:ext cx="12192000" cy="6858000"/>
-          </a:xfrm>
-          <a:prstGeom prst="rect">
-            <a:avLst/>
-          </a:prstGeom>
-          <a:blipFill>
-            <a:blip r:embed="rId3" cstate="print"/>
-            <a:stretch>
-              <a:fillRect/>
-            </a:stretch>
-          </a:blipFill>
-        </p:spPr>
-        <p:txBody>
-          <a:bodyPr wrap="square" lIns="0" tIns="0" rIns="0" bIns="0" rtlCol="0">
-            <a:spAutoFit/>
-          </a:bodyPr>
-          <a:lstStyle/>
-          <a:p>
-            <a:endParaRPr dirty="0"/>
-          </a:p>
-        </p:txBody>
-      </p:sp>
-      <p:sp>
-        <p:nvSpPr>
-          <p:cNvPr id="3" name="object 3"/>
-          <p:cNvSpPr txBox="1"/>
-          <p:nvPr/>
-        </p:nvSpPr>
-        <p:spPr>
-          <a:xfrm>
-            <a:off x="1199456" y="181814"/>
-            <a:ext cx="5065008" cy="641201"/>
-          </a:xfrm>
-          <a:prstGeom prst="rect">
-            <a:avLst/>
-          </a:prstGeom>
-        </p:spPr>
-        <p:txBody>
-          <a:bodyPr vert="horz" wrap="square" lIns="0" tIns="0" rIns="0" bIns="0" rtlCol="0">
-            <a:spAutoFit/>
-          </a:bodyPr>
-          <a:lstStyle/>
-          <a:p>
-            <a:pPr marL="0" marR="0">
-              <a:lnSpc>
-                <a:spcPts val="4979"/>
-              </a:lnSpc>
-              <a:spcBef>
-                <a:spcPts val="0"/>
-              </a:spcBef>
-              <a:spcAft>
-                <a:spcPts val="0"/>
-              </a:spcAft>
-            </a:pPr>
-            <a:r>
-              <a:rPr sz="4400" spc="-21" dirty="0">
-                <a:solidFill>
-                  <a:srgbClr val="181A0D"/>
-                </a:solidFill>
-                <a:cs typeface="KDMFEK+FranklinGothic-Book"/>
-              </a:rPr>
-              <a:t>Research</a:t>
-            </a:r>
-            <a:r>
-              <a:rPr sz="4400" spc="21" dirty="0">
-                <a:solidFill>
-                  <a:srgbClr val="181A0D"/>
-                </a:solidFill>
-                <a:cs typeface="KDMFEK+FranklinGothic-Book"/>
-              </a:rPr>
-              <a:t> </a:t>
-            </a:r>
-            <a:r>
-              <a:rPr sz="4400" dirty="0">
-                <a:solidFill>
-                  <a:srgbClr val="181A0D"/>
-                </a:solidFill>
-                <a:cs typeface="KDMFEK+FranklinGothic-Book"/>
-              </a:rPr>
-              <a:t>Question</a:t>
-            </a:r>
-            <a:r>
-              <a:rPr lang="en-US" sz="4400" dirty="0">
-                <a:solidFill>
-                  <a:srgbClr val="181A0D"/>
-                </a:solidFill>
-                <a:cs typeface="KDMFEK+FranklinGothic-Book"/>
-              </a:rPr>
-              <a:t>s</a:t>
-            </a:r>
-            <a:endParaRPr sz="4400" dirty="0">
-              <a:solidFill>
-                <a:srgbClr val="181A0D"/>
-              </a:solidFill>
-              <a:cs typeface="KDMFEK+FranklinGothic-Book"/>
-            </a:endParaRPr>
-          </a:p>
-        </p:txBody>
-      </p:sp>
-      <p:sp>
-        <p:nvSpPr>
-          <p:cNvPr id="6" name="TextBox 5">
-            <a:extLst>
-              <a:ext uri="{FF2B5EF4-FFF2-40B4-BE49-F238E27FC236}">
-                <a16:creationId xmlns:a16="http://schemas.microsoft.com/office/drawing/2014/main" id="{8701BA5A-512C-C680-9EBD-36CA578908FA}"/>
-              </a:ext>
-            </a:extLst>
-          </p:cNvPr>
-          <p:cNvSpPr txBox="1"/>
-          <p:nvPr/>
-        </p:nvSpPr>
-        <p:spPr>
-          <a:xfrm>
-            <a:off x="1055440" y="971873"/>
-            <a:ext cx="10801200" cy="6088846"/>
-          </a:xfrm>
-          <a:prstGeom prst="rect">
-            <a:avLst/>
-          </a:prstGeom>
-          <a:noFill/>
-        </p:spPr>
-        <p:txBody>
-          <a:bodyPr wrap="square">
-            <a:spAutoFit/>
-          </a:bodyPr>
-          <a:lstStyle/>
-          <a:p>
-            <a:pPr marL="285750" indent="-285750">
-              <a:lnSpc>
-                <a:spcPts val="2258"/>
-              </a:lnSpc>
-              <a:buFont typeface="Wingdings" pitchFamily="2" charset="2"/>
-              <a:buChar char="q"/>
-            </a:pPr>
-            <a:r>
-              <a:rPr lang="en-US" sz="2000" b="1" dirty="0">
-                <a:solidFill>
-                  <a:srgbClr val="181A0D"/>
-                </a:solidFill>
-              </a:rPr>
-              <a:t>Once HAART is initiated, is there a decrease in viral load (HIV copies per mL) and an increase in CD4+ T counts (cells/mm³)</a:t>
-            </a:r>
-            <a:r>
-              <a:rPr lang="en-US" sz="2000" b="1" dirty="0"/>
-              <a:t>?</a:t>
-            </a:r>
-            <a:endParaRPr lang="en-US" sz="2000" b="1" dirty="0">
-              <a:solidFill>
-                <a:srgbClr val="181A0D"/>
-              </a:solidFill>
-            </a:endParaRPr>
-          </a:p>
-          <a:p>
-            <a:pPr marL="742950" lvl="1" indent="-285750">
-              <a:lnSpc>
-                <a:spcPts val="2258"/>
-              </a:lnSpc>
-              <a:buFont typeface="Wingdings" pitchFamily="2" charset="2"/>
-              <a:buChar char="Ø"/>
-            </a:pPr>
-            <a:r>
-              <a:rPr lang="en-US" sz="2000" i="1" dirty="0">
-                <a:solidFill>
-                  <a:srgbClr val="181A0D"/>
-                </a:solidFill>
-                <a:cs typeface="OAGDQN+FranklinGothic-BookItalic"/>
-              </a:rPr>
-              <a:t>Hypothesis</a:t>
-            </a:r>
-            <a:r>
-              <a:rPr lang="en-US" sz="2000" dirty="0">
-                <a:solidFill>
-                  <a:srgbClr val="181A0D"/>
-                </a:solidFill>
-                <a:cs typeface="OAGDQN+FranklinGothic-BookItalic"/>
-              </a:rPr>
-              <a:t>: Year-2 viral load will be higher among homosexual and bisexual men with HIV-1, who reported baseline hard drug use as compared with non-users</a:t>
-            </a:r>
-          </a:p>
-          <a:p>
-            <a:pPr marL="742950" lvl="1" indent="-285750">
-              <a:lnSpc>
-                <a:spcPts val="2258"/>
-              </a:lnSpc>
-              <a:buFont typeface="Wingdings" pitchFamily="2" charset="2"/>
-              <a:buChar char="Ø"/>
-            </a:pPr>
-            <a:r>
-              <a:rPr lang="en-US" sz="2000" i="1" dirty="0">
-                <a:solidFill>
-                  <a:srgbClr val="181A0D"/>
-                </a:solidFill>
-                <a:cs typeface="OAGDQN+FranklinGothic-BookItalic"/>
-              </a:rPr>
-              <a:t>Hypothesis</a:t>
-            </a:r>
-            <a:r>
-              <a:rPr lang="en-US" sz="2000" dirty="0">
-                <a:solidFill>
-                  <a:srgbClr val="181A0D"/>
-                </a:solidFill>
-                <a:cs typeface="OAGDQN+FranklinGothic-BookItalic"/>
-              </a:rPr>
-              <a:t>: Year-2 CD4+ T-cell counts will be lower among homosexual and bisexual men with HIV-1, who reported baseline hard drug use as compared with non-users</a:t>
-            </a:r>
-          </a:p>
-          <a:p>
-            <a:pPr lvl="1">
-              <a:lnSpc>
-                <a:spcPts val="2258"/>
-              </a:lnSpc>
-            </a:pPr>
-            <a:endParaRPr lang="en-US" sz="2000" dirty="0">
-              <a:solidFill>
-                <a:srgbClr val="181A0D"/>
-              </a:solidFill>
-              <a:cs typeface="OAGDQN+FranklinGothic-BookItalic"/>
-            </a:endParaRPr>
-          </a:p>
-          <a:p>
-            <a:pPr marL="285750" indent="-285750">
-              <a:buFont typeface="Wingdings" pitchFamily="2" charset="2"/>
-              <a:buChar char="q"/>
-            </a:pPr>
-            <a:r>
-              <a:rPr lang="en-US" sz="2000" b="1" dirty="0"/>
-              <a:t>What happens to physical and mental quality-of-life (QOL) scores after HAART initiation?</a:t>
-            </a:r>
-          </a:p>
-          <a:p>
-            <a:pPr marL="742950" lvl="1" indent="-285750">
-              <a:lnSpc>
-                <a:spcPts val="2258"/>
-              </a:lnSpc>
-              <a:buFont typeface="Wingdings" pitchFamily="2" charset="2"/>
-              <a:buChar char="Ø"/>
-            </a:pPr>
-            <a:r>
-              <a:rPr lang="en-US" sz="2000" i="1" dirty="0">
-                <a:solidFill>
-                  <a:srgbClr val="181A0D"/>
-                </a:solidFill>
-                <a:cs typeface="OAGDQN+FranklinGothic-BookItalic"/>
-              </a:rPr>
-              <a:t>Hypothesis</a:t>
-            </a:r>
-            <a:r>
-              <a:rPr lang="en-US" sz="2000" dirty="0">
-                <a:solidFill>
-                  <a:srgbClr val="181A0D"/>
-                </a:solidFill>
-                <a:cs typeface="OAGDQN+FranklinGothic-BookItalic"/>
-              </a:rPr>
-              <a:t>: Year-2 physical QOL will differ between hard drug users and non-users</a:t>
-            </a:r>
-          </a:p>
-          <a:p>
-            <a:pPr marL="742950" lvl="1" indent="-285750">
-              <a:lnSpc>
-                <a:spcPts val="2258"/>
-              </a:lnSpc>
-              <a:buFont typeface="Wingdings" pitchFamily="2" charset="2"/>
-              <a:buChar char="Ø"/>
-            </a:pPr>
-            <a:r>
-              <a:rPr lang="en-US" sz="2000" i="1" dirty="0">
-                <a:solidFill>
-                  <a:srgbClr val="181A0D"/>
-                </a:solidFill>
-                <a:cs typeface="OAGDQN+FranklinGothic-BookItalic"/>
-              </a:rPr>
-              <a:t>Hypothesis</a:t>
-            </a:r>
-            <a:r>
-              <a:rPr lang="en-US" sz="2000" dirty="0">
-                <a:solidFill>
-                  <a:srgbClr val="181A0D"/>
-                </a:solidFill>
-                <a:cs typeface="OAGDQN+FranklinGothic-BookItalic"/>
-              </a:rPr>
-              <a:t>: Year-2 mental QOL will differ between hard drug users and non-users</a:t>
-            </a:r>
-          </a:p>
-          <a:p>
-            <a:pPr marL="742950" lvl="1" indent="-285750">
-              <a:lnSpc>
-                <a:spcPts val="2258"/>
-              </a:lnSpc>
-              <a:buFont typeface="Wingdings" pitchFamily="2" charset="2"/>
-              <a:buChar char="Ø"/>
-            </a:pPr>
-            <a:endParaRPr lang="en-US" sz="2000" b="1" dirty="0">
-              <a:solidFill>
-                <a:srgbClr val="181A0D"/>
-              </a:solidFill>
-            </a:endParaRPr>
-          </a:p>
-          <a:p>
-            <a:pPr marL="285750" indent="-285750">
-              <a:buFont typeface="Wingdings" pitchFamily="2" charset="2"/>
-              <a:buChar char="q"/>
-            </a:pPr>
-            <a:r>
-              <a:rPr lang="en-US" sz="2000" b="1" dirty="0">
-                <a:solidFill>
-                  <a:srgbClr val="181A0D"/>
-                </a:solidFill>
-              </a:rPr>
-              <a:t>Does adherence mediate the association between hard drug use and year-2 outcomes?</a:t>
-            </a:r>
-          </a:p>
-          <a:p>
-            <a:pPr marL="742950" lvl="1" indent="-285750">
-              <a:buFont typeface="Wingdings" pitchFamily="2" charset="2"/>
-              <a:buChar char="Ø"/>
-            </a:pPr>
-            <a:r>
-              <a:rPr lang="en-US" sz="2000" i="1" dirty="0"/>
-              <a:t>Hypothesis</a:t>
-            </a:r>
-            <a:r>
-              <a:rPr lang="en-US" sz="2000" dirty="0"/>
-              <a:t>: The association between hard drug use and treatment response will be weaker after accounting for adherence.</a:t>
-            </a:r>
-          </a:p>
-          <a:p>
-            <a:pPr lvl="1"/>
-            <a:endParaRPr lang="en-US" sz="2000" dirty="0"/>
-          </a:p>
-          <a:p>
-            <a:pPr marL="285750" indent="-285750">
-              <a:buFont typeface="Wingdings" pitchFamily="2" charset="2"/>
-              <a:buChar char="q"/>
-            </a:pPr>
-            <a:r>
-              <a:rPr lang="en-US" sz="2000" b="1" dirty="0"/>
-              <a:t>What are the dropout rates between hard drug users and non-users and how does that affect results?</a:t>
-            </a:r>
-          </a:p>
-          <a:p>
-            <a:pPr marL="742950" lvl="1" indent="-285750">
-              <a:buFont typeface="Wingdings" pitchFamily="2" charset="2"/>
-              <a:buChar char="Ø"/>
-            </a:pPr>
-            <a:r>
-              <a:rPr lang="en-US" sz="2000" i="1" dirty="0"/>
-              <a:t>Hypothesis</a:t>
-            </a:r>
-            <a:r>
-              <a:rPr lang="en-US" sz="2000" dirty="0"/>
-              <a:t>: Baseline outcomes differ between participants with complete and incomplete cases</a:t>
-            </a:r>
-            <a:endParaRPr lang="en-US" dirty="0">
-              <a:solidFill>
-                <a:srgbClr val="181A0D"/>
-              </a:solidFill>
-              <a:cs typeface="OAGDQN+FranklinGothic-BookItalic"/>
-            </a:endParaRPr>
-          </a:p>
-          <a:p>
-            <a:pPr marL="285750" indent="-285750">
-              <a:buFont typeface="Wingdings" pitchFamily="2" charset="2"/>
-              <a:buChar char="§"/>
-            </a:pPr>
-            <a:endParaRPr lang="en-US" dirty="0"/>
-          </a:p>
-        </p:txBody>
-      </p:sp>
-    </p:spTree>
-  </p:cSld>
-  <p:clrMapOvr>
-    <a:masterClrMapping/>
-  </p:clrMapOvr>
-</p:sld>
-</file>
-
-<file path=ppt/slides/slide3.xml><?xml version="1.0" encoding="utf-8"?>
 <p:sld xmlns:a="http://schemas.openxmlformats.org/drawingml/2006/main" xmlns:r="http://schemas.openxmlformats.org/officeDocument/2006/relationships" xmlns:p="http://schemas.openxmlformats.org/presentationml/2006/main">
   <p:cSld>
     <p:spTree>
@@ -3873,7 +3371,7 @@
 </p:sld>
 </file>
 
-<file path=ppt/slides/slide4.xml><?xml version="1.0" encoding="utf-8"?>
+<file path=ppt/slides/slide3.xml><?xml version="1.0" encoding="utf-8"?>
 <p:sld xmlns:a="http://schemas.openxmlformats.org/drawingml/2006/main" xmlns:r="http://schemas.openxmlformats.org/officeDocument/2006/relationships" xmlns:p="http://schemas.openxmlformats.org/presentationml/2006/main" showMasterSp="0">
   <p:cSld>
     <p:spTree>
@@ -4252,6 +3750,58 @@
           </a:prstGeom>
         </p:spPr>
       </p:pic>
+      <p:sp>
+        <p:nvSpPr>
+          <p:cNvPr id="15" name="Process 14">
+            <a:extLst>
+              <a:ext uri="{FF2B5EF4-FFF2-40B4-BE49-F238E27FC236}">
+                <a16:creationId xmlns:a16="http://schemas.microsoft.com/office/drawing/2014/main" id="{C21B61A2-A07B-C030-FA5E-758620D88CD4}"/>
+              </a:ext>
+            </a:extLst>
+          </p:cNvPr>
+          <p:cNvSpPr/>
+          <p:nvPr/>
+        </p:nvSpPr>
+        <p:spPr>
+          <a:xfrm>
+            <a:off x="6581716" y="3140968"/>
+            <a:ext cx="4710631" cy="504056"/>
+          </a:xfrm>
+          <a:prstGeom prst="flowChartProcess">
+            <a:avLst/>
+          </a:prstGeom>
+          <a:noFill/>
+          <a:ln>
+            <a:solidFill>
+              <a:schemeClr val="accent2"/>
+            </a:solidFill>
+          </a:ln>
+        </p:spPr>
+        <p:style>
+          <a:lnRef idx="2">
+            <a:schemeClr val="accent1">
+              <a:shade val="15000"/>
+            </a:schemeClr>
+          </a:lnRef>
+          <a:fillRef idx="1">
+            <a:schemeClr val="accent1"/>
+          </a:fillRef>
+          <a:effectRef idx="0">
+            <a:schemeClr val="accent1"/>
+          </a:effectRef>
+          <a:fontRef idx="minor">
+            <a:schemeClr val="lt1"/>
+          </a:fontRef>
+        </p:style>
+        <p:txBody>
+          <a:bodyPr rtlCol="0" anchor="ctr"/>
+          <a:lstStyle/>
+          <a:p>
+            <a:pPr algn="ctr"/>
+            <a:endParaRPr lang="en-US"/>
+          </a:p>
+        </p:txBody>
+      </p:sp>
     </p:spTree>
   </p:cSld>
   <p:clrMapOvr>
@@ -4260,7 +3810,7 @@
 </p:sld>
 </file>
 
-<file path=ppt/slides/slide5.xml><?xml version="1.0" encoding="utf-8"?>
+<file path=ppt/slides/slide4.xml><?xml version="1.0" encoding="utf-8"?>
 <p:sld xmlns:a="http://schemas.openxmlformats.org/drawingml/2006/main" xmlns:r="http://schemas.openxmlformats.org/officeDocument/2006/relationships" xmlns:p="http://schemas.openxmlformats.org/presentationml/2006/main" showMasterSp="0">
   <p:cSld>
     <p:spTree>
@@ -4623,7 +4173,7 @@
                 </a:pPr>
                 <a:r>
                   <a:rPr lang="en-US" sz="2000" dirty="0"/>
-                  <a:t>Baseline outcome value, Age, BMI, smoking status, education, race/ethnicity </a:t>
+                  <a:t>Baseline outcome measure value, Age, BMI, smoking status, education, race/ethnicity </a:t>
                 </a:r>
                 <a:endParaRPr lang="en-US" sz="2000" spc="-25" dirty="0">
                   <a:solidFill>
@@ -4793,7 +4343,7 @@
                     </a:solidFill>
                     <a:cs typeface="OAGDQN+FranklinGothic-BookItalic"/>
                   </a:rPr>
-                  <a:t>Complete (Baseline+Year-2) vs Missing Year-2</a:t>
+                  <a:t>Complete (Baseline+Year-2) vs Missing Year-2 baseline outcomes</a:t>
                 </a:r>
               </a:p>
               <a:p>
@@ -4975,7 +4525,7 @@
 </p:sld>
 </file>
 
-<file path=ppt/slides/slide6.xml><?xml version="1.0" encoding="utf-8"?>
+<file path=ppt/slides/slide5.xml><?xml version="1.0" encoding="utf-8"?>
 <p:sld xmlns:a="http://schemas.openxmlformats.org/drawingml/2006/main" xmlns:r="http://schemas.openxmlformats.org/officeDocument/2006/relationships" xmlns:p="http://schemas.openxmlformats.org/presentationml/2006/main" showMasterSp="0">
   <p:cSld>
     <p:spTree>
@@ -5071,7 +4621,7 @@
                 </a:solidFill>
                 <a:cs typeface="MPIRPG+FranklinGothic-Book"/>
               </a:rPr>
-              <a:t> - treatment response</a:t>
+              <a:t> - Primary</a:t>
             </a:r>
             <a:endParaRPr sz="4400" spc="-12" dirty="0">
               <a:solidFill>
@@ -5096,8 +4646,8 @@
         </p:nvSpPr>
         <p:spPr>
           <a:xfrm>
-            <a:off x="911424" y="814400"/>
-            <a:ext cx="3960440" cy="7086555"/>
+            <a:off x="911424" y="620688"/>
+            <a:ext cx="3960440" cy="7917552"/>
           </a:xfrm>
           <a:prstGeom prst="rect">
             <a:avLst/>
@@ -5272,6 +4822,23 @@
               <a:rPr lang="en-US" dirty="0"/>
               <a:t>No meaningful difference</a:t>
             </a:r>
+          </a:p>
+          <a:p>
+            <a:pPr marL="285750" indent="-285750">
+              <a:buFont typeface="Wingdings" pitchFamily="2" charset="2"/>
+              <a:buChar char="Ø"/>
+            </a:pPr>
+            <a:r>
+              <a:rPr lang="en-US" dirty="0"/>
+              <a:t>26% probability exceeds 2-point threshold</a:t>
+            </a:r>
+          </a:p>
+          <a:p>
+            <a:pPr marL="285750" lvl="0" indent="-285750">
+              <a:buFont typeface="Wingdings" pitchFamily="2" charset="2"/>
+              <a:buChar char="Ø"/>
+            </a:pPr>
+            <a:endParaRPr lang="en-US" dirty="0"/>
           </a:p>
           <a:p>
             <a:pPr marL="342900" indent="-342900">
@@ -5411,8 +4978,8 @@
         </p:blipFill>
         <p:spPr>
           <a:xfrm>
-            <a:off x="4511824" y="2132856"/>
-            <a:ext cx="7490643" cy="3312368"/>
+            <a:off x="4378125" y="2132856"/>
+            <a:ext cx="7653483" cy="3384376"/>
           </a:xfrm>
           <a:prstGeom prst="rect">
             <a:avLst/>
@@ -5427,7 +4994,7 @@
 </p:sld>
 </file>
 
-<file path=ppt/slides/slide7.xml><?xml version="1.0" encoding="utf-8"?>
+<file path=ppt/slides/slide6.xml><?xml version="1.0" encoding="utf-8"?>
 <p:sld xmlns:a="http://schemas.openxmlformats.org/drawingml/2006/main" xmlns:r="http://schemas.openxmlformats.org/officeDocument/2006/relationships" xmlns:p="http://schemas.openxmlformats.org/presentationml/2006/main" showMasterSp="0">
   <p:cSld>
     <p:spTree>
@@ -5523,7 +5090,7 @@
                 </a:solidFill>
                 <a:cs typeface="WPQCJM+FranklinGothic-Book"/>
               </a:rPr>
-              <a:t> - </a:t>
+              <a:t> - M</a:t>
             </a:r>
             <a:r>
               <a:rPr lang="en-US" sz="4400" dirty="0">
@@ -5532,7 +5099,7 @@
                 </a:solidFill>
                 <a:cs typeface="WPQCJM+FranklinGothic-Book"/>
               </a:rPr>
-              <a:t>mediation</a:t>
+              <a:t>ediation</a:t>
             </a:r>
             <a:endParaRPr sz="4400" dirty="0">
               <a:solidFill>
@@ -5848,36 +5415,6 @@
           </a:p>
         </p:txBody>
       </p:sp>
-      <p:pic>
-        <p:nvPicPr>
-          <p:cNvPr id="5" name="Picture 4" descr="A screenshot of a computer&#10;&#10;AI-generated content may be incorrect.">
-            <a:extLst>
-              <a:ext uri="{FF2B5EF4-FFF2-40B4-BE49-F238E27FC236}">
-                <a16:creationId xmlns:a16="http://schemas.microsoft.com/office/drawing/2014/main" id="{FC982772-C5EA-DA3E-6CBC-3ED39B55EF11}"/>
-              </a:ext>
-            </a:extLst>
-          </p:cNvPr>
-          <p:cNvPicPr>
-            <a:picLocks noChangeAspect="1"/>
-          </p:cNvPicPr>
-          <p:nvPr/>
-        </p:nvPicPr>
-        <p:blipFill>
-          <a:blip r:embed="rId4"/>
-          <a:stretch>
-            <a:fillRect/>
-          </a:stretch>
-        </p:blipFill>
-        <p:spPr>
-          <a:xfrm>
-            <a:off x="3863752" y="1452933"/>
-            <a:ext cx="8151671" cy="3779728"/>
-          </a:xfrm>
-          <a:prstGeom prst="rect">
-            <a:avLst/>
-          </a:prstGeom>
-        </p:spPr>
-      </p:pic>
       <p:sp>
         <p:nvSpPr>
           <p:cNvPr id="6" name="object 4">
@@ -6112,6 +5649,36 @@
           </a:p>
         </p:txBody>
       </p:sp>
+      <p:pic>
+        <p:nvPicPr>
+          <p:cNvPr id="9" name="Picture 8">
+            <a:extLst>
+              <a:ext uri="{FF2B5EF4-FFF2-40B4-BE49-F238E27FC236}">
+                <a16:creationId xmlns:a16="http://schemas.microsoft.com/office/drawing/2014/main" id="{FF560D31-57C2-F34D-10FD-70C200250EBB}"/>
+              </a:ext>
+            </a:extLst>
+          </p:cNvPr>
+          <p:cNvPicPr>
+            <a:picLocks noChangeAspect="1"/>
+          </p:cNvPicPr>
+          <p:nvPr/>
+        </p:nvPicPr>
+        <p:blipFill>
+          <a:blip r:embed="rId4"/>
+          <a:stretch>
+            <a:fillRect/>
+          </a:stretch>
+        </p:blipFill>
+        <p:spPr>
+          <a:xfrm>
+            <a:off x="3841322" y="1810161"/>
+            <a:ext cx="8217579" cy="3863703"/>
+          </a:xfrm>
+          <a:prstGeom prst="rect">
+            <a:avLst/>
+          </a:prstGeom>
+        </p:spPr>
+      </p:pic>
     </p:spTree>
   </p:cSld>
   <p:clrMapOvr>
@@ -6120,7 +5687,7 @@
 </p:sld>
 </file>
 
-<file path=ppt/slides/slide8.xml><?xml version="1.0" encoding="utf-8"?>
+<file path=ppt/slides/slide7.xml><?xml version="1.0" encoding="utf-8"?>
 <p:sld xmlns:a="http://schemas.openxmlformats.org/drawingml/2006/main" xmlns:r="http://schemas.openxmlformats.org/officeDocument/2006/relationships" xmlns:p="http://schemas.openxmlformats.org/presentationml/2006/main">
   <p:cSld>
     <p:spTree>
@@ -6157,7 +5724,7 @@
         </p:nvSpPr>
         <p:spPr>
           <a:xfrm>
-            <a:off x="0" y="14166"/>
+            <a:off x="0" y="0"/>
             <a:ext cx="12192000" cy="6858000"/>
           </a:xfrm>
           <a:prstGeom prst="rect">
@@ -6194,7 +5761,7 @@
         </p:nvSpPr>
         <p:spPr>
           <a:xfrm>
-            <a:off x="1415480" y="188640"/>
+            <a:off x="1271464" y="132743"/>
             <a:ext cx="4528479" cy="641201"/>
           </a:xfrm>
           <a:prstGeom prst="rect">
@@ -6234,7 +5801,7 @@
                 </a:solidFill>
                 <a:cs typeface="WPQCJM+FranklinGothic-Book"/>
               </a:rPr>
-              <a:t> – follow-up</a:t>
+              <a:t> – Dropouts</a:t>
             </a:r>
             <a:endParaRPr sz="4400" dirty="0">
               <a:solidFill>
@@ -6259,7 +5826,7 @@
         </p:nvSpPr>
         <p:spPr>
           <a:xfrm>
-            <a:off x="962944" y="1340768"/>
+            <a:off x="911424" y="1196752"/>
             <a:ext cx="2905849" cy="6783908"/>
           </a:xfrm>
           <a:prstGeom prst="rect">
@@ -6402,7 +5969,7 @@
             </a:pPr>
             <a:r>
               <a:rPr lang="en-US" b="1" dirty="0"/>
-              <a:t>Younger age also associated with dropout</a:t>
+              <a:t>Younger age associated with dropout</a:t>
             </a:r>
           </a:p>
           <a:p>
@@ -6632,10 +6199,10 @@
       </p:pic>
       <p:pic>
         <p:nvPicPr>
-          <p:cNvPr id="7" name="Picture 6" descr="A screenshot of a computer&#10;&#10;AI-generated content may be incorrect.">
+          <p:cNvPr id="9" name="Picture 8">
             <a:extLst>
               <a:ext uri="{FF2B5EF4-FFF2-40B4-BE49-F238E27FC236}">
-                <a16:creationId xmlns:a16="http://schemas.microsoft.com/office/drawing/2014/main" id="{906C3A0D-869F-920A-2F61-71B4D8843D52}"/>
+                <a16:creationId xmlns:a16="http://schemas.microsoft.com/office/drawing/2014/main" id="{D76EAC4B-A053-6B41-3285-C4D31E821E0B}"/>
               </a:ext>
             </a:extLst>
           </p:cNvPr>
@@ -6652,14 +6219,66 @@
         </p:blipFill>
         <p:spPr>
           <a:xfrm>
-            <a:off x="4187660" y="5266454"/>
-            <a:ext cx="7865278" cy="1418439"/>
+            <a:off x="4143300" y="5274450"/>
+            <a:ext cx="8012202" cy="1450807"/>
           </a:xfrm>
           <a:prstGeom prst="rect">
             <a:avLst/>
           </a:prstGeom>
         </p:spPr>
       </p:pic>
+      <p:sp>
+        <p:nvSpPr>
+          <p:cNvPr id="10" name="Process 9">
+            <a:extLst>
+              <a:ext uri="{FF2B5EF4-FFF2-40B4-BE49-F238E27FC236}">
+                <a16:creationId xmlns:a16="http://schemas.microsoft.com/office/drawing/2014/main" id="{BB1EA9AF-CF3B-589F-E74B-6D7D9947D0CD}"/>
+              </a:ext>
+            </a:extLst>
+          </p:cNvPr>
+          <p:cNvSpPr/>
+          <p:nvPr/>
+        </p:nvSpPr>
+        <p:spPr>
+          <a:xfrm>
+            <a:off x="4187660" y="3284984"/>
+            <a:ext cx="8004340" cy="720080"/>
+          </a:xfrm>
+          <a:prstGeom prst="flowChartProcess">
+            <a:avLst/>
+          </a:prstGeom>
+          <a:noFill/>
+          <a:ln>
+            <a:solidFill>
+              <a:schemeClr val="accent2"/>
+            </a:solidFill>
+          </a:ln>
+        </p:spPr>
+        <p:style>
+          <a:lnRef idx="2">
+            <a:schemeClr val="accent1">
+              <a:shade val="15000"/>
+            </a:schemeClr>
+          </a:lnRef>
+          <a:fillRef idx="1">
+            <a:schemeClr val="accent1"/>
+          </a:fillRef>
+          <a:effectRef idx="0">
+            <a:schemeClr val="accent1"/>
+          </a:effectRef>
+          <a:fontRef idx="minor">
+            <a:schemeClr val="lt1"/>
+          </a:fontRef>
+        </p:style>
+        <p:txBody>
+          <a:bodyPr rtlCol="0" anchor="ctr"/>
+          <a:lstStyle/>
+          <a:p>
+            <a:pPr algn="ctr"/>
+            <a:endParaRPr lang="en-US"/>
+          </a:p>
+        </p:txBody>
+      </p:sp>
     </p:spTree>
     <p:extLst>
       <p:ext uri="{BB962C8B-B14F-4D97-AF65-F5344CB8AC3E}">
@@ -6673,7 +6292,7 @@
 </p:sld>
 </file>
 
-<file path=ppt/slides/slide9.xml><?xml version="1.0" encoding="utf-8"?>
+<file path=ppt/slides/slide8.xml><?xml version="1.0" encoding="utf-8"?>
 <p:sld xmlns:a="http://schemas.openxmlformats.org/drawingml/2006/main" xmlns:r="http://schemas.openxmlformats.org/officeDocument/2006/relationships" xmlns:p="http://schemas.openxmlformats.org/presentationml/2006/main" showMasterSp="0">
   <p:cSld>
     <p:spTree>
@@ -6786,7 +6405,7 @@
         <p:spPr>
           <a:xfrm>
             <a:off x="1127448" y="1132209"/>
-            <a:ext cx="10297144" cy="6194003"/>
+            <a:ext cx="10297144" cy="5899051"/>
           </a:xfrm>
           <a:prstGeom prst="rect">
             <a:avLst/>
@@ -7004,7 +6623,7 @@
                 </a:solidFill>
                 <a:cs typeface="OAGDQN+FranklinGothic-BookItalic"/>
               </a:rPr>
-              <a:t>Mediation = exploratory </a:t>
+              <a:t>Mediation = exploratory/descriptive</a:t>
             </a:r>
           </a:p>
           <a:p>
@@ -7023,24 +6642,6 @@
                 <a:cs typeface="OAGDQN+FranklinGothic-BookItalic"/>
               </a:rPr>
               <a:t>Hard drug user group was relatively small (36)</a:t>
-            </a:r>
-          </a:p>
-          <a:p>
-            <a:pPr marL="800100" lvl="1" indent="-342900">
-              <a:lnSpc>
-                <a:spcPts val="2258"/>
-              </a:lnSpc>
-              <a:buFont typeface="Wingdings" pitchFamily="2" charset="2"/>
-              <a:buChar char="Ø"/>
-            </a:pPr>
-            <a:r>
-              <a:rPr lang="en-US" sz="2000" spc="-25" dirty="0">
-                <a:solidFill>
-                  <a:srgbClr val="181A0D"/>
-                </a:solidFill>
-                <a:cs typeface="OAGDQN+FranklinGothic-BookItalic"/>
-              </a:rPr>
-              <a:t>SF-36 Scores comparisons are limited</a:t>
             </a:r>
           </a:p>
           <a:p>

</xml_diff>